<commit_message>
Updated deck and report with new UI screenshots; gate simulator uses real residents
- Deck (30 slides): every screenshot recaptured from the current UI; new slides for
  encrypted resident records and onboarding; operations slide dropped; numbers
  updated (14 modules, 41 tests, 57 browser checks, readability results); charts
  replaced by shapes and stat callouts so the deck renders in Keynote as well as
  PowerPoint; PDF export added
- LaTeX report (40 pages): encryption and bed-assignment algorithms, resident
  directory and onboarding section with figures, 24-question assistant evaluation,
  readability audit, new API rows, references (DPDP Act, NIST GCM, HKDF, WCAG),
  new appendix excerpts
- Screenshot library replaced with the new captures
- Biometric gate simulator verifies a randomly chosen active resident instead of a
  hard-coded name; onboarding selects show their default option

Co-Authored-By: Claude Opus 5.5 <noreply@anthropic.com>
</commit_message>
<xml_diff>
--- a/presentation/Demeure_AI_Showcase.pptx
+++ b/presentation/Demeure_AI_Showcase.pptx
@@ -27,7 +27,8 @@
     <p:sldId id="275" r:id="rId21"/>
     <p:sldId id="276" r:id="rId22"/>
     <p:sldId id="277" r:id="rId23"/>
-    <p:sldId id="278" r:id="rId24"/>
+    <p:sldId id="285" r:id="rId36"/>
+    <p:sldId id="286" r:id="rId37"/>
     <p:sldId id="279" r:id="rId25"/>
     <p:sldId id="280" r:id="rId26"/>
     <p:sldId id="281" r:id="rId27"/>
@@ -163,7 +164,8 @@
             <p14:sldId id="275"/>
             <p14:sldId id="276"/>
             <p14:sldId id="277"/>
-            <p14:sldId id="278"/>
+            <p14:sldId id="285"/>
+            <p14:sldId id="286"/>
             <p14:sldId id="279"/>
           </p14:sldIdLst>
         </p14:section>
@@ -2372,94 +2374,6 @@
 </p:notes>
 </file>
 
-<file path=ppt/notesSlides/notesSlide23.xml><?xml version="1.0" encoding="utf-8"?>
-<p:notes xmlns:a="http://schemas.openxmlformats.org/drawingml/2006/main" xmlns:r="http://schemas.openxmlformats.org/officeDocument/2006/relationships" xmlns:p="http://schemas.openxmlformats.org/presentationml/2006/main">
-  <p:cSld>
-    <p:spTree>
-      <p:nvGrpSpPr>
-        <p:cNvPr id="1" name=""/>
-        <p:cNvGrpSpPr/>
-        <p:nvPr/>
-      </p:nvGrpSpPr>
-      <p:grpSpPr>
-        <a:xfrm>
-          <a:off x="0" y="0"/>
-          <a:ext cx="0" cy="0"/>
-          <a:chOff x="0" y="0"/>
-          <a:chExt cx="0" cy="0"/>
-        </a:xfrm>
-      </p:grpSpPr>
-      <p:sp>
-        <p:nvSpPr>
-          <p:cNvPr id="2" name="Slide Image Placeholder 1"/>
-          <p:cNvSpPr>
-            <a:spLocks noGrp="1" noRot="1" noChangeAspect="1"/>
-          </p:cNvSpPr>
-          <p:nvPr>
-            <p:ph type="sldImg"/>
-          </p:nvPr>
-        </p:nvSpPr>
-        <p:spPr/>
-      </p:sp>
-      <p:sp>
-        <p:nvSpPr>
-          <p:cNvPr id="3" name="Notes Placeholder 2"/>
-          <p:cNvSpPr>
-            <a:spLocks noGrp="1"/>
-          </p:cNvSpPr>
-          <p:nvPr>
-            <p:ph type="body" idx="1"/>
-          </p:nvPr>
-        </p:nvSpPr>
-        <p:spPr/>
-        <p:txBody>
-          <a:bodyPr/>
-          <a:lstStyle/>
-          <a:p>
-            <a:r>
-              <a:rPr lang="en-US" dirty="0"/>
-              <a:t>The overview shows live system state from the health endpoint: environment, storage backend, AWS mode and assistant readiness. Welfare alerts are resolved by wardens and persisted.</a:t>
-            </a:r>
-            <a:endParaRPr lang="en-US" dirty="0"/>
-          </a:p>
-        </p:txBody>
-      </p:sp>
-      <p:sp>
-        <p:nvSpPr>
-          <p:cNvPr id="4" name="Slide Number Placeholder 3"/>
-          <p:cNvSpPr>
-            <a:spLocks noGrp="1"/>
-          </p:cNvSpPr>
-          <p:nvPr>
-            <p:ph type="sldNum" sz="quarter" idx="10"/>
-          </p:nvPr>
-        </p:nvSpPr>
-        <p:spPr/>
-        <p:txBody>
-          <a:bodyPr/>
-          <a:lstStyle/>
-          <a:p>
-            <a:fld id="{F7021451-1387-4CA6-816F-3879F97B5CBC}" type="slidenum">
-              <a:rPr lang="en-US"/>
-              <a:t>23</a:t>
-            </a:fld>
-            <a:endParaRPr lang="en-US"/>
-          </a:p>
-        </p:txBody>
-      </p:sp>
-    </p:spTree>
-    <p:extLst>
-      <p:ext uri="{BB962C8B-B14F-4D97-AF65-F5344CB8AC3E}">
-        <p14:creationId xmlns:p14="http://schemas.microsoft.com/office/powerpoint/2010/main" val="1024086991"/>
-      </p:ext>
-    </p:extLst>
-  </p:cSld>
-  <p:clrMapOvr>
-    <a:masterClrMapping/>
-  </p:clrMapOvr>
-</p:notes>
-</file>
-
 <file path=ppt/notesSlides/notesSlide24.xml><?xml version="1.0" encoding="utf-8"?>
 <p:notes xmlns:a="http://schemas.openxmlformats.org/drawingml/2006/main" xmlns:r="http://schemas.openxmlformats.org/officeDocument/2006/relationships" xmlns:p="http://schemas.openxmlformats.org/presentationml/2006/main">
   <p:cSld>
@@ -3069,6 +2983,146 @@
         <p14:creationId xmlns:p14="http://schemas.microsoft.com/office/powerpoint/2010/main" val="1024086991"/>
       </p:ext>
     </p:extLst>
+  </p:cSld>
+  <p:clrMapOvr>
+    <a:masterClrMapping/>
+  </p:clrMapOvr>
+</p:notes>
+</file>
+
+<file path=ppt/notesSlides/notesSlide30.xml><?xml version="1.0" encoding="utf-8"?>
+<p:notes xmlns:a="http://schemas.openxmlformats.org/drawingml/2006/main" xmlns:p="http://schemas.openxmlformats.org/presentationml/2006/main" xmlns:r="http://schemas.openxmlformats.org/officeDocument/2006/relationships">
+  <p:cSld>
+    <p:spTree>
+      <p:nvGrpSpPr>
+        <p:cNvPr id="1" name=""/>
+        <p:cNvGrpSpPr/>
+        <p:nvPr/>
+      </p:nvGrpSpPr>
+      <p:grpSpPr>
+        <a:xfrm>
+          <a:off x="0" y="0"/>
+          <a:ext cx="0" cy="0"/>
+          <a:chOff x="0" y="0"/>
+          <a:chExt cx="0" cy="0"/>
+        </a:xfrm>
+      </p:grpSpPr>
+      <p:sp>
+        <p:nvSpPr>
+          <p:cNvPr id="2" name="Slide Image Placeholder 1"/>
+          <p:cNvSpPr>
+            <a:spLocks noGrp="1"/>
+          </p:cNvSpPr>
+          <p:nvPr>
+            <p:ph type="sldImg" idx="2"/>
+          </p:nvPr>
+        </p:nvSpPr>
+        <p:spPr/>
+      </p:sp>
+      <p:sp>
+        <p:nvSpPr>
+          <p:cNvPr id="3" name="Notes Placeholder 2"/>
+          <p:cNvSpPr>
+            <a:spLocks noGrp="1"/>
+          </p:cNvSpPr>
+          <p:nvPr>
+            <p:ph type="body" idx="3" sz="quarter"/>
+          </p:nvPr>
+        </p:nvSpPr>
+        <p:spPr/>
+        <p:txBody>
+          <a:bodyPr/>
+          <a:lstStyle/>
+          <a:p>
+            <a:r>
+              <a:t>The directory lists all residents with masked phone numbers and current dues status. Opening a profile decrypts it for that session and writes an audit entry. The campus admin can show the record exactly as stored: contact, guardian, health and address fields are AES-256-GCM ciphertext.</a:t>
+            </a:r>
+          </a:p>
+        </p:txBody>
+      </p:sp>
+      <p:sp>
+        <p:nvSpPr>
+          <p:cNvPr id="4" name="Slide Number Placeholder 3"/>
+          <p:cNvSpPr>
+            <a:spLocks noGrp="1"/>
+          </p:cNvSpPr>
+          <p:nvPr>
+            <p:ph type="sldNum" idx="5" sz="quarter"/>
+          </p:nvPr>
+        </p:nvSpPr>
+        <p:spPr/>
+      </p:sp>
+    </p:spTree>
+  </p:cSld>
+  <p:clrMapOvr>
+    <a:masterClrMapping/>
+  </p:clrMapOvr>
+</p:notes>
+</file>
+
+<file path=ppt/notesSlides/notesSlide31.xml><?xml version="1.0" encoding="utf-8"?>
+<p:notes xmlns:a="http://schemas.openxmlformats.org/drawingml/2006/main" xmlns:p="http://schemas.openxmlformats.org/presentationml/2006/main" xmlns:r="http://schemas.openxmlformats.org/officeDocument/2006/relationships">
+  <p:cSld>
+    <p:spTree>
+      <p:nvGrpSpPr>
+        <p:cNvPr id="1" name=""/>
+        <p:cNvGrpSpPr/>
+        <p:nvPr/>
+      </p:nvGrpSpPr>
+      <p:grpSpPr>
+        <a:xfrm>
+          <a:off x="0" y="0"/>
+          <a:ext cx="0" cy="0"/>
+          <a:chOff x="0" y="0"/>
+          <a:chExt cx="0" cy="0"/>
+        </a:xfrm>
+      </p:grpSpPr>
+      <p:sp>
+        <p:nvSpPr>
+          <p:cNvPr id="2" name="Slide Image Placeholder 1"/>
+          <p:cNvSpPr>
+            <a:spLocks noGrp="1"/>
+          </p:cNvSpPr>
+          <p:nvPr>
+            <p:ph type="sldImg" idx="2"/>
+          </p:nvPr>
+        </p:nvSpPr>
+        <p:spPr/>
+      </p:sp>
+      <p:sp>
+        <p:nvSpPr>
+          <p:cNvPr id="3" name="Notes Placeholder 2"/>
+          <p:cNvSpPr>
+            <a:spLocks noGrp="1"/>
+          </p:cNvSpPr>
+          <p:nvPr>
+            <p:ph type="body" idx="3" sz="quarter"/>
+          </p:nvPr>
+        </p:nvSpPr>
+        <p:spPr/>
+        <p:txBody>
+          <a:bodyPr/>
+          <a:lstStyle/>
+          <a:p>
+            <a:r>
+              <a:t>Staff add a resident through a validated form or import a CSV/Excel sheet. Each resident gets a bed in a block that matches their gender, an encrypted record and a one-time access code that is e-mailed to them. Rows with errors are reported and skipped; codes can be downloaded as a CSV.</a:t>
+            </a:r>
+          </a:p>
+        </p:txBody>
+      </p:sp>
+      <p:sp>
+        <p:nvSpPr>
+          <p:cNvPr id="4" name="Slide Number Placeholder 3"/>
+          <p:cNvSpPr>
+            <a:spLocks noGrp="1"/>
+          </p:cNvSpPr>
+          <p:nvPr>
+            <p:ph type="sldNum" idx="5" sz="quarter"/>
+          </p:nvPr>
+        </p:nvSpPr>
+        <p:spPr/>
+      </p:sp>
+    </p:spTree>
   </p:cSld>
   <p:clrMapOvr>
     <a:masterClrMapping/>
@@ -4728,7 +4782,7 @@
           <p:nvPr/>
         </p:nvPicPr>
         <p:blipFill>
-          <a:blip r:embed="rId1"/>
+          <a:blip r:embed="rId4"/>
           <a:stretch>
             <a:fillRect/>
           </a:stretch>
@@ -4894,8 +4948,8 @@
         </p:nvSpPr>
         <p:spPr>
           <a:xfrm>
-            <a:off x="420624" y="1152144"/>
-            <a:ext cx="4050792" cy="2580656"/>
+            <a:off x="943020" y="1152144"/>
+            <a:ext cx="3005999" cy="2580656"/>
           </a:xfrm>
           <a:prstGeom prst="rect">
             <a:avLst/>
@@ -4927,15 +4981,15 @@
           <p:nvPr/>
         </p:nvPicPr>
         <p:blipFill>
-          <a:blip r:embed="rId1"/>
+          <a:blip r:embed="rId5"/>
           <a:stretch>
             <a:fillRect/>
           </a:stretch>
         </p:blipFill>
         <p:spPr>
           <a:xfrm>
-            <a:off x="457200" y="1188720"/>
-            <a:ext cx="3977640" cy="2507504"/>
+            <a:off x="979596" y="1188720"/>
+            <a:ext cx="2932847" cy="2507504"/>
           </a:xfrm>
           <a:prstGeom prst="rect">
             <a:avLst/>
@@ -4950,7 +5004,7 @@
         </p:nvSpPr>
         <p:spPr>
           <a:xfrm>
-            <a:off x="457200" y="3787664"/>
+            <a:off x="457199" y="3787664"/>
             <a:ext cx="3977640" cy="256032"/>
           </a:xfrm>
           <a:prstGeom prst="rect">
@@ -4987,7 +5041,7 @@
         <p:spPr>
           <a:xfrm>
             <a:off x="4672584" y="1152144"/>
-            <a:ext cx="4050792" cy="1507442"/>
+            <a:ext cx="4050792" cy="1335287"/>
           </a:xfrm>
           <a:prstGeom prst="rect">
             <a:avLst/>
@@ -5019,7 +5073,7 @@
           <p:nvPr/>
         </p:nvPicPr>
         <p:blipFill>
-          <a:blip r:embed="rId2"/>
+          <a:blip r:embed="rId1"/>
           <a:stretch>
             <a:fillRect/>
           </a:stretch>
@@ -5027,7 +5081,7 @@
         <p:spPr>
           <a:xfrm>
             <a:off x="4709160" y="1188720"/>
-            <a:ext cx="3977640" cy="1434290"/>
+            <a:ext cx="3977640" cy="1262135"/>
           </a:xfrm>
           <a:prstGeom prst="rect">
             <a:avLst/>
@@ -5042,7 +5096,7 @@
         </p:nvSpPr>
         <p:spPr>
           <a:xfrm>
-            <a:off x="4709160" y="2714450"/>
+            <a:off x="4709160" y="2542295"/>
             <a:ext cx="3977640" cy="256032"/>
           </a:xfrm>
           <a:prstGeom prst="rect">
@@ -5591,7 +5645,7 @@
         <p:spPr>
           <a:xfrm>
             <a:off x="3986784" y="1078992"/>
-            <a:ext cx="4731838" cy="3657600"/>
+            <a:ext cx="4731838" cy="3657599"/>
           </a:xfrm>
           <a:prstGeom prst="rect">
             <a:avLst/>
@@ -5623,7 +5677,7 @@
           <p:nvPr/>
         </p:nvPicPr>
         <p:blipFill>
-          <a:blip r:embed="rId1"/>
+          <a:blip r:embed="rId4"/>
           <a:stretch>
             <a:fillRect/>
           </a:stretch>
@@ -5631,7 +5685,7 @@
         <p:spPr>
           <a:xfrm>
             <a:off x="4023360" y="1115568"/>
-            <a:ext cx="4658686" cy="3584448"/>
+            <a:ext cx="4658686" cy="3584447"/>
           </a:xfrm>
           <a:prstGeom prst="rect">
             <a:avLst/>
@@ -5798,8 +5852,8 @@
         </p:nvSpPr>
         <p:spPr>
           <a:xfrm>
-            <a:off x="420624" y="1152144"/>
-            <a:ext cx="4050792" cy="3133595"/>
+            <a:off x="458564" y="1152144"/>
+            <a:ext cx="3974912" cy="3133595"/>
           </a:xfrm>
           <a:prstGeom prst="rect">
             <a:avLst/>
@@ -5831,15 +5885,15 @@
           <p:nvPr/>
         </p:nvPicPr>
         <p:blipFill>
-          <a:blip r:embed="rId1"/>
+          <a:blip r:embed="rId5"/>
           <a:stretch>
             <a:fillRect/>
           </a:stretch>
         </p:blipFill>
         <p:spPr>
           <a:xfrm>
-            <a:off x="457200" y="1188720"/>
-            <a:ext cx="3977640" cy="3060443"/>
+            <a:off x="495140" y="1188720"/>
+            <a:ext cx="3901760" cy="3060443"/>
           </a:xfrm>
           <a:prstGeom prst="rect">
             <a:avLst/>
@@ -5891,7 +5945,7 @@
         <p:spPr>
           <a:xfrm>
             <a:off x="5685279" y="1152144"/>
-            <a:ext cx="2025401" cy="3200400"/>
+            <a:ext cx="2025401" cy="3078795"/>
           </a:xfrm>
           <a:prstGeom prst="rect">
             <a:avLst/>
@@ -5923,7 +5977,7 @@
           <p:nvPr/>
         </p:nvPicPr>
         <p:blipFill>
-          <a:blip r:embed="rId2"/>
+          <a:blip r:embed="rId1"/>
           <a:stretch>
             <a:fillRect/>
           </a:stretch>
@@ -5931,7 +5985,7 @@
         <p:spPr>
           <a:xfrm>
             <a:off x="5721855" y="1188720"/>
-            <a:ext cx="1952249" cy="3127248"/>
+            <a:ext cx="1952249" cy="3005643"/>
           </a:xfrm>
           <a:prstGeom prst="rect">
             <a:avLst/>
@@ -5946,7 +6000,7 @@
         </p:nvSpPr>
         <p:spPr>
           <a:xfrm>
-            <a:off x="4709160" y="4407408"/>
+            <a:off x="4709159" y="4285803"/>
             <a:ext cx="3977640" cy="256032"/>
           </a:xfrm>
           <a:prstGeom prst="rect">
@@ -6135,7 +6189,7 @@
         <p:spPr>
           <a:xfrm>
             <a:off x="420624" y="1106424"/>
-            <a:ext cx="5696712" cy="3589531"/>
+            <a:ext cx="5696712" cy="3589530"/>
           </a:xfrm>
           <a:prstGeom prst="rect">
             <a:avLst/>
@@ -6157,6 +6211,10 @@
             </a:outerShdw>
           </a:effectLst>
         </p:spPr>
+        <p:txBody>
+          <a:bodyPr/>
+          <a:p/>
+        </p:txBody>
       </p:sp>
       <p:pic>
         <p:nvPicPr>
@@ -6167,7 +6225,7 @@
           <p:nvPr/>
         </p:nvPicPr>
         <p:blipFill>
-          <a:blip r:embed="rId1"/>
+          <a:blip r:embed="rId4"/>
           <a:stretch>
             <a:fillRect/>
           </a:stretch>
@@ -6175,7 +6233,7 @@
         <p:spPr>
           <a:xfrm>
             <a:off x="457200" y="1143000"/>
-            <a:ext cx="5623560" cy="3516379"/>
+            <a:ext cx="5623560" cy="3516378"/>
           </a:xfrm>
           <a:prstGeom prst="rect">
             <a:avLst/>
@@ -6215,7 +6273,7 @@
                 <a:ea typeface="Arial" pitchFamily="34" charset="-122"/>
                 <a:cs typeface="Arial" pitchFamily="34" charset="-120"/>
               </a:rPr>
-              <a:t>101</a:t>
+              <a:t>100</a:t>
             </a:r>
             <a:endParaRPr lang="en-US" sz="4000" dirty="0"/>
           </a:p>
@@ -6251,7 +6309,7 @@
                   <a:schemeClr val="accent6"/>
                 </a:solidFill>
               </a:rPr>
-              <a:t>live survey responses (100 seeded + 1 new)</a:t>
+              <a:t>survey responses from the seeded residents</a:t>
             </a:r>
             <a:endParaRPr lang="en-US" sz="1400" dirty="0"/>
           </a:p>
@@ -6492,8 +6550,8 @@
         </p:nvSpPr>
         <p:spPr>
           <a:xfrm>
-            <a:off x="555791" y="1078992"/>
-            <a:ext cx="2180258" cy="3657600"/>
+            <a:off x="635556" y="1078992"/>
+            <a:ext cx="2020727" cy="3657600"/>
           </a:xfrm>
           <a:prstGeom prst="rect">
             <a:avLst/>
@@ -6515,6 +6573,10 @@
             </a:outerShdw>
           </a:effectLst>
         </p:spPr>
+        <p:txBody>
+          <a:bodyPr/>
+          <a:p/>
+        </p:txBody>
       </p:sp>
       <p:pic>
         <p:nvPicPr>
@@ -6525,37 +6587,21 @@
           <p:nvPr/>
         </p:nvPicPr>
         <p:blipFill>
-          <a:blip r:embed="rId1"/>
+          <a:blip r:embed="rId5"/>
           <a:stretch>
             <a:fillRect/>
           </a:stretch>
         </p:blipFill>
         <p:spPr>
           <a:xfrm>
-            <a:off x="592367" y="1115568"/>
-            <a:ext cx="2107106" cy="3584448"/>
+            <a:off x="672132" y="1115568"/>
+            <a:ext cx="1947575" cy="3584448"/>
           </a:xfrm>
           <a:prstGeom prst="rect">
             <a:avLst/>
           </a:prstGeom>
         </p:spPr>
       </p:pic>
-      <p:graphicFrame>
-        <p:nvGraphicFramePr>
-          <p:cNvPr id="7" name="Chart 0" descr=""/>
-          <p:cNvGraphicFramePr/>
-          <p:nvPr/>
-        </p:nvGraphicFramePr>
-        <p:xfrm>
-          <a:off x="3200400" y="1143000"/>
-          <a:ext cx="5486400" cy="2743200"/>
-        </p:xfrm>
-        <a:graphic xmlns:a="http://schemas.openxmlformats.org/drawingml/2006/main">
-          <a:graphicData uri="http://schemas.openxmlformats.org/drawingml/2006/chart">
-            <c:chart xmlns:c="http://schemas.openxmlformats.org/drawingml/2006/chart" r:id="rId2"/>
-          </a:graphicData>
-        </a:graphic>
-      </p:graphicFrame>
       <p:sp>
         <p:nvSpPr>
           <p:cNvPr id="8" name="Text 3"/>
@@ -6586,7 +6632,7 @@
                   <a:schemeClr val="accent1"/>
                 </a:solidFill>
               </a:rPr>
-              <a:t>Pratik's own answers match his search at 100%; the next-best residents follow at 95% and 90%.</a:t>
+              <a:t>Search a Night Owl / silent / strictly clean / quiet profile in Block A: the best residents score 95%, 90% and 90%. Single-gender blocks only rank residents of that block.</a:t>
             </a:r>
             <a:endParaRPr lang="en-US" sz="1400" dirty="0"/>
           </a:p>
@@ -6637,6 +6683,502 @@
               <a:t>14</a:t>
             </a:fld>
             <a:endParaRPr lang="en-US"/>
+          </a:p>
+        </p:txBody>
+      </p:sp>
+      <p:sp>
+        <p:nvSpPr>
+          <p:cNvPr id="8" name="Text 3"/>
+          <p:cNvSpPr txBox="1"/>
+          <p:nvPr/>
+        </p:nvSpPr>
+        <p:spPr>
+          <a:xfrm>
+            <a:off x="3200400" y="1143000"/>
+            <a:ext cx="5486400" cy="274320"/>
+          </a:xfrm>
+          <a:prstGeom prst="rect">
+            <a:avLst/>
+          </a:prstGeom>
+          <a:noFill/>
+          <a:ln/>
+        </p:spPr>
+        <p:txBody>
+          <a:bodyPr wrap="square" lIns="0" tIns="0" rIns="0" bIns="0" rtlCol="0" anchor="t"/>
+          <a:lstStyle/>
+          <a:p>
+            <a:pPr indent="0" marL="0">
+              <a:buNone/>
+            </a:pPr>
+            <a:r>
+              <a:rPr lang="en-US" sz="1400" i="0" dirty="0" b="1">
+                <a:solidFill>
+                  <a:schemeClr val="accent1"/>
+                </a:solidFill>
+              </a:rPr>
+              <a:t>Similarity weights used for every match</a:t>
+            </a:r>
+            <a:endParaRPr lang="en-US" sz="1400" dirty="0"/>
+          </a:p>
+        </p:txBody>
+      </p:sp>
+      <p:sp>
+        <p:nvSpPr>
+          <p:cNvPr id="6" name="Text 3"/>
+          <p:cNvSpPr txBox="1"/>
+          <p:nvPr/>
+        </p:nvSpPr>
+        <p:spPr>
+          <a:xfrm>
+            <a:off x="3200400" y="1600200"/>
+            <a:ext cx="1600200" cy="365760"/>
+          </a:xfrm>
+          <a:prstGeom prst="rect">
+            <a:avLst/>
+          </a:prstGeom>
+          <a:noFill/>
+          <a:ln/>
+        </p:spPr>
+        <p:txBody>
+          <a:bodyPr wrap="square" lIns="0" tIns="0" rIns="0" bIns="0" rtlCol="0" anchor="ctr"/>
+          <a:lstStyle/>
+          <a:p>
+            <a:pPr indent="0" marL="0">
+              <a:buNone/>
+            </a:pPr>
+            <a:r>
+              <a:rPr lang="en-US" sz="1400" dirty="0">
+                <a:solidFill>
+                  <a:schemeClr val="accent6"/>
+                </a:solidFill>
+              </a:rPr>
+              <a:t>Sleep cycle</a:t>
+            </a:r>
+            <a:endParaRPr lang="en-US" sz="1400" dirty="0"/>
+          </a:p>
+        </p:txBody>
+      </p:sp>
+      <p:sp>
+        <p:nvSpPr>
+          <p:cNvPr id="26" name="bar-Sleep cycle"/>
+          <p:cNvSpPr/>
+          <p:nvPr/>
+        </p:nvSpPr>
+        <p:spPr>
+          <a:xfrm>
+            <a:off x="4892040" y="1655064"/>
+            <a:ext cx="3291840" cy="256032"/>
+          </a:xfrm>
+          <a:prstGeom prst="rect">
+            <a:avLst/>
+          </a:prstGeom>
+          <a:solidFill>
+            <a:schemeClr val="accent1"/>
+          </a:solidFill>
+          <a:ln>
+            <a:noFill/>
+          </a:ln>
+        </p:spPr>
+        <p:style>
+          <a:lnRef idx="1">
+            <a:schemeClr val="accent1"/>
+          </a:lnRef>
+          <a:fillRef idx="3">
+            <a:schemeClr val="accent1"/>
+          </a:fillRef>
+          <a:effectRef idx="2">
+            <a:schemeClr val="accent1"/>
+          </a:effectRef>
+          <a:fontRef idx="minor">
+            <a:schemeClr val="lt1"/>
+          </a:fontRef>
+        </p:style>
+        <p:txBody>
+          <a:bodyPr rtlCol="0" anchor="ctr"/>
+          <a:lstStyle/>
+          <a:p>
+            <a:pPr algn="ctr"/>
+          </a:p>
+        </p:txBody>
+      </p:sp>
+      <p:sp>
+        <p:nvSpPr>
+          <p:cNvPr id="6" name="Text 3"/>
+          <p:cNvSpPr txBox="1"/>
+          <p:nvPr/>
+        </p:nvSpPr>
+        <p:spPr>
+          <a:xfrm>
+            <a:off x="8275320" y="1600200"/>
+            <a:ext cx="640080" cy="365760"/>
+          </a:xfrm>
+          <a:prstGeom prst="rect">
+            <a:avLst/>
+          </a:prstGeom>
+          <a:noFill/>
+          <a:ln/>
+        </p:spPr>
+        <p:txBody>
+          <a:bodyPr wrap="square" lIns="0" tIns="0" rIns="0" bIns="0" rtlCol="0" anchor="t"/>
+          <a:lstStyle/>
+          <a:p>
+            <a:pPr indent="0" marL="0">
+              <a:buNone/>
+            </a:pPr>
+            <a:r>
+              <a:rPr lang="en-US" sz="1400" dirty="0" b="1">
+                <a:solidFill>
+                  <a:schemeClr val="accent6"/>
+                </a:solidFill>
+              </a:rPr>
+              <a:t>30%</a:t>
+            </a:r>
+            <a:endParaRPr lang="en-US" sz="1400" dirty="0"/>
+          </a:p>
+        </p:txBody>
+      </p:sp>
+      <p:sp>
+        <p:nvSpPr>
+          <p:cNvPr id="6" name="Text 3"/>
+          <p:cNvSpPr txBox="1"/>
+          <p:nvPr/>
+        </p:nvSpPr>
+        <p:spPr>
+          <a:xfrm>
+            <a:off x="3200400" y="2148840"/>
+            <a:ext cx="1600200" cy="365760"/>
+          </a:xfrm>
+          <a:prstGeom prst="rect">
+            <a:avLst/>
+          </a:prstGeom>
+          <a:noFill/>
+          <a:ln/>
+        </p:spPr>
+        <p:txBody>
+          <a:bodyPr wrap="square" lIns="0" tIns="0" rIns="0" bIns="0" rtlCol="0" anchor="ctr"/>
+          <a:lstStyle/>
+          <a:p>
+            <a:pPr indent="0" marL="0">
+              <a:buNone/>
+            </a:pPr>
+            <a:r>
+              <a:rPr lang="en-US" sz="1400" dirty="0">
+                <a:solidFill>
+                  <a:schemeClr val="accent6"/>
+                </a:solidFill>
+              </a:rPr>
+              <a:t>Study environment</a:t>
+            </a:r>
+            <a:endParaRPr lang="en-US" sz="1400" dirty="0"/>
+          </a:p>
+        </p:txBody>
+      </p:sp>
+      <p:sp>
+        <p:nvSpPr>
+          <p:cNvPr id="27" name="bar-Study environment"/>
+          <p:cNvSpPr/>
+          <p:nvPr/>
+        </p:nvSpPr>
+        <p:spPr>
+          <a:xfrm>
+            <a:off x="4892040" y="2203704"/>
+            <a:ext cx="2743200" cy="256032"/>
+          </a:xfrm>
+          <a:prstGeom prst="rect">
+            <a:avLst/>
+          </a:prstGeom>
+          <a:solidFill>
+            <a:schemeClr val="accent1"/>
+          </a:solidFill>
+          <a:ln>
+            <a:noFill/>
+          </a:ln>
+        </p:spPr>
+        <p:style>
+          <a:lnRef idx="1">
+            <a:schemeClr val="accent1"/>
+          </a:lnRef>
+          <a:fillRef idx="3">
+            <a:schemeClr val="accent1"/>
+          </a:fillRef>
+          <a:effectRef idx="2">
+            <a:schemeClr val="accent1"/>
+          </a:effectRef>
+          <a:fontRef idx="minor">
+            <a:schemeClr val="lt1"/>
+          </a:fontRef>
+        </p:style>
+        <p:txBody>
+          <a:bodyPr rtlCol="0" anchor="ctr"/>
+          <a:lstStyle/>
+          <a:p>
+            <a:pPr algn="ctr"/>
+          </a:p>
+        </p:txBody>
+      </p:sp>
+      <p:sp>
+        <p:nvSpPr>
+          <p:cNvPr id="6" name="Text 3"/>
+          <p:cNvSpPr txBox="1"/>
+          <p:nvPr/>
+        </p:nvSpPr>
+        <p:spPr>
+          <a:xfrm>
+            <a:off x="7726680" y="2148840"/>
+            <a:ext cx="640080" cy="365760"/>
+          </a:xfrm>
+          <a:prstGeom prst="rect">
+            <a:avLst/>
+          </a:prstGeom>
+          <a:noFill/>
+          <a:ln/>
+        </p:spPr>
+        <p:txBody>
+          <a:bodyPr wrap="square" lIns="0" tIns="0" rIns="0" bIns="0" rtlCol="0" anchor="t"/>
+          <a:lstStyle/>
+          <a:p>
+            <a:pPr indent="0" marL="0">
+              <a:buNone/>
+            </a:pPr>
+            <a:r>
+              <a:rPr lang="en-US" sz="1400" dirty="0" b="1">
+                <a:solidFill>
+                  <a:schemeClr val="accent6"/>
+                </a:solidFill>
+              </a:rPr>
+              <a:t>25%</a:t>
+            </a:r>
+            <a:endParaRPr lang="en-US" sz="1400" dirty="0"/>
+          </a:p>
+        </p:txBody>
+      </p:sp>
+      <p:sp>
+        <p:nvSpPr>
+          <p:cNvPr id="6" name="Text 3"/>
+          <p:cNvSpPr txBox="1"/>
+          <p:nvPr/>
+        </p:nvSpPr>
+        <p:spPr>
+          <a:xfrm>
+            <a:off x="3200400" y="2697480"/>
+            <a:ext cx="1600200" cy="365760"/>
+          </a:xfrm>
+          <a:prstGeom prst="rect">
+            <a:avLst/>
+          </a:prstGeom>
+          <a:noFill/>
+          <a:ln/>
+        </p:spPr>
+        <p:txBody>
+          <a:bodyPr wrap="square" lIns="0" tIns="0" rIns="0" bIns="0" rtlCol="0" anchor="ctr"/>
+          <a:lstStyle/>
+          <a:p>
+            <a:pPr indent="0" marL="0">
+              <a:buNone/>
+            </a:pPr>
+            <a:r>
+              <a:rPr lang="en-US" sz="1400" dirty="0">
+                <a:solidFill>
+                  <a:schemeClr val="accent6"/>
+                </a:solidFill>
+              </a:rPr>
+              <a:t>Cleanliness</a:t>
+            </a:r>
+            <a:endParaRPr lang="en-US" sz="1400" dirty="0"/>
+          </a:p>
+        </p:txBody>
+      </p:sp>
+      <p:sp>
+        <p:nvSpPr>
+          <p:cNvPr id="28" name="bar-Cleanliness"/>
+          <p:cNvSpPr/>
+          <p:nvPr/>
+        </p:nvSpPr>
+        <p:spPr>
+          <a:xfrm>
+            <a:off x="4892040" y="2752344"/>
+            <a:ext cx="2743200" cy="256032"/>
+          </a:xfrm>
+          <a:prstGeom prst="rect">
+            <a:avLst/>
+          </a:prstGeom>
+          <a:solidFill>
+            <a:schemeClr val="accent1"/>
+          </a:solidFill>
+          <a:ln>
+            <a:noFill/>
+          </a:ln>
+        </p:spPr>
+        <p:style>
+          <a:lnRef idx="1">
+            <a:schemeClr val="accent1"/>
+          </a:lnRef>
+          <a:fillRef idx="3">
+            <a:schemeClr val="accent1"/>
+          </a:fillRef>
+          <a:effectRef idx="2">
+            <a:schemeClr val="accent1"/>
+          </a:effectRef>
+          <a:fontRef idx="minor">
+            <a:schemeClr val="lt1"/>
+          </a:fontRef>
+        </p:style>
+        <p:txBody>
+          <a:bodyPr rtlCol="0" anchor="ctr"/>
+          <a:lstStyle/>
+          <a:p>
+            <a:pPr algn="ctr"/>
+          </a:p>
+        </p:txBody>
+      </p:sp>
+      <p:sp>
+        <p:nvSpPr>
+          <p:cNvPr id="6" name="Text 3"/>
+          <p:cNvSpPr txBox="1"/>
+          <p:nvPr/>
+        </p:nvSpPr>
+        <p:spPr>
+          <a:xfrm>
+            <a:off x="7726680" y="2697480"/>
+            <a:ext cx="640080" cy="365760"/>
+          </a:xfrm>
+          <a:prstGeom prst="rect">
+            <a:avLst/>
+          </a:prstGeom>
+          <a:noFill/>
+          <a:ln/>
+        </p:spPr>
+        <p:txBody>
+          <a:bodyPr wrap="square" lIns="0" tIns="0" rIns="0" bIns="0" rtlCol="0" anchor="t"/>
+          <a:lstStyle/>
+          <a:p>
+            <a:pPr indent="0" marL="0">
+              <a:buNone/>
+            </a:pPr>
+            <a:r>
+              <a:rPr lang="en-US" sz="1400" dirty="0" b="1">
+                <a:solidFill>
+                  <a:schemeClr val="accent6"/>
+                </a:solidFill>
+              </a:rPr>
+              <a:t>25%</a:t>
+            </a:r>
+            <a:endParaRPr lang="en-US" sz="1400" dirty="0"/>
+          </a:p>
+        </p:txBody>
+      </p:sp>
+      <p:sp>
+        <p:nvSpPr>
+          <p:cNvPr id="6" name="Text 3"/>
+          <p:cNvSpPr txBox="1"/>
+          <p:nvPr/>
+        </p:nvSpPr>
+        <p:spPr>
+          <a:xfrm>
+            <a:off x="3200400" y="3246120"/>
+            <a:ext cx="1600200" cy="365760"/>
+          </a:xfrm>
+          <a:prstGeom prst="rect">
+            <a:avLst/>
+          </a:prstGeom>
+          <a:noFill/>
+          <a:ln/>
+        </p:spPr>
+        <p:txBody>
+          <a:bodyPr wrap="square" lIns="0" tIns="0" rIns="0" bIns="0" rtlCol="0" anchor="ctr"/>
+          <a:lstStyle/>
+          <a:p>
+            <a:pPr indent="0" marL="0">
+              <a:buNone/>
+            </a:pPr>
+            <a:r>
+              <a:rPr lang="en-US" sz="1400" dirty="0">
+                <a:solidFill>
+                  <a:schemeClr val="accent6"/>
+                </a:solidFill>
+              </a:rPr>
+              <a:t>Social preference</a:t>
+            </a:r>
+            <a:endParaRPr lang="en-US" sz="1400" dirty="0"/>
+          </a:p>
+        </p:txBody>
+      </p:sp>
+      <p:sp>
+        <p:nvSpPr>
+          <p:cNvPr id="29" name="bar-Social preference"/>
+          <p:cNvSpPr/>
+          <p:nvPr/>
+        </p:nvSpPr>
+        <p:spPr>
+          <a:xfrm>
+            <a:off x="4892040" y="3300984"/>
+            <a:ext cx="2194560" cy="256032"/>
+          </a:xfrm>
+          <a:prstGeom prst="rect">
+            <a:avLst/>
+          </a:prstGeom>
+          <a:solidFill>
+            <a:schemeClr val="accent1"/>
+          </a:solidFill>
+          <a:ln>
+            <a:noFill/>
+          </a:ln>
+        </p:spPr>
+        <p:style>
+          <a:lnRef idx="1">
+            <a:schemeClr val="accent1"/>
+          </a:lnRef>
+          <a:fillRef idx="3">
+            <a:schemeClr val="accent1"/>
+          </a:fillRef>
+          <a:effectRef idx="2">
+            <a:schemeClr val="accent1"/>
+          </a:effectRef>
+          <a:fontRef idx="minor">
+            <a:schemeClr val="lt1"/>
+          </a:fontRef>
+        </p:style>
+        <p:txBody>
+          <a:bodyPr rtlCol="0" anchor="ctr"/>
+          <a:lstStyle/>
+          <a:p>
+            <a:pPr algn="ctr"/>
+          </a:p>
+        </p:txBody>
+      </p:sp>
+      <p:sp>
+        <p:nvSpPr>
+          <p:cNvPr id="6" name="Text 3"/>
+          <p:cNvSpPr txBox="1"/>
+          <p:nvPr/>
+        </p:nvSpPr>
+        <p:spPr>
+          <a:xfrm>
+            <a:off x="7178040" y="3246120"/>
+            <a:ext cx="640080" cy="365760"/>
+          </a:xfrm>
+          <a:prstGeom prst="rect">
+            <a:avLst/>
+          </a:prstGeom>
+          <a:noFill/>
+          <a:ln/>
+        </p:spPr>
+        <p:txBody>
+          <a:bodyPr wrap="square" lIns="0" tIns="0" rIns="0" bIns="0" rtlCol="0" anchor="t"/>
+          <a:lstStyle/>
+          <a:p>
+            <a:pPr indent="0" marL="0">
+              <a:buNone/>
+            </a:pPr>
+            <a:r>
+              <a:rPr lang="en-US" sz="1400" dirty="0" b="1">
+                <a:solidFill>
+                  <a:schemeClr val="accent6"/>
+                </a:solidFill>
+              </a:rPr>
+              <a:t>20%</a:t>
+            </a:r>
+            <a:endParaRPr lang="en-US" sz="1400" dirty="0"/>
           </a:p>
         </p:txBody>
       </p:sp>
@@ -6753,7 +7295,7 @@
         <p:spPr>
           <a:xfrm>
             <a:off x="420624" y="1152144"/>
-            <a:ext cx="4050792" cy="3133595"/>
+            <a:ext cx="4050792" cy="2385155"/>
           </a:xfrm>
           <a:prstGeom prst="rect">
             <a:avLst/>
@@ -6785,7 +7327,7 @@
           <p:nvPr/>
         </p:nvPicPr>
         <p:blipFill>
-          <a:blip r:embed="rId1"/>
+          <a:blip r:embed="rId5"/>
           <a:stretch>
             <a:fillRect/>
           </a:stretch>
@@ -6793,7 +7335,7 @@
         <p:spPr>
           <a:xfrm>
             <a:off x="457200" y="1188720"/>
-            <a:ext cx="3977640" cy="3060443"/>
+            <a:ext cx="3977640" cy="2312003"/>
           </a:xfrm>
           <a:prstGeom prst="rect">
             <a:avLst/>
@@ -6808,7 +7350,7 @@
         </p:nvSpPr>
         <p:spPr>
           <a:xfrm>
-            <a:off x="457200" y="4340603"/>
+            <a:off x="457200" y="3592163"/>
             <a:ext cx="3977640" cy="256032"/>
           </a:xfrm>
           <a:prstGeom prst="rect">
@@ -6845,7 +7387,7 @@
         <p:spPr>
           <a:xfrm>
             <a:off x="4672584" y="1152144"/>
-            <a:ext cx="4050792" cy="3133595"/>
+            <a:ext cx="4050791" cy="3133595"/>
           </a:xfrm>
           <a:prstGeom prst="rect">
             <a:avLst/>
@@ -6877,7 +7419,7 @@
           <p:nvPr/>
         </p:nvPicPr>
         <p:blipFill>
-          <a:blip r:embed="rId2"/>
+          <a:blip r:embed="rId1"/>
           <a:stretch>
             <a:fillRect/>
           </a:stretch>
@@ -6885,7 +7427,7 @@
         <p:spPr>
           <a:xfrm>
             <a:off x="4709160" y="1188720"/>
-            <a:ext cx="3977640" cy="3060443"/>
+            <a:ext cx="3977639" cy="3060443"/>
           </a:xfrm>
           <a:prstGeom prst="rect">
             <a:avLst/>
@@ -6900,7 +7442,7 @@
         </p:nvSpPr>
         <p:spPr>
           <a:xfrm>
-            <a:off x="4709160" y="4340603"/>
+            <a:off x="4709159" y="4340603"/>
             <a:ext cx="3977640" cy="256032"/>
           </a:xfrm>
           <a:prstGeom prst="rect">
@@ -7088,8 +7630,8 @@
         </p:nvSpPr>
         <p:spPr>
           <a:xfrm>
-            <a:off x="1029017" y="1152144"/>
-            <a:ext cx="2834006" cy="3200400"/>
+            <a:off x="1170157" y="1152144"/>
+            <a:ext cx="2551726" cy="3200400"/>
           </a:xfrm>
           <a:prstGeom prst="rect">
             <a:avLst/>
@@ -7111,6 +7653,10 @@
             </a:outerShdw>
           </a:effectLst>
         </p:spPr>
+        <p:txBody>
+          <a:bodyPr/>
+          <a:p/>
+        </p:txBody>
       </p:sp>
       <p:pic>
         <p:nvPicPr>
@@ -7121,15 +7667,15 @@
           <p:nvPr/>
         </p:nvPicPr>
         <p:blipFill>
-          <a:blip r:embed="rId1"/>
+          <a:blip r:embed="rId5"/>
           <a:stretch>
             <a:fillRect/>
           </a:stretch>
         </p:blipFill>
         <p:spPr>
           <a:xfrm>
-            <a:off x="1065593" y="1188720"/>
-            <a:ext cx="2760854" cy="3127248"/>
+            <a:off x="1206733" y="1188720"/>
+            <a:ext cx="2478574" cy="3127248"/>
           </a:xfrm>
           <a:prstGeom prst="rect">
             <a:avLst/>
@@ -7180,8 +7726,8 @@
         </p:nvSpPr>
         <p:spPr>
           <a:xfrm>
-            <a:off x="5001605" y="1152144"/>
-            <a:ext cx="3392751" cy="3200400"/>
+            <a:off x="5125082" y="1152144"/>
+            <a:ext cx="3145797" cy="3200400"/>
           </a:xfrm>
           <a:prstGeom prst="rect">
             <a:avLst/>
@@ -7203,6 +7749,10 @@
             </a:outerShdw>
           </a:effectLst>
         </p:spPr>
+        <p:txBody>
+          <a:bodyPr/>
+          <a:p/>
+        </p:txBody>
       </p:sp>
       <p:pic>
         <p:nvPicPr>
@@ -7213,15 +7763,15 @@
           <p:nvPr/>
         </p:nvPicPr>
         <p:blipFill>
-          <a:blip r:embed="rId2"/>
+          <a:blip r:embed="rId1"/>
           <a:stretch>
             <a:fillRect/>
           </a:stretch>
         </p:blipFill>
         <p:spPr>
           <a:xfrm>
-            <a:off x="5038181" y="1188720"/>
-            <a:ext cx="3319599" cy="3127248"/>
+            <a:off x="5161658" y="1188720"/>
+            <a:ext cx="3072645" cy="3127248"/>
           </a:xfrm>
           <a:prstGeom prst="rect">
             <a:avLst/>
@@ -7258,7 +7808,7 @@
                   <a:schemeClr val="accent6"/>
                 </a:solidFill>
               </a:rPr>
-              <a:t>Sparking socket filed earlier: Electrical, critical, 2 h</a:t>
+              <a:t>Seeded hazards escalated to critical, 2 h target</a:t>
             </a:r>
             <a:endParaRPr lang="en-US" sz="1100" dirty="0"/>
           </a:p>
@@ -7440,6 +7990,10 @@
             <a:prstDash val="solid"/>
           </a:ln>
         </p:spPr>
+        <p:txBody>
+          <a:bodyPr/>
+          <a:p/>
+        </p:txBody>
       </p:sp>
       <p:sp>
         <p:nvSpPr>
@@ -7530,7 +8084,7 @@
                   <a:schemeClr val="accent6"/>
                 </a:solidFill>
               </a:rPr>
-              <a:t>MiniLM embeddings over six rulebooks</a:t>
+              <a:t>MiniLM embeddings over eight rulebooks</a:t>
             </a:r>
             <a:endParaRPr lang="en-US" sz="1500" dirty="0"/>
           </a:p>
@@ -7785,7 +8339,7 @@
         <p:spPr>
           <a:xfrm>
             <a:off x="3986784" y="1078992"/>
-            <a:ext cx="4731838" cy="3657600"/>
+            <a:ext cx="4731838" cy="3657599"/>
           </a:xfrm>
           <a:prstGeom prst="rect">
             <a:avLst/>
@@ -7817,7 +8371,7 @@
           <p:nvPr/>
         </p:nvPicPr>
         <p:blipFill>
-          <a:blip r:embed="rId1"/>
+          <a:blip r:embed="rId4"/>
           <a:stretch>
             <a:fillRect/>
           </a:stretch>
@@ -7825,7 +8379,7 @@
         <p:spPr>
           <a:xfrm>
             <a:off x="4023360" y="1115568"/>
-            <a:ext cx="4658686" cy="3584448"/>
+            <a:ext cx="4658686" cy="3584447"/>
           </a:xfrm>
           <a:prstGeom prst="rect">
             <a:avLst/>
@@ -7993,7 +8547,7 @@
         <p:spPr>
           <a:xfrm>
             <a:off x="420624" y="1152144"/>
-            <a:ext cx="4050792" cy="3133595"/>
+            <a:ext cx="4050791" cy="3133595"/>
           </a:xfrm>
           <a:prstGeom prst="rect">
             <a:avLst/>
@@ -8025,7 +8579,7 @@
           <p:nvPr/>
         </p:nvPicPr>
         <p:blipFill>
-          <a:blip r:embed="rId1"/>
+          <a:blip r:embed="rId5"/>
           <a:stretch>
             <a:fillRect/>
           </a:stretch>
@@ -8033,7 +8587,7 @@
         <p:spPr>
           <a:xfrm>
             <a:off x="457200" y="1188720"/>
-            <a:ext cx="3977640" cy="3060443"/>
+            <a:ext cx="3977639" cy="3060443"/>
           </a:xfrm>
           <a:prstGeom prst="rect">
             <a:avLst/>
@@ -8048,7 +8602,7 @@
         </p:nvSpPr>
         <p:spPr>
           <a:xfrm>
-            <a:off x="457200" y="4340603"/>
+            <a:off x="457199" y="4340603"/>
             <a:ext cx="3977640" cy="256032"/>
           </a:xfrm>
           <a:prstGeom prst="rect">
@@ -8085,7 +8639,7 @@
         <p:spPr>
           <a:xfrm>
             <a:off x="4672584" y="1152144"/>
-            <a:ext cx="4050792" cy="3133595"/>
+            <a:ext cx="4050791" cy="3133595"/>
           </a:xfrm>
           <a:prstGeom prst="rect">
             <a:avLst/>
@@ -8117,7 +8671,7 @@
           <p:nvPr/>
         </p:nvPicPr>
         <p:blipFill>
-          <a:blip r:embed="rId2"/>
+          <a:blip r:embed="rId1"/>
           <a:stretch>
             <a:fillRect/>
           </a:stretch>
@@ -8125,7 +8679,7 @@
         <p:spPr>
           <a:xfrm>
             <a:off x="4709160" y="1188720"/>
-            <a:ext cx="3977640" cy="3060443"/>
+            <a:ext cx="3977639" cy="3060443"/>
           </a:xfrm>
           <a:prstGeom prst="rect">
             <a:avLst/>
@@ -8140,7 +8694,7 @@
         </p:nvSpPr>
         <p:spPr>
           <a:xfrm>
-            <a:off x="4709160" y="4340603"/>
+            <a:off x="4709159" y="4340603"/>
             <a:ext cx="3977640" cy="256032"/>
           </a:xfrm>
           <a:prstGeom prst="rect">
@@ -8329,7 +8883,7 @@
         <p:spPr>
           <a:xfrm>
             <a:off x="420624" y="1152144"/>
-            <a:ext cx="4050792" cy="3133595"/>
+            <a:ext cx="4050791" cy="3133595"/>
           </a:xfrm>
           <a:prstGeom prst="rect">
             <a:avLst/>
@@ -8361,7 +8915,7 @@
           <p:nvPr/>
         </p:nvPicPr>
         <p:blipFill>
-          <a:blip r:embed="rId1"/>
+          <a:blip r:embed="rId5"/>
           <a:stretch>
             <a:fillRect/>
           </a:stretch>
@@ -8369,7 +8923,7 @@
         <p:spPr>
           <a:xfrm>
             <a:off x="457200" y="1188720"/>
-            <a:ext cx="3977640" cy="3060443"/>
+            <a:ext cx="3977639" cy="3060443"/>
           </a:xfrm>
           <a:prstGeom prst="rect">
             <a:avLst/>
@@ -8384,7 +8938,7 @@
         </p:nvSpPr>
         <p:spPr>
           <a:xfrm>
-            <a:off x="457200" y="4340603"/>
+            <a:off x="457199" y="4340603"/>
             <a:ext cx="3977640" cy="256032"/>
           </a:xfrm>
           <a:prstGeom prst="rect">
@@ -8421,7 +8975,7 @@
         <p:spPr>
           <a:xfrm>
             <a:off x="4672584" y="1152144"/>
-            <a:ext cx="4050792" cy="3133595"/>
+            <a:ext cx="4050791" cy="3133595"/>
           </a:xfrm>
           <a:prstGeom prst="rect">
             <a:avLst/>
@@ -8453,7 +9007,7 @@
           <p:nvPr/>
         </p:nvPicPr>
         <p:blipFill>
-          <a:blip r:embed="rId2"/>
+          <a:blip r:embed="rId1"/>
           <a:stretch>
             <a:fillRect/>
           </a:stretch>
@@ -8461,7 +9015,7 @@
         <p:spPr>
           <a:xfrm>
             <a:off x="4709160" y="1188720"/>
-            <a:ext cx="3977640" cy="3060443"/>
+            <a:ext cx="3977639" cy="3060443"/>
           </a:xfrm>
           <a:prstGeom prst="rect">
             <a:avLst/>
@@ -8476,7 +9030,7 @@
         </p:nvSpPr>
         <p:spPr>
           <a:xfrm>
-            <a:off x="4709160" y="4340603"/>
+            <a:off x="4709159" y="4340603"/>
             <a:ext cx="3977640" cy="256032"/>
           </a:xfrm>
           <a:prstGeom prst="rect">
@@ -9373,7 +9927,7 @@
         <p:spPr>
           <a:xfrm>
             <a:off x="420624" y="1152144"/>
-            <a:ext cx="4050792" cy="3133595"/>
+            <a:ext cx="4050791" cy="3133595"/>
           </a:xfrm>
           <a:prstGeom prst="rect">
             <a:avLst/>
@@ -9405,7 +9959,7 @@
           <p:nvPr/>
         </p:nvPicPr>
         <p:blipFill>
-          <a:blip r:embed="rId1"/>
+          <a:blip r:embed="rId5"/>
           <a:stretch>
             <a:fillRect/>
           </a:stretch>
@@ -9413,7 +9967,7 @@
         <p:spPr>
           <a:xfrm>
             <a:off x="457200" y="1188720"/>
-            <a:ext cx="3977640" cy="3060443"/>
+            <a:ext cx="3977639" cy="3060443"/>
           </a:xfrm>
           <a:prstGeom prst="rect">
             <a:avLst/>
@@ -9428,7 +9982,7 @@
         </p:nvSpPr>
         <p:spPr>
           <a:xfrm>
-            <a:off x="457200" y="4340603"/>
+            <a:off x="457199" y="4340603"/>
             <a:ext cx="3977640" cy="256032"/>
           </a:xfrm>
           <a:prstGeom prst="rect">
@@ -9464,8 +10018,8 @@
         </p:nvSpPr>
         <p:spPr>
           <a:xfrm>
-            <a:off x="4672584" y="1152144"/>
-            <a:ext cx="4050792" cy="2342747"/>
+            <a:off x="5472296" y="1152144"/>
+            <a:ext cx="2451367" cy="2342747"/>
           </a:xfrm>
           <a:prstGeom prst="rect">
             <a:avLst/>
@@ -9497,15 +10051,15 @@
           <p:nvPr/>
         </p:nvPicPr>
         <p:blipFill>
-          <a:blip r:embed="rId2"/>
+          <a:blip r:embed="rId1"/>
           <a:stretch>
             <a:fillRect/>
           </a:stretch>
         </p:blipFill>
         <p:spPr>
           <a:xfrm>
-            <a:off x="4709160" y="1188720"/>
-            <a:ext cx="3977640" cy="2269595"/>
+            <a:off x="5508872" y="1188720"/>
+            <a:ext cx="2378215" cy="2269595"/>
           </a:xfrm>
           <a:prstGeom prst="rect">
             <a:avLst/>
@@ -9520,7 +10074,7 @@
         </p:nvSpPr>
         <p:spPr>
           <a:xfrm>
-            <a:off x="4709160" y="3549755"/>
+            <a:off x="4709159" y="3549755"/>
             <a:ext cx="3977640" cy="256032"/>
           </a:xfrm>
           <a:prstGeom prst="rect">
@@ -9708,8 +10262,8 @@
         </p:nvSpPr>
         <p:spPr>
           <a:xfrm>
-            <a:off x="420624" y="1152144"/>
-            <a:ext cx="4050792" cy="1708664"/>
+            <a:off x="567279" y="1152144"/>
+            <a:ext cx="3757482" cy="1708664"/>
           </a:xfrm>
           <a:prstGeom prst="rect">
             <a:avLst/>
@@ -9741,15 +10295,15 @@
           <p:nvPr/>
         </p:nvPicPr>
         <p:blipFill>
-          <a:blip r:embed="rId1"/>
+          <a:blip r:embed="rId5"/>
           <a:stretch>
             <a:fillRect/>
           </a:stretch>
         </p:blipFill>
         <p:spPr>
           <a:xfrm>
-            <a:off x="457200" y="1188720"/>
-            <a:ext cx="3977640" cy="1635512"/>
+            <a:off x="603855" y="1188720"/>
+            <a:ext cx="3684330" cy="1635512"/>
           </a:xfrm>
           <a:prstGeom prst="rect">
             <a:avLst/>
@@ -9801,7 +10355,7 @@
         <p:spPr>
           <a:xfrm>
             <a:off x="4672584" y="1152144"/>
-            <a:ext cx="4050792" cy="3133595"/>
+            <a:ext cx="4050791" cy="3133595"/>
           </a:xfrm>
           <a:prstGeom prst="rect">
             <a:avLst/>
@@ -9833,7 +10387,7 @@
           <p:nvPr/>
         </p:nvPicPr>
         <p:blipFill>
-          <a:blip r:embed="rId2"/>
+          <a:blip r:embed="rId1"/>
           <a:stretch>
             <a:fillRect/>
           </a:stretch>
@@ -9841,7 +10395,7 @@
         <p:spPr>
           <a:xfrm>
             <a:off x="4709160" y="1188720"/>
-            <a:ext cx="3977640" cy="3060443"/>
+            <a:ext cx="3977639" cy="3060443"/>
           </a:xfrm>
           <a:prstGeom prst="rect">
             <a:avLst/>
@@ -9856,7 +10410,7 @@
         </p:nvSpPr>
         <p:spPr>
           <a:xfrm>
-            <a:off x="4709160" y="4340603"/>
+            <a:off x="4709159" y="4340603"/>
             <a:ext cx="3977640" cy="256032"/>
           </a:xfrm>
           <a:prstGeom prst="rect">
@@ -10045,7 +10599,7 @@
         <p:spPr>
           <a:xfrm>
             <a:off x="420624" y="1152144"/>
-            <a:ext cx="4050792" cy="3133595"/>
+            <a:ext cx="4050791" cy="3133595"/>
           </a:xfrm>
           <a:prstGeom prst="rect">
             <a:avLst/>
@@ -10077,7 +10631,7 @@
           <p:nvPr/>
         </p:nvPicPr>
         <p:blipFill>
-          <a:blip r:embed="rId1"/>
+          <a:blip r:embed="rId5"/>
           <a:stretch>
             <a:fillRect/>
           </a:stretch>
@@ -10085,7 +10639,7 @@
         <p:spPr>
           <a:xfrm>
             <a:off x="457200" y="1188720"/>
-            <a:ext cx="3977640" cy="3060443"/>
+            <a:ext cx="3977639" cy="3060443"/>
           </a:xfrm>
           <a:prstGeom prst="rect">
             <a:avLst/>
@@ -10100,7 +10654,7 @@
         </p:nvSpPr>
         <p:spPr>
           <a:xfrm>
-            <a:off x="457200" y="4340603"/>
+            <a:off x="457199" y="4340603"/>
             <a:ext cx="3977640" cy="256032"/>
           </a:xfrm>
           <a:prstGeom prst="rect">
@@ -10136,8 +10690,8 @@
         </p:nvSpPr>
         <p:spPr>
           <a:xfrm>
-            <a:off x="4672584" y="1152144"/>
-            <a:ext cx="4050792" cy="2682484"/>
+            <a:off x="5594084" y="1152144"/>
+            <a:ext cx="2207791" cy="2682484"/>
           </a:xfrm>
           <a:prstGeom prst="rect">
             <a:avLst/>
@@ -10169,15 +10723,15 @@
           <p:nvPr/>
         </p:nvPicPr>
         <p:blipFill>
-          <a:blip r:embed="rId2"/>
+          <a:blip r:embed="rId1"/>
           <a:stretch>
             <a:fillRect/>
           </a:stretch>
         </p:blipFill>
         <p:spPr>
           <a:xfrm>
-            <a:off x="4709160" y="1188720"/>
-            <a:ext cx="3977640" cy="2609332"/>
+            <a:off x="5630660" y="1188720"/>
+            <a:ext cx="2134639" cy="2609332"/>
           </a:xfrm>
           <a:prstGeom prst="rect">
             <a:avLst/>
@@ -10192,7 +10746,7 @@
         </p:nvSpPr>
         <p:spPr>
           <a:xfrm>
-            <a:off x="4709160" y="3889492"/>
+            <a:off x="4709159" y="3889492"/>
             <a:ext cx="3977640" cy="256032"/>
           </a:xfrm>
           <a:prstGeom prst="rect">
@@ -10263,342 +10817,6 @@
             <a:fld id="{F7021451-1387-4CA6-816F-3879F97B5CBC}" type="slidenum">
               <a:rPr b="0" lang="en-US"/>
               <a:t>22</a:t>
-            </a:fld>
-            <a:endParaRPr lang="en-US"/>
-          </a:p>
-        </p:txBody>
-      </p:sp>
-    </p:spTree>
-  </p:cSld>
-  <p:clrMapOvr>
-    <a:masterClrMapping/>
-  </p:clrMapOvr>
-</p:sld>
-</file>
-
-<file path=ppt/slides/slide23.xml><?xml version="1.0" encoding="utf-8"?>
-<p:sld xmlns:a="http://schemas.openxmlformats.org/drawingml/2006/main" xmlns:r="http://schemas.openxmlformats.org/officeDocument/2006/relationships" xmlns:p="http://schemas.openxmlformats.org/presentationml/2006/main">
-  <p:cSld name="Slide 23">
-    <p:spTree>
-      <p:nvGrpSpPr>
-        <p:cNvPr id="1" name=""/>
-        <p:cNvGrpSpPr/>
-        <p:nvPr/>
-      </p:nvGrpSpPr>
-      <p:grpSpPr>
-        <a:xfrm>
-          <a:off x="0" y="0"/>
-          <a:ext cx="0" cy="0"/>
-          <a:chOff x="0" y="0"/>
-          <a:chExt cx="0" cy="0"/>
-        </a:xfrm>
-      </p:grpSpPr>
-      <p:sp>
-        <p:nvSpPr>
-          <p:cNvPr id="2" name="Text 0"/>
-          <p:cNvSpPr/>
-          <p:nvPr>
-            <p:ph idx="100" type="body" hasCustomPrompt="1"/>
-          </p:nvPr>
-        </p:nvSpPr>
-        <p:spPr>
-          <a:xfrm>
-            <a:off x="457200" y="201168"/>
-            <a:ext cx="6400800" cy="256032"/>
-          </a:xfrm>
-          <a:prstGeom prst="rect">
-            <a:avLst/>
-          </a:prstGeom>
-          <a:noFill/>
-          <a:ln/>
-        </p:spPr>
-        <p:txBody>
-          <a:bodyPr wrap="square" lIns="0" tIns="0" rIns="0" bIns="0" rtlCol="0"/>
-          <a:lstStyle/>
-          <a:p>
-            <a:pPr indent="0" marL="0">
-              <a:buNone/>
-            </a:pPr>
-            <a:r>
-              <a:rPr lang="en-US" sz="1000" b="1" dirty="0">
-                <a:solidFill>
-                  <a:schemeClr val="accent2"/>
-                </a:solidFill>
-                <a:latin typeface="Courier New" pitchFamily="34" charset="0"/>
-                <a:ea typeface="Courier New" pitchFamily="34" charset="-122"/>
-                <a:cs typeface="Courier New" pitchFamily="34" charset="-120"/>
-              </a:rPr>
-              <a:t>OPERATIONS</a:t>
-            </a:r>
-            <a:endParaRPr lang="en-US" sz="1000" dirty="0"/>
-          </a:p>
-        </p:txBody>
-      </p:sp>
-      <p:sp>
-        <p:nvSpPr>
-          <p:cNvPr id="3" name="Text 0"/>
-          <p:cNvSpPr/>
-          <p:nvPr>
-            <p:ph idx="101" type="title" hasCustomPrompt="1"/>
-          </p:nvPr>
-        </p:nvSpPr>
-        <p:spPr>
-          <a:xfrm>
-            <a:off x="457200" y="457200"/>
-            <a:ext cx="8229600" cy="548640"/>
-          </a:xfrm>
-          <a:prstGeom prst="rect">
-            <a:avLst/>
-          </a:prstGeom>
-          <a:noFill/>
-          <a:ln/>
-        </p:spPr>
-        <p:txBody>
-          <a:bodyPr wrap="square" lIns="0" tIns="0" rIns="0" bIns="0" rtlCol="0" anchor="t"/>
-          <a:lstStyle/>
-          <a:p>
-            <a:pPr indent="0" marL="0">
-              <a:buNone/>
-            </a:pPr>
-            <a:r>
-              <a:rPr lang="en-US" sz="2800" b="1" dirty="0">
-                <a:solidFill>
-                  <a:schemeClr val="tx2"/>
-                </a:solidFill>
-              </a:rPr>
-              <a:t>Command overview and resident welfare</a:t>
-            </a:r>
-            <a:endParaRPr lang="en-US" sz="2800" dirty="0"/>
-          </a:p>
-        </p:txBody>
-      </p:sp>
-      <p:sp>
-        <p:nvSpPr>
-          <p:cNvPr id="5" name="frame-06-admin-overview"/>
-          <p:cNvSpPr/>
-          <p:nvPr/>
-        </p:nvSpPr>
-        <p:spPr>
-          <a:xfrm>
-            <a:off x="420624" y="1152144"/>
-            <a:ext cx="4050792" cy="2090049"/>
-          </a:xfrm>
-          <a:prstGeom prst="rect">
-            <a:avLst/>
-          </a:prstGeom>
-          <a:solidFill>
-            <a:schemeClr val="bg1"/>
-          </a:solidFill>
-          <a:ln w="9525">
-            <a:solidFill>
-              <a:schemeClr val="accent1"/>
-            </a:solidFill>
-            <a:prstDash val="solid"/>
-          </a:ln>
-          <a:effectLst>
-            <a:outerShdw sx="100000" sy="100000" kx="0" ky="0" algn="bl" rotWithShape="0" blurRad="76200" dist="25400" dir="5400000">
-              <a:srgbClr val="000000">
-                <a:alpha val="18000"/>
-              </a:srgbClr>
-            </a:outerShdw>
-          </a:effectLst>
-        </p:spPr>
-      </p:sp>
-      <p:pic>
-        <p:nvPicPr>
-          <p:cNvPr id="6" name="shot-06-admin-overview" descr="06-admin-overview">    </p:cNvPr>
-          <p:cNvPicPr>
-            <a:picLocks noChangeAspect="1"/>
-          </p:cNvPicPr>
-          <p:nvPr/>
-        </p:nvPicPr>
-        <p:blipFill>
-          <a:blip r:embed="rId1"/>
-          <a:stretch>
-            <a:fillRect/>
-          </a:stretch>
-        </p:blipFill>
-        <p:spPr>
-          <a:xfrm>
-            <a:off x="457200" y="1188720"/>
-            <a:ext cx="3977640" cy="2016897"/>
-          </a:xfrm>
-          <a:prstGeom prst="rect">
-            <a:avLst/>
-          </a:prstGeom>
-        </p:spPr>
-      </p:pic>
-      <p:sp>
-        <p:nvSpPr>
-          <p:cNvPr id="7" name="cap-06-admin-overview"/>
-          <p:cNvSpPr txBox="1"/>
-          <p:nvPr/>
-        </p:nvSpPr>
-        <p:spPr>
-          <a:xfrm>
-            <a:off x="457200" y="3297057"/>
-            <a:ext cx="3977640" cy="256032"/>
-          </a:xfrm>
-          <a:prstGeom prst="rect">
-            <a:avLst/>
-          </a:prstGeom>
-          <a:noFill/>
-          <a:ln/>
-        </p:spPr>
-        <p:txBody>
-          <a:bodyPr wrap="square" lIns="0" tIns="0" rIns="0" bIns="0" rtlCol="0" anchor="ctr"/>
-          <a:lstStyle/>
-          <a:p>
-            <a:pPr algn="ctr" indent="0" marL="0">
-              <a:buNone/>
-            </a:pPr>
-            <a:r>
-              <a:rPr lang="en-US" sz="1100" i="1" dirty="0">
-                <a:solidFill>
-                  <a:schemeClr val="accent6"/>
-                </a:solidFill>
-              </a:rPr>
-              <a:t>Live session diagnostics from the server</a:t>
-            </a:r>
-            <a:endParaRPr lang="en-US" sz="1100" dirty="0"/>
-          </a:p>
-        </p:txBody>
-      </p:sp>
-      <p:sp>
-        <p:nvSpPr>
-          <p:cNvPr id="8" name="frame-47-welfare"/>
-          <p:cNvSpPr/>
-          <p:nvPr/>
-        </p:nvSpPr>
-        <p:spPr>
-          <a:xfrm>
-            <a:off x="4672584" y="1152144"/>
-            <a:ext cx="4050792" cy="3133595"/>
-          </a:xfrm>
-          <a:prstGeom prst="rect">
-            <a:avLst/>
-          </a:prstGeom>
-          <a:solidFill>
-            <a:schemeClr val="bg1"/>
-          </a:solidFill>
-          <a:ln w="9525">
-            <a:solidFill>
-              <a:schemeClr val="accent1"/>
-            </a:solidFill>
-            <a:prstDash val="solid"/>
-          </a:ln>
-          <a:effectLst>
-            <a:outerShdw sx="100000" sy="100000" kx="0" ky="0" algn="bl" rotWithShape="0" blurRad="76200" dist="25400" dir="5400000">
-              <a:srgbClr val="000000">
-                <a:alpha val="18000"/>
-              </a:srgbClr>
-            </a:outerShdw>
-          </a:effectLst>
-        </p:spPr>
-      </p:sp>
-      <p:pic>
-        <p:nvPicPr>
-          <p:cNvPr id="9" name="shot-47-welfare" descr="47-welfare">    </p:cNvPr>
-          <p:cNvPicPr>
-            <a:picLocks noChangeAspect="1"/>
-          </p:cNvPicPr>
-          <p:nvPr/>
-        </p:nvPicPr>
-        <p:blipFill>
-          <a:blip r:embed="rId2"/>
-          <a:stretch>
-            <a:fillRect/>
-          </a:stretch>
-        </p:blipFill>
-        <p:spPr>
-          <a:xfrm>
-            <a:off x="4709160" y="1188720"/>
-            <a:ext cx="3977640" cy="3060443"/>
-          </a:xfrm>
-          <a:prstGeom prst="rect">
-            <a:avLst/>
-          </a:prstGeom>
-        </p:spPr>
-      </p:pic>
-      <p:sp>
-        <p:nvSpPr>
-          <p:cNvPr id="10" name="cap-47-welfare"/>
-          <p:cNvSpPr txBox="1"/>
-          <p:nvPr/>
-        </p:nvSpPr>
-        <p:spPr>
-          <a:xfrm>
-            <a:off x="4709160" y="4340603"/>
-            <a:ext cx="3977640" cy="256032"/>
-          </a:xfrm>
-          <a:prstGeom prst="rect">
-            <a:avLst/>
-          </a:prstGeom>
-          <a:noFill/>
-          <a:ln/>
-        </p:spPr>
-        <p:txBody>
-          <a:bodyPr wrap="square" lIns="0" tIns="0" rIns="0" bIns="0" rtlCol="0" anchor="ctr"/>
-          <a:lstStyle/>
-          <a:p>
-            <a:pPr algn="ctr" indent="0" marL="0">
-              <a:buNone/>
-            </a:pPr>
-            <a:r>
-              <a:rPr lang="en-US" sz="1100" i="1" dirty="0">
-                <a:solidFill>
-                  <a:schemeClr val="accent6"/>
-                </a:solidFill>
-              </a:rPr>
-              <a:t>Welfare early-warnings resolved by the warden</a:t>
-            </a:r>
-            <a:endParaRPr lang="en-US" sz="1100" dirty="0"/>
-          </a:p>
-        </p:txBody>
-      </p:sp>
-      <p:sp>
-        <p:nvSpPr>
-          <p:cNvPr id="25" name="Slide Number Placeholder 0"/>
-          <p:cNvSpPr>
-            <a:spLocks noGrp="1"/>
-          </p:cNvSpPr>
-          <p:nvPr>
-            <p:ph type="sldNum" sz="quarter" idx="4294967295"/>
-          </p:nvPr>
-        </p:nvSpPr>
-        <p:spPr>
-          <a:xfrm>
-            <a:off x="8229600" y="4800600"/>
-            <a:ext cx="457200" cy="228600"/>
-          </a:xfrm>
-          <a:prstGeom prst="rect">
-            <a:avLst/>
-          </a:prstGeom>
-          <a:extLst>
-            <a:ext uri="{C572A759-6A51-4108-AA02-DFA0A04FC94B}">
-              <ma14:wrappingTextBoxFlag xmlns:ma14="http://schemas.microsoft.com/office/mac/drawingml/2011/main" val="0"/>
-            </a:ext>
-          </a:extLst>
-        </p:spPr>
-        <p:txBody>
-          <a:bodyPr/>
-          <a:lstStyle>
-            <a:lvl1pPr>
-              <a:defRPr sz="800">
-                <a:solidFill>
-                  <a:srgbClr val="4B5563"/>
-                </a:solidFill>
-                <a:latin typeface="Courier New"/>
-                <a:ea typeface="Courier New"/>
-                <a:cs typeface="Courier New"/>
-              </a:defRPr>
-            </a:lvl1pPr>
-          </a:lstStyle>
-          <a:p>
-            <a:pPr algn="r"/>
-            <a:fld id="{F7021451-1387-4CA6-816F-3879F97B5CBC}" type="slidenum">
-              <a:rPr b="0" lang="en-US"/>
-              <a:t>23</a:t>
             </a:fld>
             <a:endParaRPr lang="en-US"/>
           </a:p>
@@ -10717,7 +10935,7 @@
         <p:spPr>
           <a:xfrm>
             <a:off x="420624" y="1152144"/>
-            <a:ext cx="4050792" cy="3133595"/>
+            <a:ext cx="4050791" cy="3133595"/>
           </a:xfrm>
           <a:prstGeom prst="rect">
             <a:avLst/>
@@ -10749,7 +10967,7 @@
           <p:nvPr/>
         </p:nvPicPr>
         <p:blipFill>
-          <a:blip r:embed="rId1"/>
+          <a:blip r:embed="rId5"/>
           <a:stretch>
             <a:fillRect/>
           </a:stretch>
@@ -10757,7 +10975,7 @@
         <p:spPr>
           <a:xfrm>
             <a:off x="457200" y="1188720"/>
-            <a:ext cx="3977640" cy="3060443"/>
+            <a:ext cx="3977639" cy="3060443"/>
           </a:xfrm>
           <a:prstGeom prst="rect">
             <a:avLst/>
@@ -10772,7 +10990,7 @@
         </p:nvSpPr>
         <p:spPr>
           <a:xfrm>
-            <a:off x="457200" y="4340603"/>
+            <a:off x="457199" y="4340603"/>
             <a:ext cx="3977640" cy="256032"/>
           </a:xfrm>
           <a:prstGeom prst="rect">
@@ -10808,8 +11026,8 @@
         </p:nvSpPr>
         <p:spPr>
           <a:xfrm>
-            <a:off x="4672584" y="1152144"/>
-            <a:ext cx="4050792" cy="1673567"/>
+            <a:off x="4822253" y="1152144"/>
+            <a:ext cx="3751453" cy="1673567"/>
           </a:xfrm>
           <a:prstGeom prst="rect">
             <a:avLst/>
@@ -10841,15 +11059,15 @@
           <p:nvPr/>
         </p:nvPicPr>
         <p:blipFill>
-          <a:blip r:embed="rId2"/>
+          <a:blip r:embed="rId1"/>
           <a:stretch>
             <a:fillRect/>
           </a:stretch>
         </p:blipFill>
         <p:spPr>
           <a:xfrm>
-            <a:off x="4709160" y="1188720"/>
-            <a:ext cx="3977640" cy="1600415"/>
+            <a:off x="4858829" y="1188720"/>
+            <a:ext cx="3678301" cy="1600415"/>
           </a:xfrm>
           <a:prstGeom prst="rect">
             <a:avLst/>
@@ -10864,7 +11082,7 @@
         </p:nvSpPr>
         <p:spPr>
           <a:xfrm>
-            <a:off x="4709160" y="2880575"/>
+            <a:off x="4709159" y="2880575"/>
             <a:ext cx="3977640" cy="256032"/>
           </a:xfrm>
           <a:prstGeom prst="rect">
@@ -11258,6 +11476,10 @@
             <a:prstDash val="solid"/>
           </a:ln>
         </p:spPr>
+        <p:txBody>
+          <a:bodyPr/>
+          <a:p/>
+        </p:txBody>
       </p:sp>
       <p:pic>
         <p:nvPicPr>
@@ -11357,6 +11579,10 @@
             <a:prstDash val="solid"/>
           </a:ln>
         </p:spPr>
+        <p:txBody>
+          <a:bodyPr/>
+          <a:p/>
+        </p:txBody>
       </p:sp>
       <p:pic>
         <p:nvPicPr>
@@ -11456,6 +11682,10 @@
             <a:prstDash val="solid"/>
           </a:ln>
         </p:spPr>
+        <p:txBody>
+          <a:bodyPr/>
+          <a:p/>
+        </p:txBody>
       </p:sp>
       <p:pic>
         <p:nvPicPr>
@@ -11511,7 +11741,7 @@
                   <a:schemeClr val="tx1"/>
                 </a:solidFill>
               </a:rPr>
-              <a:t>Durable storage</a:t>
+              <a:t>Encrypted records</a:t>
             </a:r>
             <a:endParaRPr lang="en-US" sz="1400" dirty="0"/>
           </a:p>
@@ -11525,7 +11755,7 @@
                   <a:schemeClr val="accent6"/>
                 </a:solidFill>
               </a:rPr>
-              <a:t>SQLite locally, DynamoDB on AWS, auto-provisioned</a:t>
+              <a:t>AES-256-GCM personal fields; SQLite or DynamoDB</a:t>
             </a:r>
             <a:endParaRPr lang="en-US" sz="1400" dirty="0"/>
           </a:p>
@@ -11555,6 +11785,10 @@
             <a:prstDash val="solid"/>
           </a:ln>
         </p:spPr>
+        <p:txBody>
+          <a:bodyPr/>
+          <a:p/>
+        </p:txBody>
       </p:sp>
       <p:pic>
         <p:nvPicPr>
@@ -11654,6 +11888,10 @@
             <a:prstDash val="solid"/>
           </a:ln>
         </p:spPr>
+        <p:txBody>
+          <a:bodyPr/>
+          <a:p/>
+        </p:txBody>
       </p:sp>
       <p:pic>
         <p:nvPicPr>
@@ -11753,6 +11991,10 @@
             <a:prstDash val="solid"/>
           </a:ln>
         </p:spPr>
+        <p:txBody>
+          <a:bodyPr/>
+          <a:p/>
+        </p:txBody>
       </p:sp>
       <p:pic>
         <p:nvPicPr>
@@ -11822,7 +12064,7 @@
                   <a:schemeClr val="accent6"/>
                 </a:solidFill>
               </a:rPr>
-              <a:t>31 API tests plus 8 scripted browser scenarios</a:t>
+              <a:t>41 API tests, 57 browser checks, readability audit</a:t>
             </a:r>
             <a:endParaRPr lang="en-US" sz="1400" dirty="0"/>
           </a:p>
@@ -12172,250 +12414,9 @@
                   <a:schemeClr val="tx2"/>
                 </a:solidFill>
               </a:rPr>
-              <a:t>Leaner and safer than the prototype</a:t>
+              <a:t>Leaner, safer and easier to read</a:t>
             </a:r>
             <a:endParaRPr lang="en-US" sz="2800" dirty="0"/>
-          </a:p>
-        </p:txBody>
-      </p:sp>
-      <p:graphicFrame>
-        <p:nvGraphicFramePr>
-          <p:cNvPr id="5" name="Chart 0" descr=""/>
-          <p:cNvGraphicFramePr/>
-          <p:nvPr/>
-        </p:nvGraphicFramePr>
-        <p:xfrm>
-          <a:off x="457200" y="1143000"/>
-          <a:ext cx="4206240" cy="3429000"/>
-        </p:xfrm>
-        <a:graphic xmlns:a="http://schemas.openxmlformats.org/drawingml/2006/main">
-          <a:graphicData uri="http://schemas.openxmlformats.org/drawingml/2006/chart">
-            <c:chart xmlns:c="http://schemas.openxmlformats.org/drawingml/2006/chart" r:id="rId1"/>
-          </a:graphicData>
-        </a:graphic>
-      </p:graphicFrame>
-      <p:sp>
-        <p:nvSpPr>
-          <p:cNvPr id="6" name="stat-lint errors"/>
-          <p:cNvSpPr txBox="1"/>
-          <p:nvPr/>
-        </p:nvSpPr>
-        <p:spPr>
-          <a:xfrm>
-            <a:off x="5120640" y="1188720"/>
-            <a:ext cx="3566160" cy="685800"/>
-          </a:xfrm>
-          <a:prstGeom prst="rect">
-            <a:avLst/>
-          </a:prstGeom>
-          <a:noFill/>
-          <a:ln/>
-        </p:spPr>
-        <p:txBody>
-          <a:bodyPr wrap="square" lIns="0" tIns="0" rIns="0" bIns="0" rtlCol="0" anchor="ctr"/>
-          <a:lstStyle/>
-          <a:p>
-            <a:pPr indent="0" marL="0">
-              <a:buNone/>
-            </a:pPr>
-            <a:r>
-              <a:rPr lang="en-US" sz="4000" b="1" dirty="0">
-                <a:solidFill>
-                  <a:schemeClr val="accent1"/>
-                </a:solidFill>
-                <a:latin typeface="Arial" pitchFamily="34" charset="0"/>
-                <a:ea typeface="Arial" pitchFamily="34" charset="-122"/>
-                <a:cs typeface="Arial" pitchFamily="34" charset="-120"/>
-              </a:rPr>
-              <a:t>65 → 0</a:t>
-            </a:r>
-            <a:endParaRPr lang="en-US" sz="4000" dirty="0"/>
-          </a:p>
-        </p:txBody>
-      </p:sp>
-      <p:sp>
-        <p:nvSpPr>
-          <p:cNvPr id="7" name="Text 3"/>
-          <p:cNvSpPr txBox="1"/>
-          <p:nvPr/>
-        </p:nvSpPr>
-        <p:spPr>
-          <a:xfrm>
-            <a:off x="5120640" y="1901952"/>
-            <a:ext cx="3566160" cy="457200"/>
-          </a:xfrm>
-          <a:prstGeom prst="rect">
-            <a:avLst/>
-          </a:prstGeom>
-          <a:noFill/>
-          <a:ln/>
-        </p:spPr>
-        <p:txBody>
-          <a:bodyPr wrap="square" lIns="0" tIns="0" rIns="0" bIns="0" rtlCol="0" anchor="t"/>
-          <a:lstStyle/>
-          <a:p>
-            <a:pPr indent="0" marL="0">
-              <a:buNone/>
-            </a:pPr>
-            <a:r>
-              <a:rPr lang="en-US" sz="1400" dirty="0">
-                <a:solidFill>
-                  <a:schemeClr val="accent6"/>
-                </a:solidFill>
-              </a:rPr>
-              <a:t>lint errors</a:t>
-            </a:r>
-            <a:endParaRPr lang="en-US" sz="1400" dirty="0"/>
-          </a:p>
-        </p:txBody>
-      </p:sp>
-      <p:sp>
-        <p:nvSpPr>
-          <p:cNvPr id="8" name="stat-high-severity production vulnerabilities"/>
-          <p:cNvSpPr txBox="1"/>
-          <p:nvPr/>
-        </p:nvSpPr>
-        <p:spPr>
-          <a:xfrm>
-            <a:off x="5120640" y="2331720"/>
-            <a:ext cx="3566160" cy="685800"/>
-          </a:xfrm>
-          <a:prstGeom prst="rect">
-            <a:avLst/>
-          </a:prstGeom>
-          <a:noFill/>
-          <a:ln/>
-        </p:spPr>
-        <p:txBody>
-          <a:bodyPr wrap="square" lIns="0" tIns="0" rIns="0" bIns="0" rtlCol="0" anchor="ctr"/>
-          <a:lstStyle/>
-          <a:p>
-            <a:pPr indent="0" marL="0">
-              <a:buNone/>
-            </a:pPr>
-            <a:r>
-              <a:rPr lang="en-US" sz="4000" b="1" dirty="0">
-                <a:solidFill>
-                  <a:schemeClr val="accent1"/>
-                </a:solidFill>
-                <a:latin typeface="Arial" pitchFamily="34" charset="0"/>
-                <a:ea typeface="Arial" pitchFamily="34" charset="-122"/>
-                <a:cs typeface="Arial" pitchFamily="34" charset="-120"/>
-              </a:rPr>
-              <a:t>1 → 0</a:t>
-            </a:r>
-            <a:endParaRPr lang="en-US" sz="4000" dirty="0"/>
-          </a:p>
-        </p:txBody>
-      </p:sp>
-      <p:sp>
-        <p:nvSpPr>
-          <p:cNvPr id="9" name="Text 5"/>
-          <p:cNvSpPr txBox="1"/>
-          <p:nvPr/>
-        </p:nvSpPr>
-        <p:spPr>
-          <a:xfrm>
-            <a:off x="5120640" y="3044952"/>
-            <a:ext cx="3566160" cy="457200"/>
-          </a:xfrm>
-          <a:prstGeom prst="rect">
-            <a:avLst/>
-          </a:prstGeom>
-          <a:noFill/>
-          <a:ln/>
-        </p:spPr>
-        <p:txBody>
-          <a:bodyPr wrap="square" lIns="0" tIns="0" rIns="0" bIns="0" rtlCol="0" anchor="t"/>
-          <a:lstStyle/>
-          <a:p>
-            <a:pPr indent="0" marL="0">
-              <a:buNone/>
-            </a:pPr>
-            <a:r>
-              <a:rPr lang="en-US" sz="1400" dirty="0">
-                <a:solidFill>
-                  <a:schemeClr val="accent6"/>
-                </a:solidFill>
-              </a:rPr>
-              <a:t>high-severity production vulnerabilities</a:t>
-            </a:r>
-            <a:endParaRPr lang="en-US" sz="1400" dirty="0"/>
-          </a:p>
-        </p:txBody>
-      </p:sp>
-      <p:sp>
-        <p:nvSpPr>
-          <p:cNvPr id="10" name="stat-automated backend tests"/>
-          <p:cNvSpPr txBox="1"/>
-          <p:nvPr/>
-        </p:nvSpPr>
-        <p:spPr>
-          <a:xfrm>
-            <a:off x="5120640" y="3474720"/>
-            <a:ext cx="3566160" cy="685800"/>
-          </a:xfrm>
-          <a:prstGeom prst="rect">
-            <a:avLst/>
-          </a:prstGeom>
-          <a:noFill/>
-          <a:ln/>
-        </p:spPr>
-        <p:txBody>
-          <a:bodyPr wrap="square" lIns="0" tIns="0" rIns="0" bIns="0" rtlCol="0" anchor="ctr"/>
-          <a:lstStyle/>
-          <a:p>
-            <a:pPr indent="0" marL="0">
-              <a:buNone/>
-            </a:pPr>
-            <a:r>
-              <a:rPr lang="en-US" sz="4000" b="1" dirty="0">
-                <a:solidFill>
-                  <a:schemeClr val="accent2"/>
-                </a:solidFill>
-                <a:latin typeface="Arial" pitchFamily="34" charset="0"/>
-                <a:ea typeface="Arial" pitchFamily="34" charset="-122"/>
-                <a:cs typeface="Arial" pitchFamily="34" charset="-120"/>
-              </a:rPr>
-              <a:t>0 → 31</a:t>
-            </a:r>
-            <a:endParaRPr lang="en-US" sz="4000" dirty="0"/>
-          </a:p>
-        </p:txBody>
-      </p:sp>
-      <p:sp>
-        <p:nvSpPr>
-          <p:cNvPr id="11" name="Text 7"/>
-          <p:cNvSpPr txBox="1"/>
-          <p:nvPr/>
-        </p:nvSpPr>
-        <p:spPr>
-          <a:xfrm>
-            <a:off x="5120640" y="4187952"/>
-            <a:ext cx="3566160" cy="457200"/>
-          </a:xfrm>
-          <a:prstGeom prst="rect">
-            <a:avLst/>
-          </a:prstGeom>
-          <a:noFill/>
-          <a:ln/>
-        </p:spPr>
-        <p:txBody>
-          <a:bodyPr wrap="square" lIns="0" tIns="0" rIns="0" bIns="0" rtlCol="0" anchor="t"/>
-          <a:lstStyle/>
-          <a:p>
-            <a:pPr indent="0" marL="0">
-              <a:buNone/>
-            </a:pPr>
-            <a:r>
-              <a:rPr lang="en-US" sz="1400" dirty="0">
-                <a:solidFill>
-                  <a:schemeClr val="accent6"/>
-                </a:solidFill>
-              </a:rPr>
-              <a:t>automated backend tests</a:t>
-            </a:r>
-            <a:endParaRPr lang="en-US" sz="1400" dirty="0"/>
           </a:p>
         </p:txBody>
       </p:sp>
@@ -12464,6 +12465,456 @@
               <a:t>27</a:t>
             </a:fld>
             <a:endParaRPr lang="en-US"/>
+          </a:p>
+        </p:txBody>
+      </p:sp>
+      <p:sp>
+        <p:nvSpPr>
+          <p:cNvPr id="5" name="stat-lint errors"/>
+          <p:cNvSpPr txBox="1"/>
+          <p:nvPr/>
+        </p:nvSpPr>
+        <p:spPr>
+          <a:xfrm>
+            <a:off x="457200" y="1325880"/>
+            <a:ext cx="2560320" cy="685800"/>
+          </a:xfrm>
+          <a:prstGeom prst="rect">
+            <a:avLst/>
+          </a:prstGeom>
+          <a:noFill/>
+          <a:ln/>
+        </p:spPr>
+        <p:txBody>
+          <a:bodyPr wrap="square" lIns="0" tIns="0" rIns="0" bIns="0" rtlCol="0" anchor="ctr"/>
+          <a:lstStyle/>
+          <a:p>
+            <a:pPr indent="0" marL="0">
+              <a:buNone/>
+            </a:pPr>
+            <a:r>
+              <a:rPr lang="en-US" sz="4000" b="1" dirty="0">
+                <a:solidFill>
+                  <a:schemeClr val="accent1"/>
+                </a:solidFill>
+                <a:latin typeface="Arial" pitchFamily="34" charset="0"/>
+                <a:ea typeface="Arial" pitchFamily="34" charset="-122"/>
+                <a:cs typeface="Arial" pitchFamily="34" charset="-120"/>
+              </a:rPr>
+              <a:t>65 → 0</a:t>
+            </a:r>
+            <a:endParaRPr lang="en-US" sz="4000" dirty="0"/>
+          </a:p>
+        </p:txBody>
+      </p:sp>
+      <p:sp>
+        <p:nvSpPr>
+          <p:cNvPr id="6" name="Text 3"/>
+          <p:cNvSpPr txBox="1"/>
+          <p:nvPr/>
+        </p:nvSpPr>
+        <p:spPr>
+          <a:xfrm>
+            <a:off x="457200" y="2039112"/>
+            <a:ext cx="2560320" cy="457200"/>
+          </a:xfrm>
+          <a:prstGeom prst="rect">
+            <a:avLst/>
+          </a:prstGeom>
+          <a:noFill/>
+          <a:ln/>
+        </p:spPr>
+        <p:txBody>
+          <a:bodyPr wrap="square" lIns="0" tIns="0" rIns="0" bIns="0" rtlCol="0" anchor="t"/>
+          <a:lstStyle/>
+          <a:p>
+            <a:pPr indent="0" marL="0">
+              <a:buNone/>
+            </a:pPr>
+            <a:r>
+              <a:rPr lang="en-US" sz="1400" dirty="0">
+                <a:solidFill>
+                  <a:schemeClr val="accent6"/>
+                </a:solidFill>
+              </a:rPr>
+              <a:t>lint errors</a:t>
+            </a:r>
+            <a:endParaRPr lang="en-US" sz="1400" dirty="0"/>
+          </a:p>
+        </p:txBody>
+      </p:sp>
+      <p:sp>
+        <p:nvSpPr>
+          <p:cNvPr id="5" name="stat-high-severity production vulnerabilities"/>
+          <p:cNvSpPr txBox="1"/>
+          <p:nvPr/>
+        </p:nvSpPr>
+        <p:spPr>
+          <a:xfrm>
+            <a:off x="3291840" y="1325880"/>
+            <a:ext cx="2560320" cy="685800"/>
+          </a:xfrm>
+          <a:prstGeom prst="rect">
+            <a:avLst/>
+          </a:prstGeom>
+          <a:noFill/>
+          <a:ln/>
+        </p:spPr>
+        <p:txBody>
+          <a:bodyPr wrap="square" lIns="0" tIns="0" rIns="0" bIns="0" rtlCol="0" anchor="ctr"/>
+          <a:lstStyle/>
+          <a:p>
+            <a:pPr indent="0" marL="0">
+              <a:buNone/>
+            </a:pPr>
+            <a:r>
+              <a:rPr lang="en-US" sz="4000" b="1" dirty="0">
+                <a:solidFill>
+                  <a:schemeClr val="accent1"/>
+                </a:solidFill>
+                <a:latin typeface="Arial" pitchFamily="34" charset="0"/>
+                <a:ea typeface="Arial" pitchFamily="34" charset="-122"/>
+                <a:cs typeface="Arial" pitchFamily="34" charset="-120"/>
+              </a:rPr>
+              <a:t>1 → 0</a:t>
+            </a:r>
+            <a:endParaRPr lang="en-US" sz="4000" dirty="0"/>
+          </a:p>
+        </p:txBody>
+      </p:sp>
+      <p:sp>
+        <p:nvSpPr>
+          <p:cNvPr id="6" name="Text 3"/>
+          <p:cNvSpPr txBox="1"/>
+          <p:nvPr/>
+        </p:nvSpPr>
+        <p:spPr>
+          <a:xfrm>
+            <a:off x="3291840" y="2039112"/>
+            <a:ext cx="2560320" cy="457200"/>
+          </a:xfrm>
+          <a:prstGeom prst="rect">
+            <a:avLst/>
+          </a:prstGeom>
+          <a:noFill/>
+          <a:ln/>
+        </p:spPr>
+        <p:txBody>
+          <a:bodyPr wrap="square" lIns="0" tIns="0" rIns="0" bIns="0" rtlCol="0" anchor="t"/>
+          <a:lstStyle/>
+          <a:p>
+            <a:pPr indent="0" marL="0">
+              <a:buNone/>
+            </a:pPr>
+            <a:r>
+              <a:rPr lang="en-US" sz="1400" dirty="0">
+                <a:solidFill>
+                  <a:schemeClr val="accent6"/>
+                </a:solidFill>
+              </a:rPr>
+              <a:t>high-severity production vulnerabilities</a:t>
+            </a:r>
+            <a:endParaRPr lang="en-US" sz="1400" dirty="0"/>
+          </a:p>
+        </p:txBody>
+      </p:sp>
+      <p:sp>
+        <p:nvSpPr>
+          <p:cNvPr id="5" name="stat-automated backend tests"/>
+          <p:cNvSpPr txBox="1"/>
+          <p:nvPr/>
+        </p:nvSpPr>
+        <p:spPr>
+          <a:xfrm>
+            <a:off x="6126480" y="1325880"/>
+            <a:ext cx="2560320" cy="685800"/>
+          </a:xfrm>
+          <a:prstGeom prst="rect">
+            <a:avLst/>
+          </a:prstGeom>
+          <a:noFill/>
+          <a:ln/>
+        </p:spPr>
+        <p:txBody>
+          <a:bodyPr wrap="square" lIns="0" tIns="0" rIns="0" bIns="0" rtlCol="0" anchor="ctr"/>
+          <a:lstStyle/>
+          <a:p>
+            <a:pPr indent="0" marL="0">
+              <a:buNone/>
+            </a:pPr>
+            <a:r>
+              <a:rPr lang="en-US" sz="4000" b="1" dirty="0">
+                <a:solidFill>
+                  <a:schemeClr val="accent1"/>
+                </a:solidFill>
+                <a:latin typeface="Arial" pitchFamily="34" charset="0"/>
+                <a:ea typeface="Arial" pitchFamily="34" charset="-122"/>
+                <a:cs typeface="Arial" pitchFamily="34" charset="-120"/>
+              </a:rPr>
+              <a:t>0 → 41</a:t>
+            </a:r>
+            <a:endParaRPr lang="en-US" sz="4000" dirty="0"/>
+          </a:p>
+        </p:txBody>
+      </p:sp>
+      <p:sp>
+        <p:nvSpPr>
+          <p:cNvPr id="6" name="Text 3"/>
+          <p:cNvSpPr txBox="1"/>
+          <p:nvPr/>
+        </p:nvSpPr>
+        <p:spPr>
+          <a:xfrm>
+            <a:off x="6126480" y="2039112"/>
+            <a:ext cx="2560320" cy="457200"/>
+          </a:xfrm>
+          <a:prstGeom prst="rect">
+            <a:avLst/>
+          </a:prstGeom>
+          <a:noFill/>
+          <a:ln/>
+        </p:spPr>
+        <p:txBody>
+          <a:bodyPr wrap="square" lIns="0" tIns="0" rIns="0" bIns="0" rtlCol="0" anchor="t"/>
+          <a:lstStyle/>
+          <a:p>
+            <a:pPr indent="0" marL="0">
+              <a:buNone/>
+            </a:pPr>
+            <a:r>
+              <a:rPr lang="en-US" sz="1400" dirty="0">
+                <a:solidFill>
+                  <a:schemeClr val="accent6"/>
+                </a:solidFill>
+              </a:rPr>
+              <a:t>automated backend tests</a:t>
+            </a:r>
+            <a:endParaRPr lang="en-US" sz="1400" dirty="0"/>
+          </a:p>
+        </p:txBody>
+      </p:sp>
+      <p:sp>
+        <p:nvSpPr>
+          <p:cNvPr id="15" name="stat-first-load JavaScript (1,316 → 254 kB; 76 kB gzip)"/>
+          <p:cNvSpPr txBox="1"/>
+          <p:nvPr/>
+        </p:nvSpPr>
+        <p:spPr>
+          <a:xfrm>
+            <a:off x="457200" y="3017520"/>
+            <a:ext cx="2560320" cy="685800"/>
+          </a:xfrm>
+          <a:prstGeom prst="rect">
+            <a:avLst/>
+          </a:prstGeom>
+          <a:noFill/>
+          <a:ln/>
+        </p:spPr>
+        <p:txBody>
+          <a:bodyPr wrap="square" lIns="0" tIns="0" rIns="0" bIns="0" rtlCol="0" anchor="ctr"/>
+          <a:lstStyle/>
+          <a:p>
+            <a:pPr indent="0" marL="0">
+              <a:buNone/>
+            </a:pPr>
+            <a:r>
+              <a:rPr lang="en-US" sz="4000" b="1" dirty="0">
+                <a:solidFill>
+                  <a:schemeClr val="accent2"/>
+                </a:solidFill>
+                <a:latin typeface="Arial" pitchFamily="34" charset="0"/>
+                <a:ea typeface="Arial" pitchFamily="34" charset="-122"/>
+                <a:cs typeface="Arial" pitchFamily="34" charset="-120"/>
+              </a:rPr>
+              <a:t>−81%</a:t>
+            </a:r>
+            <a:endParaRPr lang="en-US" sz="4000" dirty="0"/>
+          </a:p>
+        </p:txBody>
+      </p:sp>
+      <p:sp>
+        <p:nvSpPr>
+          <p:cNvPr id="6" name="Text 3"/>
+          <p:cNvSpPr txBox="1"/>
+          <p:nvPr/>
+        </p:nvSpPr>
+        <p:spPr>
+          <a:xfrm>
+            <a:off x="457200" y="3730752"/>
+            <a:ext cx="2560320" cy="457200"/>
+          </a:xfrm>
+          <a:prstGeom prst="rect">
+            <a:avLst/>
+          </a:prstGeom>
+          <a:noFill/>
+          <a:ln/>
+        </p:spPr>
+        <p:txBody>
+          <a:bodyPr wrap="square" lIns="0" tIns="0" rIns="0" bIns="0" rtlCol="0" anchor="t"/>
+          <a:lstStyle/>
+          <a:p>
+            <a:pPr indent="0" marL="0">
+              <a:buNone/>
+            </a:pPr>
+            <a:r>
+              <a:rPr lang="en-US" sz="1400" dirty="0">
+                <a:solidFill>
+                  <a:schemeClr val="accent6"/>
+                </a:solidFill>
+              </a:rPr>
+              <a:t>first-load JavaScript (1,316 → 254 kB; 76 kB gzip)</a:t>
+            </a:r>
+            <a:endParaRPr lang="en-US" sz="1400" dirty="0"/>
+          </a:p>
+        </p:txBody>
+      </p:sp>
+      <p:sp>
+        <p:nvSpPr>
+          <p:cNvPr id="15" name="stat-on-screen text smaller than 12 px"/>
+          <p:cNvSpPr txBox="1"/>
+          <p:nvPr/>
+        </p:nvSpPr>
+        <p:spPr>
+          <a:xfrm>
+            <a:off x="3291840" y="3017520"/>
+            <a:ext cx="2560320" cy="685800"/>
+          </a:xfrm>
+          <a:prstGeom prst="rect">
+            <a:avLst/>
+          </a:prstGeom>
+          <a:noFill/>
+          <a:ln/>
+        </p:spPr>
+        <p:txBody>
+          <a:bodyPr wrap="square" lIns="0" tIns="0" rIns="0" bIns="0" rtlCol="0" anchor="ctr"/>
+          <a:lstStyle/>
+          <a:p>
+            <a:pPr indent="0" marL="0">
+              <a:buNone/>
+            </a:pPr>
+            <a:r>
+              <a:rPr lang="en-US" sz="4000" b="1" dirty="0">
+                <a:solidFill>
+                  <a:schemeClr val="accent2"/>
+                </a:solidFill>
+                <a:latin typeface="Arial" pitchFamily="34" charset="0"/>
+                <a:ea typeface="Arial" pitchFamily="34" charset="-122"/>
+                <a:cs typeface="Arial" pitchFamily="34" charset="-120"/>
+              </a:rPr>
+              <a:t>70% → 0%</a:t>
+            </a:r>
+            <a:endParaRPr lang="en-US" sz="4000" dirty="0"/>
+          </a:p>
+        </p:txBody>
+      </p:sp>
+      <p:sp>
+        <p:nvSpPr>
+          <p:cNvPr id="6" name="Text 3"/>
+          <p:cNvSpPr txBox="1"/>
+          <p:nvPr/>
+        </p:nvSpPr>
+        <p:spPr>
+          <a:xfrm>
+            <a:off x="3291840" y="3730752"/>
+            <a:ext cx="2560320" cy="457200"/>
+          </a:xfrm>
+          <a:prstGeom prst="rect">
+            <a:avLst/>
+          </a:prstGeom>
+          <a:noFill/>
+          <a:ln/>
+        </p:spPr>
+        <p:txBody>
+          <a:bodyPr wrap="square" lIns="0" tIns="0" rIns="0" bIns="0" rtlCol="0" anchor="t"/>
+          <a:lstStyle/>
+          <a:p>
+            <a:pPr indent="0" marL="0">
+              <a:buNone/>
+            </a:pPr>
+            <a:r>
+              <a:rPr lang="en-US" sz="1400" dirty="0">
+                <a:solidFill>
+                  <a:schemeClr val="accent6"/>
+                </a:solidFill>
+              </a:rPr>
+              <a:t>on-screen text smaller than 12 px</a:t>
+            </a:r>
+            <a:endParaRPr lang="en-US" sz="1400" dirty="0"/>
+          </a:p>
+        </p:txBody>
+      </p:sp>
+      <p:sp>
+        <p:nvSpPr>
+          <p:cNvPr id="15" name="stat-elements below WCAG contrast"/>
+          <p:cNvSpPr txBox="1"/>
+          <p:nvPr/>
+        </p:nvSpPr>
+        <p:spPr>
+          <a:xfrm>
+            <a:off x="6126480" y="3017520"/>
+            <a:ext cx="2560320" cy="685800"/>
+          </a:xfrm>
+          <a:prstGeom prst="rect">
+            <a:avLst/>
+          </a:prstGeom>
+          <a:noFill/>
+          <a:ln/>
+        </p:spPr>
+        <p:txBody>
+          <a:bodyPr wrap="square" lIns="0" tIns="0" rIns="0" bIns="0" rtlCol="0" anchor="ctr"/>
+          <a:lstStyle/>
+          <a:p>
+            <a:pPr indent="0" marL="0">
+              <a:buNone/>
+            </a:pPr>
+            <a:r>
+              <a:rPr lang="en-US" sz="4000" b="1" dirty="0">
+                <a:solidFill>
+                  <a:schemeClr val="accent2"/>
+                </a:solidFill>
+                <a:latin typeface="Arial" pitchFamily="34" charset="0"/>
+                <a:ea typeface="Arial" pitchFamily="34" charset="-122"/>
+                <a:cs typeface="Arial" pitchFamily="34" charset="-120"/>
+              </a:rPr>
+              <a:t>133 → 2</a:t>
+            </a:r>
+            <a:endParaRPr lang="en-US" sz="4000" dirty="0"/>
+          </a:p>
+        </p:txBody>
+      </p:sp>
+      <p:sp>
+        <p:nvSpPr>
+          <p:cNvPr id="6" name="Text 3"/>
+          <p:cNvSpPr txBox="1"/>
+          <p:nvPr/>
+        </p:nvSpPr>
+        <p:spPr>
+          <a:xfrm>
+            <a:off x="6126480" y="3730752"/>
+            <a:ext cx="2560320" cy="457200"/>
+          </a:xfrm>
+          <a:prstGeom prst="rect">
+            <a:avLst/>
+          </a:prstGeom>
+          <a:noFill/>
+          <a:ln/>
+        </p:spPr>
+        <p:txBody>
+          <a:bodyPr wrap="square" lIns="0" tIns="0" rIns="0" bIns="0" rtlCol="0" anchor="t"/>
+          <a:lstStyle/>
+          <a:p>
+            <a:pPr indent="0" marL="0">
+              <a:buNone/>
+            </a:pPr>
+            <a:r>
+              <a:rPr lang="en-US" sz="1400" dirty="0">
+                <a:solidFill>
+                  <a:schemeClr val="accent6"/>
+                </a:solidFill>
+              </a:rPr>
+              <a:t>elements below WCAG contrast</a:t>
+            </a:r>
+            <a:endParaRPr lang="en-US" sz="1400" dirty="0"/>
           </a:p>
         </p:txBody>
       </p:sp>
@@ -13322,7 +13773,7 @@
           <p:nvPr/>
         </p:nvPicPr>
         <p:blipFill>
-          <a:blip r:embed="rId1"/>
+          <a:blip r:embed="rId4"/>
           <a:stretch>
             <a:fillRect/>
           </a:stretch>
@@ -13449,8 +13900,8 @@
         </p:nvSpPr>
         <p:spPr>
           <a:xfrm>
-            <a:off x="420624" y="1152144"/>
-            <a:ext cx="4828032" cy="2769449"/>
+            <a:off x="1045883" y="1152144"/>
+            <a:ext cx="3577513" cy="2769449"/>
           </a:xfrm>
           <a:prstGeom prst="rect">
             <a:avLst/>
@@ -13472,6 +13923,10 @@
             </a:outerShdw>
           </a:effectLst>
         </p:spPr>
+        <p:txBody>
+          <a:bodyPr/>
+          <a:p/>
+        </p:txBody>
       </p:sp>
       <p:pic>
         <p:nvPicPr>
@@ -13482,15 +13937,15 @@
           <p:nvPr/>
         </p:nvPicPr>
         <p:blipFill>
-          <a:blip r:embed="rId1"/>
+          <a:blip r:embed="rId4"/>
           <a:stretch>
             <a:fillRect/>
           </a:stretch>
         </p:blipFill>
         <p:spPr>
           <a:xfrm>
-            <a:off x="457200" y="1188720"/>
-            <a:ext cx="4754880" cy="2696297"/>
+            <a:off x="1082459" y="1188720"/>
+            <a:ext cx="3504361" cy="2696297"/>
           </a:xfrm>
           <a:prstGeom prst="rect">
             <a:avLst/>
@@ -13505,7 +13960,7 @@
         </p:nvSpPr>
         <p:spPr>
           <a:xfrm>
-            <a:off x="457200" y="3976457"/>
+            <a:off x="457199" y="3976457"/>
             <a:ext cx="4754880" cy="256032"/>
           </a:xfrm>
           <a:prstGeom prst="rect">
@@ -13627,7 +14082,7 @@
                   <a:schemeClr val="accent6"/>
                 </a:solidFill>
               </a:rPr>
-              <a:t>Rooms, surveys, gate security, welfare</a:t>
+              <a:t>Residents, rooms, surveys, gate, welfare</a:t>
             </a:r>
             <a:endParaRPr lang="en-US" sz="1500" dirty="0"/>
           </a:p>
@@ -13778,6 +14233,1065 @@
               <a:t>3</a:t>
             </a:fld>
             <a:endParaRPr lang="en-US"/>
+          </a:p>
+        </p:txBody>
+      </p:sp>
+    </p:spTree>
+  </p:cSld>
+  <p:clrMapOvr>
+    <a:masterClrMapping/>
+  </p:clrMapOvr>
+</p:sld>
+</file>
+
+<file path=ppt/slides/slide30.xml><?xml version="1.0" encoding="utf-8"?>
+<p:sld xmlns:a="http://schemas.openxmlformats.org/drawingml/2006/main" xmlns:p="http://schemas.openxmlformats.org/presentationml/2006/main" xmlns:r="http://schemas.openxmlformats.org/officeDocument/2006/relationships">
+  <p:cSld>
+    <p:spTree>
+      <p:nvGrpSpPr>
+        <p:cNvPr id="1" name=""/>
+        <p:cNvGrpSpPr/>
+        <p:nvPr/>
+      </p:nvGrpSpPr>
+      <p:grpSpPr/>
+      <p:sp>
+        <p:nvSpPr>
+          <p:cNvPr id="2" name="Text Placeholder 1"/>
+          <p:cNvSpPr>
+            <a:spLocks noGrp="1"/>
+          </p:cNvSpPr>
+          <p:nvPr>
+            <p:ph type="body" idx="100"/>
+          </p:nvPr>
+        </p:nvSpPr>
+        <p:spPr/>
+        <p:txBody>
+          <a:bodyPr/>
+          <a:lstStyle/>
+          <a:p>
+            <a:r>
+              <a:t>SCENARIO 11  ·  RESIDENT RECORDS</a:t>
+            </a:r>
+          </a:p>
+        </p:txBody>
+      </p:sp>
+      <p:sp>
+        <p:nvSpPr>
+          <p:cNvPr id="3" name="Title 2"/>
+          <p:cNvSpPr>
+            <a:spLocks noGrp="1"/>
+          </p:cNvSpPr>
+          <p:nvPr>
+            <p:ph type="title" idx="101"/>
+          </p:nvPr>
+        </p:nvSpPr>
+        <p:spPr/>
+        <p:txBody>
+          <a:bodyPr/>
+          <a:lstStyle/>
+          <a:p>
+            <a:r>
+              <a:t>100 residents, personal data encrypted</a:t>
+            </a:r>
+          </a:p>
+        </p:txBody>
+      </p:sp>
+      <p:sp>
+        <p:nvSpPr>
+          <p:cNvPr id="25" name="Slide Number Placeholder 0"/>
+          <p:cNvSpPr>
+            <a:spLocks noGrp="1"/>
+          </p:cNvSpPr>
+          <p:nvPr>
+            <p:ph type="sldNum" sz="quarter" idx="4294967295"/>
+          </p:nvPr>
+        </p:nvSpPr>
+        <p:spPr>
+          <a:xfrm>
+            <a:off x="8229600" y="4800600"/>
+            <a:ext cx="457200" cy="228600"/>
+          </a:xfrm>
+          <a:prstGeom prst="rect">
+            <a:avLst/>
+          </a:prstGeom>
+          <a:extLst>
+            <a:ext uri="{C572A759-6A51-4108-AA02-DFA0A04FC94B}">
+              <ma14:wrappingTextBoxFlag xmlns:ma14="http://schemas.microsoft.com/office/mac/drawingml/2011/main" val="0"/>
+            </a:ext>
+          </a:extLst>
+        </p:spPr>
+        <p:txBody>
+          <a:bodyPr/>
+          <a:lstStyle>
+            <a:lvl1pPr>
+              <a:defRPr sz="800">
+                <a:solidFill>
+                  <a:srgbClr val="4B5563"/>
+                </a:solidFill>
+                <a:latin typeface="Courier New"/>
+                <a:ea typeface="Courier New"/>
+                <a:cs typeface="Courier New"/>
+              </a:defRPr>
+            </a:lvl1pPr>
+          </a:lstStyle>
+          <a:p>
+            <a:pPr algn="r"/>
+            <a:fld id="{F7021451-1387-4CA6-816F-3879F97B5CBC}" type="slidenum">
+              <a:rPr b="0" lang="en-US"/>
+              <a:t>22</a:t>
+            </a:fld>
+            <a:endParaRPr lang="en-US"/>
+          </a:p>
+        </p:txBody>
+      </p:sp>
+      <p:sp>
+        <p:nvSpPr>
+          <p:cNvPr id="5" name="frame-n-directory"/>
+          <p:cNvSpPr/>
+          <p:nvPr/>
+        </p:nvSpPr>
+        <p:spPr>
+          <a:xfrm>
+            <a:off x="420624" y="1152144"/>
+            <a:ext cx="4279392" cy="3309482"/>
+          </a:xfrm>
+          <a:prstGeom prst="rect">
+            <a:avLst/>
+          </a:prstGeom>
+          <a:solidFill>
+            <a:schemeClr val="bg1"/>
+          </a:solidFill>
+          <a:ln w="9525">
+            <a:solidFill>
+              <a:schemeClr val="accent1"/>
+            </a:solidFill>
+            <a:prstDash val="solid"/>
+          </a:ln>
+          <a:effectLst>
+            <a:outerShdw sx="100000" sy="100000" kx="0" ky="0" algn="bl" rotWithShape="0" blurRad="76200" dist="25400" dir="5400000">
+              <a:srgbClr val="000000">
+                <a:alpha val="18000"/>
+              </a:srgbClr>
+            </a:outerShdw>
+          </a:effectLst>
+        </p:spPr>
+      </p:sp>
+      <p:pic>
+        <p:nvPicPr>
+          <p:cNvPr id="26" name="shot-n-directory" descr="Directory with a decrypted profile (audited)"/>
+          <p:cNvPicPr>
+            <a:picLocks noChangeAspect="1"/>
+          </p:cNvPicPr>
+          <p:nvPr/>
+        </p:nvPicPr>
+        <p:blipFill>
+          <a:blip r:embed="rId3"/>
+          <a:stretch>
+            <a:fillRect/>
+          </a:stretch>
+        </p:blipFill>
+        <p:spPr>
+          <a:xfrm>
+            <a:off x="457200" y="1188720"/>
+            <a:ext cx="4206240" cy="3236330"/>
+          </a:xfrm>
+          <a:prstGeom prst="rect">
+            <a:avLst/>
+          </a:prstGeom>
+        </p:spPr>
+      </p:pic>
+      <p:sp>
+        <p:nvSpPr>
+          <p:cNvPr id="7" name="cap-n-directory"/>
+          <p:cNvSpPr txBox="1"/>
+          <p:nvPr/>
+        </p:nvSpPr>
+        <p:spPr>
+          <a:xfrm>
+            <a:off x="457200" y="4498202"/>
+            <a:ext cx="4206240" cy="256032"/>
+          </a:xfrm>
+          <a:prstGeom prst="rect">
+            <a:avLst/>
+          </a:prstGeom>
+          <a:noFill/>
+          <a:ln/>
+        </p:spPr>
+        <p:txBody>
+          <a:bodyPr wrap="square" lIns="0" tIns="0" rIns="0" bIns="0" rtlCol="0" anchor="ctr"/>
+          <a:lstStyle/>
+          <a:p>
+            <a:pPr algn="ctr" indent="0" marL="0">
+              <a:buNone/>
+            </a:pPr>
+            <a:r>
+              <a:rPr lang="en-US" sz="1100" i="1" dirty="0">
+                <a:solidFill>
+                  <a:schemeClr val="accent6"/>
+                </a:solidFill>
+              </a:rPr>
+              <a:t>Directory with a decrypted profile (audited)</a:t>
+            </a:r>
+            <a:endParaRPr lang="en-US" sz="1100" dirty="0"/>
+          </a:p>
+        </p:txBody>
+      </p:sp>
+      <p:sp>
+        <p:nvSpPr>
+          <p:cNvPr id="5" name="frame-n-stored-record"/>
+          <p:cNvSpPr/>
+          <p:nvPr/>
+        </p:nvSpPr>
+        <p:spPr>
+          <a:xfrm>
+            <a:off x="4854213" y="1152144"/>
+            <a:ext cx="1355813" cy="3319272"/>
+          </a:xfrm>
+          <a:prstGeom prst="rect">
+            <a:avLst/>
+          </a:prstGeom>
+          <a:solidFill>
+            <a:schemeClr val="bg1"/>
+          </a:solidFill>
+          <a:ln w="9525">
+            <a:solidFill>
+              <a:schemeClr val="accent1"/>
+            </a:solidFill>
+            <a:prstDash val="solid"/>
+          </a:ln>
+          <a:effectLst>
+            <a:outerShdw sx="100000" sy="100000" kx="0" ky="0" algn="bl" rotWithShape="0" blurRad="76200" dist="25400" dir="5400000">
+              <a:srgbClr val="000000">
+                <a:alpha val="18000"/>
+              </a:srgbClr>
+            </a:outerShdw>
+          </a:effectLst>
+        </p:spPr>
+      </p:sp>
+      <p:pic>
+        <p:nvPicPr>
+          <p:cNvPr id="27" name="shot-n-stored-record" descr="As stored"/>
+          <p:cNvPicPr>
+            <a:picLocks noChangeAspect="1"/>
+          </p:cNvPicPr>
+          <p:nvPr/>
+        </p:nvPicPr>
+        <p:blipFill>
+          <a:blip r:embed="rId4"/>
+          <a:stretch>
+            <a:fillRect/>
+          </a:stretch>
+        </p:blipFill>
+        <p:spPr>
+          <a:xfrm>
+            <a:off x="4890789" y="1188720"/>
+            <a:ext cx="1282661" cy="3246120"/>
+          </a:xfrm>
+          <a:prstGeom prst="rect">
+            <a:avLst/>
+          </a:prstGeom>
+        </p:spPr>
+      </p:pic>
+      <p:sp>
+        <p:nvSpPr>
+          <p:cNvPr id="7" name="cap-n-stored-record"/>
+          <p:cNvSpPr txBox="1"/>
+          <p:nvPr/>
+        </p:nvSpPr>
+        <p:spPr>
+          <a:xfrm>
+            <a:off x="4434839" y="4507992"/>
+            <a:ext cx="2194560" cy="256032"/>
+          </a:xfrm>
+          <a:prstGeom prst="rect">
+            <a:avLst/>
+          </a:prstGeom>
+          <a:noFill/>
+          <a:ln/>
+        </p:spPr>
+        <p:txBody>
+          <a:bodyPr wrap="square" lIns="0" tIns="0" rIns="0" bIns="0" rtlCol="0" anchor="ctr"/>
+          <a:lstStyle/>
+          <a:p>
+            <a:pPr algn="ctr" indent="0" marL="0">
+              <a:buNone/>
+            </a:pPr>
+            <a:r>
+              <a:rPr lang="en-US" sz="1100" i="1" dirty="0">
+                <a:solidFill>
+                  <a:schemeClr val="accent6"/>
+                </a:solidFill>
+              </a:rPr>
+              <a:t>As stored</a:t>
+            </a:r>
+            <a:endParaRPr lang="en-US" sz="1100" dirty="0"/>
+          </a:p>
+        </p:txBody>
+      </p:sp>
+      <p:sp>
+        <p:nvSpPr>
+          <p:cNvPr id="6" name="Text 3"/>
+          <p:cNvSpPr txBox="1"/>
+          <p:nvPr/>
+        </p:nvSpPr>
+        <p:spPr>
+          <a:xfrm>
+            <a:off x="6446520" y="1234440"/>
+            <a:ext cx="411480" cy="411480"/>
+          </a:xfrm>
+          <a:prstGeom prst="rect">
+            <a:avLst/>
+          </a:prstGeom>
+          <a:noFill/>
+          <a:ln/>
+        </p:spPr>
+        <p:txBody>
+          <a:bodyPr wrap="square" lIns="0" tIns="0" rIns="0" bIns="0" rtlCol="0" anchor="ctr"/>
+          <a:lstStyle/>
+          <a:p>
+            <a:pPr algn="ctr" indent="0" marL="0">
+              <a:buNone/>
+            </a:pPr>
+            <a:r>
+              <a:rPr lang="en-US" sz="1400" b="1" dirty="0">
+                <a:solidFill>
+                  <a:schemeClr val="bg1"/>
+                </a:solidFill>
+                <a:latin typeface="Courier New" pitchFamily="34" charset="0"/>
+                <a:ea typeface="Courier New" pitchFamily="34" charset="-122"/>
+                <a:cs typeface="Courier New" pitchFamily="34" charset="-120"/>
+              </a:rPr>
+              <a:t>1</a:t>
+            </a:r>
+            <a:endParaRPr lang="en-US" sz="1400" dirty="0"/>
+          </a:p>
+        </p:txBody>
+      </p:sp>
+      <p:sp>
+        <p:nvSpPr>
+          <p:cNvPr id="7" name="step-0"/>
+          <p:cNvSpPr txBox="1"/>
+          <p:nvPr/>
+        </p:nvSpPr>
+        <p:spPr>
+          <a:xfrm>
+            <a:off x="6949440" y="1234440"/>
+            <a:ext cx="1783080" cy="640080"/>
+          </a:xfrm>
+          <a:prstGeom prst="rect">
+            <a:avLst/>
+          </a:prstGeom>
+          <a:noFill/>
+          <a:ln/>
+        </p:spPr>
+        <p:txBody>
+          <a:bodyPr wrap="square" lIns="0" tIns="0" rIns="0" bIns="0" rtlCol="0" anchor="t"/>
+          <a:lstStyle/>
+          <a:p>
+            <a:pPr indent="0" marL="0">
+              <a:spcAft>
+                <a:spcPts val="200"/>
+              </a:spcAft>
+              <a:buNone/>
+            </a:pPr>
+            <a:r>
+              <a:rPr lang="en-US" sz="1500" b="1" dirty="0">
+                <a:solidFill>
+                  <a:schemeClr val="tx1"/>
+                </a:solidFill>
+              </a:rPr>
+              <a:t>Encrypted at rest</a:t>
+            </a:r>
+            <a:endParaRPr lang="en-US" sz="1500" dirty="0"/>
+          </a:p>
+          <a:p>
+            <a:pPr indent="0" marL="0">
+              <a:spcAft>
+                <a:spcPts val="200"/>
+              </a:spcAft>
+              <a:buNone/>
+            </a:pPr>
+            <a:r>
+              <a:rPr lang="en-US" sz="1400" dirty="0">
+                <a:solidFill>
+                  <a:schemeClr val="accent6"/>
+                </a:solidFill>
+              </a:rPr>
+              <a:t>9 personal fields per record, AES-256-GCM</a:t>
+            </a:r>
+            <a:endParaRPr lang="en-US" sz="1500" dirty="0"/>
+          </a:p>
+        </p:txBody>
+      </p:sp>
+      <p:sp>
+        <p:nvSpPr>
+          <p:cNvPr id="6" name="Text 3"/>
+          <p:cNvSpPr txBox="1"/>
+          <p:nvPr/>
+        </p:nvSpPr>
+        <p:spPr>
+          <a:xfrm>
+            <a:off x="6446520" y="2286000"/>
+            <a:ext cx="411480" cy="411480"/>
+          </a:xfrm>
+          <a:prstGeom prst="rect">
+            <a:avLst/>
+          </a:prstGeom>
+          <a:noFill/>
+          <a:ln/>
+        </p:spPr>
+        <p:txBody>
+          <a:bodyPr wrap="square" lIns="0" tIns="0" rIns="0" bIns="0" rtlCol="0" anchor="ctr"/>
+          <a:lstStyle/>
+          <a:p>
+            <a:pPr algn="ctr" indent="0" marL="0">
+              <a:buNone/>
+            </a:pPr>
+            <a:r>
+              <a:rPr lang="en-US" sz="1400" b="1" dirty="0">
+                <a:solidFill>
+                  <a:schemeClr val="bg1"/>
+                </a:solidFill>
+                <a:latin typeface="Courier New" pitchFamily="34" charset="0"/>
+                <a:ea typeface="Courier New" pitchFamily="34" charset="-122"/>
+                <a:cs typeface="Courier New" pitchFamily="34" charset="-120"/>
+              </a:rPr>
+              <a:t>2</a:t>
+            </a:r>
+            <a:endParaRPr lang="en-US" sz="1400" dirty="0"/>
+          </a:p>
+        </p:txBody>
+      </p:sp>
+      <p:sp>
+        <p:nvSpPr>
+          <p:cNvPr id="7" name="step-0"/>
+          <p:cNvSpPr txBox="1"/>
+          <p:nvPr/>
+        </p:nvSpPr>
+        <p:spPr>
+          <a:xfrm>
+            <a:off x="6949440" y="2286000"/>
+            <a:ext cx="1783080" cy="640080"/>
+          </a:xfrm>
+          <a:prstGeom prst="rect">
+            <a:avLst/>
+          </a:prstGeom>
+          <a:noFill/>
+          <a:ln/>
+        </p:spPr>
+        <p:txBody>
+          <a:bodyPr wrap="square" lIns="0" tIns="0" rIns="0" bIns="0" rtlCol="0" anchor="t"/>
+          <a:lstStyle/>
+          <a:p>
+            <a:pPr indent="0" marL="0">
+              <a:spcAft>
+                <a:spcPts val="200"/>
+              </a:spcAft>
+              <a:buNone/>
+            </a:pPr>
+            <a:r>
+              <a:rPr lang="en-US" sz="1500" b="1" dirty="0">
+                <a:solidFill>
+                  <a:schemeClr val="tx1"/>
+                </a:solidFill>
+              </a:rPr>
+              <a:t>Bound to the record</a:t>
+            </a:r>
+            <a:endParaRPr lang="en-US" sz="1500" dirty="0"/>
+          </a:p>
+          <a:p>
+            <a:pPr indent="0" marL="0">
+              <a:spcAft>
+                <a:spcPts val="200"/>
+              </a:spcAft>
+              <a:buNone/>
+            </a:pPr>
+            <a:r>
+              <a:rPr lang="en-US" sz="1400" dirty="0">
+                <a:solidFill>
+                  <a:schemeClr val="accent6"/>
+                </a:solidFill>
+              </a:rPr>
+              <a:t>Ciphertext moved to another record fails</a:t>
+            </a:r>
+            <a:endParaRPr lang="en-US" sz="1500" dirty="0"/>
+          </a:p>
+        </p:txBody>
+      </p:sp>
+      <p:sp>
+        <p:nvSpPr>
+          <p:cNvPr id="6" name="Text 3"/>
+          <p:cNvSpPr txBox="1"/>
+          <p:nvPr/>
+        </p:nvSpPr>
+        <p:spPr>
+          <a:xfrm>
+            <a:off x="6446520" y="3337560"/>
+            <a:ext cx="411480" cy="411480"/>
+          </a:xfrm>
+          <a:prstGeom prst="rect">
+            <a:avLst/>
+          </a:prstGeom>
+          <a:noFill/>
+          <a:ln/>
+        </p:spPr>
+        <p:txBody>
+          <a:bodyPr wrap="square" lIns="0" tIns="0" rIns="0" bIns="0" rtlCol="0" anchor="ctr"/>
+          <a:lstStyle/>
+          <a:p>
+            <a:pPr algn="ctr" indent="0" marL="0">
+              <a:buNone/>
+            </a:pPr>
+            <a:r>
+              <a:rPr lang="en-US" sz="1400" b="1" dirty="0">
+                <a:solidFill>
+                  <a:schemeClr val="bg1"/>
+                </a:solidFill>
+                <a:latin typeface="Courier New" pitchFamily="34" charset="0"/>
+                <a:ea typeface="Courier New" pitchFamily="34" charset="-122"/>
+                <a:cs typeface="Courier New" pitchFamily="34" charset="-120"/>
+              </a:rPr>
+              <a:t>3</a:t>
+            </a:r>
+            <a:endParaRPr lang="en-US" sz="1400" dirty="0"/>
+          </a:p>
+        </p:txBody>
+      </p:sp>
+      <p:sp>
+        <p:nvSpPr>
+          <p:cNvPr id="7" name="step-0"/>
+          <p:cNvSpPr txBox="1"/>
+          <p:nvPr/>
+        </p:nvSpPr>
+        <p:spPr>
+          <a:xfrm>
+            <a:off x="6949440" y="3337560"/>
+            <a:ext cx="1783080" cy="640080"/>
+          </a:xfrm>
+          <a:prstGeom prst="rect">
+            <a:avLst/>
+          </a:prstGeom>
+          <a:noFill/>
+          <a:ln/>
+        </p:spPr>
+        <p:txBody>
+          <a:bodyPr wrap="square" lIns="0" tIns="0" rIns="0" bIns="0" rtlCol="0" anchor="t"/>
+          <a:lstStyle/>
+          <a:p>
+            <a:pPr indent="0" marL="0">
+              <a:spcAft>
+                <a:spcPts val="200"/>
+              </a:spcAft>
+              <a:buNone/>
+            </a:pPr>
+            <a:r>
+              <a:rPr lang="en-US" sz="1500" b="1" dirty="0">
+                <a:solidFill>
+                  <a:schemeClr val="tx1"/>
+                </a:solidFill>
+              </a:rPr>
+              <a:t>Masked and audited</a:t>
+            </a:r>
+            <a:endParaRPr lang="en-US" sz="1500" dirty="0"/>
+          </a:p>
+          <a:p>
+            <a:pPr indent="0" marL="0">
+              <a:spcAft>
+                <a:spcPts val="200"/>
+              </a:spcAft>
+              <a:buNone/>
+            </a:pPr>
+            <a:r>
+              <a:rPr lang="en-US" sz="1400" dirty="0">
+                <a:solidFill>
+                  <a:schemeClr val="accent6"/>
+                </a:solidFill>
+              </a:rPr>
+              <a:t>Full view logged; codes stored as hashes</a:t>
+            </a:r>
+            <a:endParaRPr lang="en-US" sz="1500" dirty="0"/>
+          </a:p>
+        </p:txBody>
+      </p:sp>
+    </p:spTree>
+  </p:cSld>
+  <p:clrMapOvr>
+    <a:masterClrMapping/>
+  </p:clrMapOvr>
+</p:sld>
+</file>
+
+<file path=ppt/slides/slide31.xml><?xml version="1.0" encoding="utf-8"?>
+<p:sld xmlns:a="http://schemas.openxmlformats.org/drawingml/2006/main" xmlns:p="http://schemas.openxmlformats.org/presentationml/2006/main" xmlns:r="http://schemas.openxmlformats.org/officeDocument/2006/relationships">
+  <p:cSld>
+    <p:spTree>
+      <p:nvGrpSpPr>
+        <p:cNvPr id="1" name=""/>
+        <p:cNvGrpSpPr/>
+        <p:nvPr/>
+      </p:nvGrpSpPr>
+      <p:grpSpPr/>
+      <p:sp>
+        <p:nvSpPr>
+          <p:cNvPr id="2" name="Text Placeholder 1"/>
+          <p:cNvSpPr>
+            <a:spLocks noGrp="1"/>
+          </p:cNvSpPr>
+          <p:nvPr>
+            <p:ph type="body" idx="100"/>
+          </p:nvPr>
+        </p:nvSpPr>
+        <p:spPr/>
+        <p:txBody>
+          <a:bodyPr/>
+          <a:lstStyle/>
+          <a:p>
+            <a:r>
+              <a:t>SCENARIO 12  ·  ONBOARDING</a:t>
+            </a:r>
+          </a:p>
+        </p:txBody>
+      </p:sp>
+      <p:sp>
+        <p:nvSpPr>
+          <p:cNvPr id="3" name="Title 2"/>
+          <p:cNvSpPr>
+            <a:spLocks noGrp="1"/>
+          </p:cNvSpPr>
+          <p:nvPr>
+            <p:ph type="title" idx="101"/>
+          </p:nvPr>
+        </p:nvSpPr>
+        <p:spPr/>
+        <p:txBody>
+          <a:bodyPr/>
+          <a:lstStyle/>
+          <a:p>
+            <a:r>
+              <a:t>Register one resident or import a whole batch</a:t>
+            </a:r>
+          </a:p>
+        </p:txBody>
+      </p:sp>
+      <p:sp>
+        <p:nvSpPr>
+          <p:cNvPr id="25" name="Slide Number Placeholder 0"/>
+          <p:cNvSpPr>
+            <a:spLocks noGrp="1"/>
+          </p:cNvSpPr>
+          <p:nvPr>
+            <p:ph type="sldNum" sz="quarter" idx="4294967295"/>
+          </p:nvPr>
+        </p:nvSpPr>
+        <p:spPr>
+          <a:xfrm>
+            <a:off x="8229600" y="4800600"/>
+            <a:ext cx="457200" cy="228600"/>
+          </a:xfrm>
+          <a:prstGeom prst="rect">
+            <a:avLst/>
+          </a:prstGeom>
+          <a:extLst>
+            <a:ext uri="{C572A759-6A51-4108-AA02-DFA0A04FC94B}">
+              <ma14:wrappingTextBoxFlag xmlns:ma14="http://schemas.microsoft.com/office/mac/drawingml/2011/main" val="0"/>
+            </a:ext>
+          </a:extLst>
+        </p:spPr>
+        <p:txBody>
+          <a:bodyPr/>
+          <a:lstStyle>
+            <a:lvl1pPr>
+              <a:defRPr sz="800">
+                <a:solidFill>
+                  <a:srgbClr val="4B5563"/>
+                </a:solidFill>
+                <a:latin typeface="Courier New"/>
+                <a:ea typeface="Courier New"/>
+                <a:cs typeface="Courier New"/>
+              </a:defRPr>
+            </a:lvl1pPr>
+          </a:lstStyle>
+          <a:p>
+            <a:pPr algn="r"/>
+            <a:fld id="{F7021451-1387-4CA6-816F-3879F97B5CBC}" type="slidenum">
+              <a:rPr b="0" lang="en-US"/>
+              <a:t>22</a:t>
+            </a:fld>
+            <a:endParaRPr lang="en-US"/>
+          </a:p>
+        </p:txBody>
+      </p:sp>
+      <p:sp>
+        <p:nvSpPr>
+          <p:cNvPr id="5" name="frame-n-add-resident"/>
+          <p:cNvSpPr/>
+          <p:nvPr/>
+        </p:nvSpPr>
+        <p:spPr>
+          <a:xfrm>
+            <a:off x="492839" y="1152144"/>
+            <a:ext cx="2031841" cy="3319272"/>
+          </a:xfrm>
+          <a:prstGeom prst="rect">
+            <a:avLst/>
+          </a:prstGeom>
+          <a:solidFill>
+            <a:schemeClr val="bg1"/>
+          </a:solidFill>
+          <a:ln w="9525">
+            <a:solidFill>
+              <a:schemeClr val="accent1"/>
+            </a:solidFill>
+            <a:prstDash val="solid"/>
+          </a:ln>
+          <a:effectLst>
+            <a:outerShdw sx="100000" sy="100000" kx="0" ky="0" algn="bl" rotWithShape="0" blurRad="76200" dist="25400" dir="5400000">
+              <a:srgbClr val="000000">
+                <a:alpha val="18000"/>
+              </a:srgbClr>
+            </a:outerShdw>
+          </a:effectLst>
+        </p:spPr>
+      </p:sp>
+      <p:pic>
+        <p:nvPicPr>
+          <p:cNvPr id="26" name="shot-n-add-resident" descr="Validated registration form"/>
+          <p:cNvPicPr>
+            <a:picLocks noChangeAspect="1"/>
+          </p:cNvPicPr>
+          <p:nvPr/>
+        </p:nvPicPr>
+        <p:blipFill>
+          <a:blip r:embed="rId3"/>
+          <a:stretch>
+            <a:fillRect/>
+          </a:stretch>
+        </p:blipFill>
+        <p:spPr>
+          <a:xfrm>
+            <a:off x="529415" y="1188720"/>
+            <a:ext cx="1958689" cy="3246120"/>
+          </a:xfrm>
+          <a:prstGeom prst="rect">
+            <a:avLst/>
+          </a:prstGeom>
+        </p:spPr>
+      </p:pic>
+      <p:sp>
+        <p:nvSpPr>
+          <p:cNvPr id="7" name="cap-n-add-resident"/>
+          <p:cNvSpPr txBox="1"/>
+          <p:nvPr/>
+        </p:nvSpPr>
+        <p:spPr>
+          <a:xfrm>
+            <a:off x="411479" y="4507992"/>
+            <a:ext cx="2194560" cy="256032"/>
+          </a:xfrm>
+          <a:prstGeom prst="rect">
+            <a:avLst/>
+          </a:prstGeom>
+          <a:noFill/>
+          <a:ln/>
+        </p:spPr>
+        <p:txBody>
+          <a:bodyPr wrap="square" lIns="0" tIns="0" rIns="0" bIns="0" rtlCol="0" anchor="ctr"/>
+          <a:lstStyle/>
+          <a:p>
+            <a:pPr algn="ctr" indent="0" marL="0">
+              <a:buNone/>
+            </a:pPr>
+            <a:r>
+              <a:rPr lang="en-US" sz="1100" i="1" dirty="0">
+                <a:solidFill>
+                  <a:schemeClr val="accent6"/>
+                </a:solidFill>
+              </a:rPr>
+              <a:t>Validated registration form</a:t>
+            </a:r>
+            <a:endParaRPr lang="en-US" sz="1100" dirty="0"/>
+          </a:p>
+        </p:txBody>
+      </p:sp>
+      <p:sp>
+        <p:nvSpPr>
+          <p:cNvPr id="5" name="frame-n-import-result"/>
+          <p:cNvSpPr/>
+          <p:nvPr/>
+        </p:nvSpPr>
+        <p:spPr>
+          <a:xfrm>
+            <a:off x="3697197" y="1152144"/>
+            <a:ext cx="4127046" cy="1856232"/>
+          </a:xfrm>
+          <a:prstGeom prst="rect">
+            <a:avLst/>
+          </a:prstGeom>
+          <a:solidFill>
+            <a:schemeClr val="bg1"/>
+          </a:solidFill>
+          <a:ln w="9525">
+            <a:solidFill>
+              <a:schemeClr val="accent1"/>
+            </a:solidFill>
+            <a:prstDash val="solid"/>
+          </a:ln>
+          <a:effectLst>
+            <a:outerShdw sx="100000" sy="100000" kx="0" ky="0" algn="bl" rotWithShape="0" blurRad="76200" dist="25400" dir="5400000">
+              <a:srgbClr val="000000">
+                <a:alpha val="18000"/>
+              </a:srgbClr>
+            </a:outerShdw>
+          </a:effectLst>
+        </p:spPr>
+      </p:sp>
+      <p:pic>
+        <p:nvPicPr>
+          <p:cNvPr id="27" name="shot-n-import-result" descr="CSV import: 2 registered, 1 row reported"/>
+          <p:cNvPicPr>
+            <a:picLocks noChangeAspect="1"/>
+          </p:cNvPicPr>
+          <p:nvPr/>
+        </p:nvPicPr>
+        <p:blipFill>
+          <a:blip r:embed="rId4"/>
+          <a:stretch>
+            <a:fillRect/>
+          </a:stretch>
+        </p:blipFill>
+        <p:spPr>
+          <a:xfrm>
+            <a:off x="3733773" y="1188720"/>
+            <a:ext cx="4053894" cy="1783080"/>
+          </a:xfrm>
+          <a:prstGeom prst="rect">
+            <a:avLst/>
+          </a:prstGeom>
+        </p:spPr>
+      </p:pic>
+      <p:sp>
+        <p:nvSpPr>
+          <p:cNvPr id="7" name="cap-n-import-result"/>
+          <p:cNvSpPr txBox="1"/>
+          <p:nvPr/>
+        </p:nvSpPr>
+        <p:spPr>
+          <a:xfrm>
+            <a:off x="3733773" y="3044952"/>
+            <a:ext cx="4053894" cy="256032"/>
+          </a:xfrm>
+          <a:prstGeom prst="rect">
+            <a:avLst/>
+          </a:prstGeom>
+          <a:noFill/>
+          <a:ln/>
+        </p:spPr>
+        <p:txBody>
+          <a:bodyPr wrap="square" lIns="0" tIns="0" rIns="0" bIns="0" rtlCol="0" anchor="ctr"/>
+          <a:lstStyle/>
+          <a:p>
+            <a:pPr algn="ctr" indent="0" marL="0">
+              <a:buNone/>
+            </a:pPr>
+            <a:r>
+              <a:rPr lang="en-US" sz="1100" i="1" dirty="0">
+                <a:solidFill>
+                  <a:schemeClr val="accent6"/>
+                </a:solidFill>
+              </a:rPr>
+              <a:t>CSV import: 2 registered, 1 row reported</a:t>
+            </a:r>
+            <a:endParaRPr lang="en-US" sz="1100" dirty="0"/>
+          </a:p>
+        </p:txBody>
+      </p:sp>
+      <p:sp>
+        <p:nvSpPr>
+          <p:cNvPr id="6" name="Text 3"/>
+          <p:cNvSpPr txBox="1"/>
+          <p:nvPr/>
+        </p:nvSpPr>
+        <p:spPr>
+          <a:xfrm>
+            <a:off x="2971800" y="3337560"/>
+            <a:ext cx="411480" cy="411480"/>
+          </a:xfrm>
+          <a:prstGeom prst="rect">
+            <a:avLst/>
+          </a:prstGeom>
+          <a:noFill/>
+          <a:ln/>
+        </p:spPr>
+        <p:txBody>
+          <a:bodyPr wrap="square" lIns="0" tIns="0" rIns="0" bIns="0" rtlCol="0" anchor="ctr"/>
+          <a:lstStyle/>
+          <a:p>
+            <a:pPr algn="ctr" indent="0" marL="0">
+              <a:buNone/>
+            </a:pPr>
+            <a:r>
+              <a:rPr lang="en-US" sz="1400" b="1" dirty="0">
+                <a:solidFill>
+                  <a:schemeClr val="bg1"/>
+                </a:solidFill>
+                <a:latin typeface="Courier New" pitchFamily="34" charset="0"/>
+                <a:ea typeface="Courier New" pitchFamily="34" charset="-122"/>
+                <a:cs typeface="Courier New" pitchFamily="34" charset="-120"/>
+              </a:rPr>
+              <a:t>1</a:t>
+            </a:r>
+            <a:endParaRPr lang="en-US" sz="1400" dirty="0"/>
+          </a:p>
+        </p:txBody>
+      </p:sp>
+      <p:sp>
+        <p:nvSpPr>
+          <p:cNvPr id="7" name="step-0"/>
+          <p:cNvSpPr txBox="1"/>
+          <p:nvPr/>
+        </p:nvSpPr>
+        <p:spPr>
+          <a:xfrm>
+            <a:off x="3474720" y="3337560"/>
+            <a:ext cx="5166360" cy="640080"/>
+          </a:xfrm>
+          <a:prstGeom prst="rect">
+            <a:avLst/>
+          </a:prstGeom>
+          <a:noFill/>
+          <a:ln/>
+        </p:spPr>
+        <p:txBody>
+          <a:bodyPr wrap="square" lIns="0" tIns="0" rIns="0" bIns="0" rtlCol="0" anchor="t"/>
+          <a:lstStyle/>
+          <a:p>
+            <a:pPr indent="0" marL="0">
+              <a:spcAft>
+                <a:spcPts val="200"/>
+              </a:spcAft>
+              <a:buNone/>
+            </a:pPr>
+            <a:r>
+              <a:rPr lang="en-US" sz="1500" b="1" dirty="0">
+                <a:solidFill>
+                  <a:schemeClr val="tx1"/>
+                </a:solidFill>
+              </a:rPr>
+              <a:t>Bed assigned automatically</a:t>
+            </a:r>
+            <a:endParaRPr lang="en-US" sz="1500" dirty="0"/>
+          </a:p>
+          <a:p>
+            <a:pPr indent="0" marL="0">
+              <a:spcAft>
+                <a:spcPts val="200"/>
+              </a:spcAft>
+              <a:buNone/>
+            </a:pPr>
+            <a:r>
+              <a:rPr lang="en-US" sz="1400" dirty="0">
+                <a:solidFill>
+                  <a:schemeClr val="accent6"/>
+                </a:solidFill>
+              </a:rPr>
+              <a:t>By block, floor and room type; never mixes genders in a room</a:t>
+            </a:r>
+            <a:endParaRPr lang="en-US" sz="1500" dirty="0"/>
+          </a:p>
+        </p:txBody>
+      </p:sp>
+      <p:sp>
+        <p:nvSpPr>
+          <p:cNvPr id="6" name="Text 3"/>
+          <p:cNvSpPr txBox="1"/>
+          <p:nvPr/>
+        </p:nvSpPr>
+        <p:spPr>
+          <a:xfrm>
+            <a:off x="2971800" y="3995928"/>
+            <a:ext cx="411480" cy="411480"/>
+          </a:xfrm>
+          <a:prstGeom prst="rect">
+            <a:avLst/>
+          </a:prstGeom>
+          <a:noFill/>
+          <a:ln/>
+        </p:spPr>
+        <p:txBody>
+          <a:bodyPr wrap="square" lIns="0" tIns="0" rIns="0" bIns="0" rtlCol="0" anchor="ctr"/>
+          <a:lstStyle/>
+          <a:p>
+            <a:pPr algn="ctr" indent="0" marL="0">
+              <a:buNone/>
+            </a:pPr>
+            <a:r>
+              <a:rPr lang="en-US" sz="1400" b="1" dirty="0">
+                <a:solidFill>
+                  <a:schemeClr val="bg1"/>
+                </a:solidFill>
+                <a:latin typeface="Courier New" pitchFamily="34" charset="0"/>
+                <a:ea typeface="Courier New" pitchFamily="34" charset="-122"/>
+                <a:cs typeface="Courier New" pitchFamily="34" charset="-120"/>
+              </a:rPr>
+              <a:t>2</a:t>
+            </a:r>
+            <a:endParaRPr lang="en-US" sz="1400" dirty="0"/>
+          </a:p>
+        </p:txBody>
+      </p:sp>
+      <p:sp>
+        <p:nvSpPr>
+          <p:cNvPr id="7" name="step-0"/>
+          <p:cNvSpPr txBox="1"/>
+          <p:nvPr/>
+        </p:nvSpPr>
+        <p:spPr>
+          <a:xfrm>
+            <a:off x="3474720" y="3995928"/>
+            <a:ext cx="5166360" cy="640080"/>
+          </a:xfrm>
+          <a:prstGeom prst="rect">
+            <a:avLst/>
+          </a:prstGeom>
+          <a:noFill/>
+          <a:ln/>
+        </p:spPr>
+        <p:txBody>
+          <a:bodyPr wrap="square" lIns="0" tIns="0" rIns="0" bIns="0" rtlCol="0" anchor="t"/>
+          <a:lstStyle/>
+          <a:p>
+            <a:pPr indent="0" marL="0">
+              <a:spcAft>
+                <a:spcPts val="200"/>
+              </a:spcAft>
+              <a:buNone/>
+            </a:pPr>
+            <a:r>
+              <a:rPr lang="en-US" sz="1500" b="1" dirty="0">
+                <a:solidFill>
+                  <a:schemeClr val="tx1"/>
+                </a:solidFill>
+              </a:rPr>
+              <a:t>One-time access code</a:t>
+            </a:r>
+            <a:endParaRPr lang="en-US" sz="1500" dirty="0"/>
+          </a:p>
+          <a:p>
+            <a:pPr indent="0" marL="0">
+              <a:spcAft>
+                <a:spcPts val="200"/>
+              </a:spcAft>
+              <a:buNone/>
+            </a:pPr>
+            <a:r>
+              <a:rPr lang="en-US" sz="1400" dirty="0">
+                <a:solidFill>
+                  <a:schemeClr val="accent6"/>
+                </a:solidFill>
+              </a:rPr>
+              <a:t>E-mailed to the resident; stored only as a PBKDF2 hash</a:t>
+            </a:r>
+            <a:endParaRPr lang="en-US" sz="1500" dirty="0"/>
           </a:p>
         </p:txBody>
       </p:sp>
@@ -13918,7 +15432,7 @@
                 <a:ea typeface="Arial" pitchFamily="34" charset="-122"/>
                 <a:cs typeface="Arial" pitchFamily="34" charset="-120"/>
               </a:rPr>
-              <a:t>13</a:t>
+              <a:t>14</a:t>
             </a:r>
             <a:endParaRPr lang="en-US" sz="4000" dirty="0"/>
           </a:p>
@@ -14104,7 +15618,7 @@
                   <a:schemeClr val="accent6"/>
                 </a:solidFill>
               </a:rPr>
-              <a:t>student survey profiles seeded for allocation</a:t>
+              <a:t>residents with encrypted personal records</a:t>
             </a:r>
             <a:endParaRPr lang="en-US" sz="1400" dirty="0"/>
           </a:p>
@@ -14143,7 +15657,7 @@
                 <a:ea typeface="Arial" pitchFamily="34" charset="-122"/>
                 <a:cs typeface="Arial" pitchFamily="34" charset="-120"/>
               </a:rPr>
-              <a:t>31</a:t>
+              <a:t>41</a:t>
             </a:r>
             <a:endParaRPr lang="en-US" sz="4000" dirty="0"/>
           </a:p>
@@ -14218,7 +15732,7 @@
                 <a:ea typeface="Arial" pitchFamily="34" charset="-122"/>
                 <a:cs typeface="Arial" pitchFamily="34" charset="-120"/>
               </a:rPr>
-              <a:t>8</a:t>
+              <a:t>57</a:t>
             </a:r>
             <a:endParaRPr lang="en-US" sz="4000" dirty="0"/>
           </a:p>
@@ -14254,7 +15768,7 @@
                   <a:schemeClr val="accent6"/>
                 </a:solidFill>
               </a:rPr>
-              <a:t>end-to-end user scenarios verified in Chrome</a:t>
+              <a:t>browser checks across 4 roles, all passing</a:t>
             </a:r>
             <a:endParaRPr lang="en-US" sz="1400" dirty="0"/>
           </a:p>
@@ -14511,6 +16025,10 @@
             <a:prstDash val="solid"/>
           </a:ln>
         </p:spPr>
+        <p:txBody>
+          <a:bodyPr/>
+          <a:p/>
+        </p:txBody>
       </p:sp>
       <p:sp>
         <p:nvSpPr>
@@ -14586,6 +16104,10 @@
             <a:prstDash val="solid"/>
           </a:ln>
         </p:spPr>
+        <p:txBody>
+          <a:bodyPr/>
+          <a:p/>
+        </p:txBody>
       </p:sp>
       <p:sp>
         <p:nvSpPr>
@@ -14709,6 +16231,10 @@
             <a:prstDash val="solid"/>
           </a:ln>
         </p:spPr>
+        <p:txBody>
+          <a:bodyPr/>
+          <a:p/>
+        </p:txBody>
       </p:sp>
       <p:sp>
         <p:nvSpPr>
@@ -14754,7 +16280,7 @@
                   <a:schemeClr val="tx1"/>
                 </a:solidFill>
               </a:rPr>
-              <a:t>SQLite  |  DynamoDB</a:t>
+              <a:t>SQLite  |  DynamoDB  ·  PII encrypted</a:t>
             </a:r>
             <a:endParaRPr lang="en-US" sz="1400" dirty="0"/>
           </a:p>
@@ -15401,8 +16927,8 @@
         </p:nvSpPr>
         <p:spPr>
           <a:xfrm>
-            <a:off x="420624" y="1152144"/>
-            <a:ext cx="1933989" cy="3182112"/>
+            <a:off x="467815" y="1152144"/>
+            <a:ext cx="1839606" cy="3182112"/>
           </a:xfrm>
           <a:prstGeom prst="rect">
             <a:avLst/>
@@ -15434,15 +16960,15 @@
           <p:nvPr/>
         </p:nvPicPr>
         <p:blipFill>
-          <a:blip r:embed="rId1"/>
+          <a:blip r:embed="rId5"/>
           <a:stretch>
             <a:fillRect/>
           </a:stretch>
         </p:blipFill>
         <p:spPr>
           <a:xfrm>
-            <a:off x="457200" y="1188720"/>
-            <a:ext cx="1860837" cy="3108960"/>
+            <a:off x="504391" y="1188720"/>
+            <a:ext cx="1766454" cy="3108960"/>
           </a:xfrm>
           <a:prstGeom prst="rect">
             <a:avLst/>
@@ -15493,8 +17019,8 @@
         </p:nvSpPr>
         <p:spPr>
           <a:xfrm>
-            <a:off x="2569464" y="1152144"/>
-            <a:ext cx="2176272" cy="2227568"/>
+            <a:off x="2676105" y="1152144"/>
+            <a:ext cx="1962990" cy="2227568"/>
           </a:xfrm>
           <a:prstGeom prst="rect">
             <a:avLst/>
@@ -15526,15 +17052,15 @@
           <p:nvPr/>
         </p:nvPicPr>
         <p:blipFill>
-          <a:blip r:embed="rId2"/>
+          <a:blip r:embed="rId1"/>
           <a:stretch>
             <a:fillRect/>
           </a:stretch>
         </p:blipFill>
         <p:spPr>
           <a:xfrm>
-            <a:off x="2606040" y="1188720"/>
-            <a:ext cx="2103120" cy="2154416"/>
+            <a:off x="2712681" y="1188720"/>
+            <a:ext cx="1889838" cy="2154416"/>
           </a:xfrm>
           <a:prstGeom prst="rect">
             <a:avLst/>
@@ -16488,7 +18014,7 @@
         <p:spPr>
           <a:xfrm>
             <a:off x="5290433" y="1078992"/>
-            <a:ext cx="2586494" cy="3657600"/>
+            <a:ext cx="2586494" cy="3463524"/>
           </a:xfrm>
           <a:prstGeom prst="rect">
             <a:avLst/>
@@ -16520,7 +18046,7 @@
           <p:nvPr/>
         </p:nvPicPr>
         <p:blipFill>
-          <a:blip r:embed="rId1"/>
+          <a:blip r:embed="rId4"/>
           <a:stretch>
             <a:fillRect/>
           </a:stretch>
@@ -16528,7 +18054,7 @@
         <p:spPr>
           <a:xfrm>
             <a:off x="5327009" y="1115568"/>
-            <a:ext cx="2513342" cy="3584448"/>
+            <a:ext cx="2513342" cy="3390372"/>
           </a:xfrm>
           <a:prstGeom prst="rect">
             <a:avLst/>
@@ -16695,8 +18221,8 @@
         </p:nvSpPr>
         <p:spPr>
           <a:xfrm>
-            <a:off x="420624" y="1152144"/>
-            <a:ext cx="4050792" cy="2854318"/>
+            <a:off x="1018861" y="1152144"/>
+            <a:ext cx="2854318" cy="2854318"/>
           </a:xfrm>
           <a:prstGeom prst="rect">
             <a:avLst/>
@@ -16728,15 +18254,15 @@
           <p:nvPr/>
         </p:nvPicPr>
         <p:blipFill>
-          <a:blip r:embed="rId1"/>
+          <a:blip r:embed="rId5"/>
           <a:stretch>
             <a:fillRect/>
           </a:stretch>
         </p:blipFill>
         <p:spPr>
           <a:xfrm>
-            <a:off x="457200" y="1188720"/>
-            <a:ext cx="3977640" cy="2781166"/>
+            <a:off x="1055437" y="1188720"/>
+            <a:ext cx="2781166" cy="2781166"/>
           </a:xfrm>
           <a:prstGeom prst="rect">
             <a:avLst/>
@@ -16788,7 +18314,7 @@
         <p:spPr>
           <a:xfrm>
             <a:off x="5624801" y="1152144"/>
-            <a:ext cx="2146359" cy="3200400"/>
+            <a:ext cx="2146359" cy="3054015"/>
           </a:xfrm>
           <a:prstGeom prst="rect">
             <a:avLst/>
@@ -16820,7 +18346,7 @@
           <p:nvPr/>
         </p:nvPicPr>
         <p:blipFill>
-          <a:blip r:embed="rId2"/>
+          <a:blip r:embed="rId1"/>
           <a:stretch>
             <a:fillRect/>
           </a:stretch>
@@ -16828,7 +18354,7 @@
         <p:spPr>
           <a:xfrm>
             <a:off x="5661377" y="1188720"/>
-            <a:ext cx="2073207" cy="3127248"/>
+            <a:ext cx="2073207" cy="2980863"/>
           </a:xfrm>
           <a:prstGeom prst="rect">
             <a:avLst/>
@@ -16843,7 +18369,7 @@
         </p:nvSpPr>
         <p:spPr>
           <a:xfrm>
-            <a:off x="4709160" y="4407408"/>
+            <a:off x="4709160" y="4261023"/>
             <a:ext cx="3977640" cy="256032"/>
           </a:xfrm>
           <a:prstGeom prst="rect">

</xml_diff>

<commit_message>
Deck: final review title slide with team and guide; impact slide removed
- Title slide shows "Final Review", the three students with register numbers and
  the faculty guide
- Impact statistics slide removed (29 slides); scenario divider now says twelve flows

Co-Authored-By: Claude Opus 5.5 <noreply@anthropic.com>
</commit_message>
<xml_diff>
--- a/presentation/Demeure_AI_Showcase.pptx
+++ b/presentation/Demeure_AI_Showcase.pptx
@@ -32,7 +32,6 @@
     <p:sldId id="279" r:id="rId25"/>
     <p:sldId id="280" r:id="rId26"/>
     <p:sldId id="281" r:id="rId27"/>
-    <p:sldId id="282" r:id="rId28"/>
     <p:sldId id="283" r:id="rId29"/>
     <p:sldId id="284" r:id="rId30"/>
   </p:sldIdLst>
@@ -173,7 +172,6 @@
           <p14:sldIdLst>
             <p14:sldId id="280"/>
             <p14:sldId id="281"/>
-            <p14:sldId id="282"/>
             <p14:sldId id="283"/>
             <p14:sldId id="284"/>
           </p14:sldIdLst>
@@ -452,259 +450,6 @@
 </c:chartSpace>
 </file>
 
-<file path=ppt/charts/chart2.xml><?xml version="1.0" encoding="utf-8"?>
-<c:chartSpace xmlns:c="http://schemas.openxmlformats.org/drawingml/2006/chart" xmlns:a="http://schemas.openxmlformats.org/drawingml/2006/main" xmlns:r="http://schemas.openxmlformats.org/officeDocument/2006/relationships">
-  <c:date1904 val="0"/>
-  <c:roundedCorners val="1"/>
-  <c:chart>
-    <c:title>
-      <c:tx>
-        <c:rich>
-          <a:bodyPr/>
-          <a:lstStyle/>
-          <a:p>
-            <a:pPr>
-              <a:defRPr sz="1400" b="0" i="0" u="none" strike="noStrike">
-                <a:solidFill>
-                  <a:srgbClr val="111827"/>
-                </a:solidFill>
-                <a:latin typeface="+mn-lt"/>
-              </a:defRPr>
-            </a:pPr>
-            <a:r>
-              <a:rPr sz="1400" b="0" i="0" u="none" strike="noStrike">
-                <a:solidFill>
-                  <a:srgbClr val="111827"/>
-                </a:solidFill>
-                <a:latin typeface="+mn-lt"/>
-              </a:rPr>
-              <a:t>First-load JavaScript (kB, uncompressed)</a:t>
-            </a:r>
-          </a:p>
-        </c:rich>
-      </c:tx>
-      <c:layout/>
-      <c:overlay val="0"/>
-    </c:title>
-    <c:autoTitleDeleted val="0"/>
-    <c:plotArea>
-      <c:layout/>
-      <c:barChart>
-        <c:barDir val="col"/>
-        <c:grouping val="clustered"/>
-        <c:varyColors val="0"/>
-        <c:ser>
-          <c:idx val="0"/>
-          <c:order val="0"/>
-          <c:tx>
-            <c:strRef>
-              <c:f>Sheet1!$B$1</c:f>
-              <c:strCache>
-                <c:ptCount val="1"/>
-                <c:pt idx="0">
-                  <c:v>First-load JS (kB)</c:v>
-                </c:pt>
-              </c:strCache>
-            </c:strRef>
-          </c:tx>
-          <c:spPr>
-            <a:solidFill>
-              <a:srgbClr val="1E3A5F"/>
-            </a:solidFill>
-            <a:effectLst/>
-          </c:spPr>
-          <c:invertIfNegative val="0"/>
-          <c:dLbls>
-            <c:numFmt formatCode="#,##0" sourceLinked="0"/>
-            <c:txPr>
-              <a:bodyPr/>
-              <a:lstStyle/>
-              <a:p>
-                <a:pPr>
-                  <a:defRPr b="0" i="0" strike="noStrike" sz="1300" u="none">
-                    <a:solidFill>
-                      <a:srgbClr val="111827"/>
-                    </a:solidFill>
-                    <a:latin typeface="+mn-lt"/>
-                  </a:defRPr>
-                </a:pPr>
-              </a:p>
-            </c:txPr>
-            <c:showLegendKey val="0"/>
-            <c:showVal val="1"/>
-            <c:showCatName val="0"/>
-            <c:showSerName val="0"/>
-            <c:showPercent val="0"/>
-            <c:showBubbleSize val="0"/>
-            <c:showLeaderLines val="0"/>
-          </c:dLbls>
-          <c:cat>
-            <c:multiLvlStrRef>
-              <c:f>Sheet1!$A$2:$A$3</c:f>
-              <c:multiLvlStrCache>
-                <c:ptCount val="2"/>
-                <c:lvl>
-                  <c:pt idx="0">
-                    <c:v>Prototype</c:v>
-                  </c:pt>
-                  <c:pt idx="1">
-                    <c:v>This release</c:v>
-                  </c:pt>
-                </c:lvl>
-              </c:multiLvlStrCache>
-            </c:multiLvlStrRef>
-          </c:cat>
-          <c:val>
-            <c:numRef>
-              <c:f>Sheet1!$B$2:$B$3</c:f>
-              <c:numCache>
-                <c:formatCode>General</c:formatCode>
-                <c:ptCount val="2"/>
-                <c:pt idx="0">
-                  <c:v>1316</c:v>
-                </c:pt>
-                <c:pt idx="1">
-                  <c:v>254</c:v>
-                </c:pt>
-              </c:numCache>
-            </c:numRef>
-          </c:val>
-        </c:ser>
-        <c:dLbls>
-          <c:numFmt formatCode="#,##0" sourceLinked="0"/>
-          <c:txPr>
-            <a:bodyPr/>
-            <a:lstStyle/>
-            <a:p>
-              <a:pPr>
-                <a:defRPr b="0" i="0" strike="noStrike" sz="1300" u="none">
-                  <a:solidFill>
-                    <a:srgbClr val="111827"/>
-                  </a:solidFill>
-                  <a:latin typeface="+mn-lt"/>
-                </a:defRPr>
-              </a:pPr>
-            </a:p>
-          </c:txPr>
-          <c:showLegendKey val="0"/>
-          <c:showVal val="1"/>
-          <c:showCatName val="0"/>
-          <c:showSerName val="0"/>
-          <c:showPercent val="0"/>
-          <c:showBubbleSize val="0"/>
-          <c:showLeaderLines val="0"/>
-        </c:dLbls>
-        <c:gapWidth val="150"/>
-        <c:overlap val="0"/>
-        <c:axId val="2094734554"/>
-        <c:axId val="2094734552"/>
-        <c:axId val="2094734556"/>
-      </c:barChart>
-      <c:catAx>
-        <c:axId val="2094734554"/>
-        <c:scaling>
-          <c:orientation val="minMax"/>
-        </c:scaling>
-        <c:delete val="0"/>
-        <c:axPos val="b"/>
-        <c:numFmt formatCode="General" sourceLinked="1"/>
-        <c:majorTickMark val="out"/>
-        <c:minorTickMark val="none"/>
-        <c:tickLblPos val="low"/>
-        <c:spPr>
-          <a:ln w="12700" cap="flat">
-            <a:solidFill>
-              <a:srgbClr val="888888"/>
-            </a:solidFill>
-            <a:prstDash val="solid"/>
-            <a:round/>
-          </a:ln>
-        </c:spPr>
-        <c:txPr>
-          <a:bodyPr/>
-          <a:lstStyle/>
-          <a:p>
-            <a:pPr>
-              <a:defRPr sz="1300" b="0" i="0" u="none" strike="noStrike">
-                <a:solidFill>
-                  <a:srgbClr val="4B5563"/>
-                </a:solidFill>
-                <a:latin typeface="+mn-lt"/>
-              </a:defRPr>
-            </a:pPr>
-            <a:endParaRPr lang="en-US"/>
-          </a:p>
-        </c:txPr>
-        <c:crossAx val="2094734552"/>
-        <c:crosses val="autoZero"/>
-        <c:auto val="1"/>
-        <c:lblAlgn val="ctr"/>
-        <c:noMultiLvlLbl val="1"/>
-      </c:catAx>
-      <c:valAx>
-        <c:axId val="2094734552"/>
-        <c:scaling>
-          <c:orientation val="minMax"/>
-          <c:max val="1500"/>
-        </c:scaling>
-        <c:delete val="1"/>
-        <c:axPos val="l"/>
-        <c:numFmt formatCode="General" sourceLinked="0"/>
-        <c:majorTickMark val="out"/>
-        <c:minorTickMark val="none"/>
-        <c:tickLblPos val="nextTo"/>
-        <c:spPr>
-          <a:ln w="12700" cap="flat">
-            <a:solidFill>
-              <a:srgbClr val="888888"/>
-            </a:solidFill>
-            <a:prstDash val="solid"/>
-            <a:round/>
-          </a:ln>
-        </c:spPr>
-        <c:txPr>
-          <a:bodyPr/>
-          <a:lstStyle/>
-          <a:p>
-            <a:pPr>
-              <a:defRPr sz="1200" b="0" i="0" u="none" strike="noStrike">
-                <a:solidFill>
-                  <a:srgbClr val="000000"/>
-                </a:solidFill>
-                <a:latin typeface="+mn-lt"/>
-              </a:defRPr>
-            </a:pPr>
-            <a:endParaRPr lang="en-US"/>
-          </a:p>
-        </c:txPr>
-        <c:crossAx val="2094734554"/>
-        <c:crosses val="autoZero"/>
-        <c:crossBetween val="between"/>
-      </c:valAx>
-      <c:spPr>
-        <a:noFill/>
-        <a:ln>
-          <a:noFill/>
-        </a:ln>
-        <a:effectLst/>
-      </c:spPr>
-    </c:plotArea>
-    <c:plotVisOnly val="1"/>
-    <c:dispBlanksAs val="span"/>
-  </c:chart>
-  <c:spPr>
-    <a:noFill/>
-    <a:ln>
-      <a:noFill/>
-    </a:ln>
-    <a:effectLst/>
-  </c:spPr>
-  <c:externalData r:id="rId1">
-    <c:autoUpdate val="0"/>
-  </c:externalData>
-</c:chartSpace>
-</file>
-
 <file path=ppt/notesMasters/notesMaster1.xml><?xml version="1.0" encoding="utf-8"?>
 <p:notesMaster xmlns:a="http://schemas.openxmlformats.org/drawingml/2006/main" xmlns:r="http://schemas.openxmlformats.org/officeDocument/2006/relationships" xmlns:p="http://schemas.openxmlformats.org/presentationml/2006/main">
   <p:cSld>
@@ -2620,94 +2365,6 @@
             <a:fld id="{F7021451-1387-4CA6-816F-3879F97B5CBC}" type="slidenum">
               <a:rPr lang="en-US"/>
               <a:t>26</a:t>
-            </a:fld>
-            <a:endParaRPr lang="en-US"/>
-          </a:p>
-        </p:txBody>
-      </p:sp>
-    </p:spTree>
-    <p:extLst>
-      <p:ext uri="{BB962C8B-B14F-4D97-AF65-F5344CB8AC3E}">
-        <p14:creationId xmlns:p14="http://schemas.microsoft.com/office/powerpoint/2010/main" val="1024086991"/>
-      </p:ext>
-    </p:extLst>
-  </p:cSld>
-  <p:clrMapOvr>
-    <a:masterClrMapping/>
-  </p:clrMapOvr>
-</p:notes>
-</file>
-
-<file path=ppt/notesSlides/notesSlide27.xml><?xml version="1.0" encoding="utf-8"?>
-<p:notes xmlns:a="http://schemas.openxmlformats.org/drawingml/2006/main" xmlns:r="http://schemas.openxmlformats.org/officeDocument/2006/relationships" xmlns:p="http://schemas.openxmlformats.org/presentationml/2006/main">
-  <p:cSld>
-    <p:spTree>
-      <p:nvGrpSpPr>
-        <p:cNvPr id="1" name=""/>
-        <p:cNvGrpSpPr/>
-        <p:nvPr/>
-      </p:nvGrpSpPr>
-      <p:grpSpPr>
-        <a:xfrm>
-          <a:off x="0" y="0"/>
-          <a:ext cx="0" cy="0"/>
-          <a:chOff x="0" y="0"/>
-          <a:chExt cx="0" cy="0"/>
-        </a:xfrm>
-      </p:grpSpPr>
-      <p:sp>
-        <p:nvSpPr>
-          <p:cNvPr id="2" name="Slide Image Placeholder 1"/>
-          <p:cNvSpPr>
-            <a:spLocks noGrp="1" noRot="1" noChangeAspect="1"/>
-          </p:cNvSpPr>
-          <p:nvPr>
-            <p:ph type="sldImg"/>
-          </p:nvPr>
-        </p:nvSpPr>
-        <p:spPr/>
-      </p:sp>
-      <p:sp>
-        <p:nvSpPr>
-          <p:cNvPr id="3" name="Notes Placeholder 2"/>
-          <p:cNvSpPr>
-            <a:spLocks noGrp="1"/>
-          </p:cNvSpPr>
-          <p:nvPr>
-            <p:ph type="body" idx="1"/>
-          </p:nvPr>
-        </p:nvSpPr>
-        <p:spPr/>
-        <p:txBody>
-          <a:bodyPr/>
-          <a:lstStyle/>
-          <a:p>
-            <a:r>
-              <a:rPr lang="en-US" dirty="0"/>
-              <a:t>Code-splitting cut the first download from 1,316 kB to 254 kB (raw), or 386 kB to 76 kB gzipped. Lint errors went from 65 to zero, and the high-severity Excel parser vulnerability is gone. The prototype had no tests.</a:t>
-            </a:r>
-            <a:endParaRPr lang="en-US" dirty="0"/>
-          </a:p>
-        </p:txBody>
-      </p:sp>
-      <p:sp>
-        <p:nvSpPr>
-          <p:cNvPr id="4" name="Slide Number Placeholder 3"/>
-          <p:cNvSpPr>
-            <a:spLocks noGrp="1"/>
-          </p:cNvSpPr>
-          <p:nvPr>
-            <p:ph type="sldNum" sz="quarter" idx="10"/>
-          </p:nvPr>
-        </p:nvSpPr>
-        <p:spPr/>
-        <p:txBody>
-          <a:bodyPr/>
-          <a:lstStyle/>
-          <a:p>
-            <a:fld id="{F7021451-1387-4CA6-816F-3879F97B5CBC}" type="slidenum">
-              <a:rPr lang="en-US"/>
-              <a:t>27</a:t>
             </a:fld>
             <a:endParaRPr lang="en-US"/>
           </a:p>
@@ -4659,7 +4316,7 @@
                 <a:ea typeface="Courier New" pitchFamily="34" charset="-122"/>
                 <a:cs typeface="Courier New" pitchFamily="34" charset="-120"/>
               </a:rPr>
-              <a:t>INTELLIGENT CAMPUS OPERATING SYSTEM  ·  2026</a:t>
+              <a:t>FINAL REVIEW  ·  OCTOBER 2026</a:t>
             </a:r>
             <a:endParaRPr lang="en-US" sz="1100" dirty="0"/>
           </a:p>
@@ -4675,8 +4332,8 @@
         </p:nvSpPr>
         <p:spPr>
           <a:xfrm>
-            <a:off x="457200" y="914400"/>
-            <a:ext cx="4206240" cy="1417320"/>
+            <a:off x="457200" y="868680"/>
+            <a:ext cx="4206240" cy="777240"/>
           </a:xfrm>
           <a:prstGeom prst="rect">
             <a:avLst/>
@@ -4688,7 +4345,7 @@
           <a:bodyPr wrap="square" lIns="0" tIns="0" rIns="0" bIns="0" rtlCol="0" anchor="t"/>
           <a:lstStyle/>
           <a:p>
-            <a:pPr indent="0" marL="0">
+            <a:pPr indent="0" marL="0" algn="l">
               <a:buNone/>
             </a:pPr>
             <a:r>
@@ -4713,8 +4370,8 @@
         </p:nvSpPr>
         <p:spPr>
           <a:xfrm>
-            <a:off x="457200" y="2423160"/>
-            <a:ext cx="3931920" cy="1188720"/>
+            <a:off x="457200" y="1691640"/>
+            <a:ext cx="3931920" cy="548640"/>
           </a:xfrm>
           <a:prstGeom prst="rect">
             <a:avLst/>
@@ -4730,12 +4387,12 @@
               <a:buNone/>
             </a:pPr>
             <a:r>
-              <a:rPr lang="en-US" sz="1600" dirty="0">
+              <a:rPr lang="en-US" sz="1500" dirty="0">
                 <a:solidFill>
                   <a:schemeClr val="bg2"/>
                 </a:solidFill>
               </a:rPr>
-              <a:t>One operating system for hostel and campus life: secure, persistent and AI-assisted, for administrators, wardens, mess managers and students.</a:t>
+              <a:t>Intelligent campus operating system for hostel and campus life</a:t>
             </a:r>
             <a:endParaRPr lang="en-US" sz="1600" dirty="0"/>
           </a:p>
@@ -4833,6 +4490,180 @@
               <a:t>Live product screenshots throughout</a:t>
             </a:r>
             <a:endParaRPr lang="en-US" sz="1000" dirty="0"/>
+          </a:p>
+        </p:txBody>
+      </p:sp>
+      <p:sp>
+        <p:nvSpPr>
+          <p:cNvPr id="8" name="team"/>
+          <p:cNvSpPr txBox="1"/>
+          <p:nvPr/>
+        </p:nvSpPr>
+        <p:spPr>
+          <a:xfrm>
+            <a:off x="457200" y="2423160"/>
+            <a:ext cx="4114800" cy="274320"/>
+          </a:xfrm>
+          <a:prstGeom prst="rect">
+            <a:avLst/>
+          </a:prstGeom>
+          <a:noFill/>
+        </p:spPr>
+        <p:txBody>
+          <a:bodyPr wrap="square" lIns="0" rIns="0" tIns="0" bIns="0" anchor="t">
+            <a:spAutoFit/>
+          </a:bodyPr>
+          <a:lstStyle/>
+          <a:p>
+            <a:pPr>
+              <a:spcAft>
+                <a:spcPts val="400"/>
+              </a:spcAft>
+            </a:pPr>
+            <a:r>
+              <a:rPr sz="1000" b="1">
+                <a:solidFill>
+                  <a:schemeClr val="accent3"/>
+                </a:solidFill>
+                <a:latin typeface="Courier New"/>
+              </a:rPr>
+              <a:t>TEAM</a:t>
+            </a:r>
+          </a:p>
+          <a:p>
+            <a:pPr>
+              <a:spcAft>
+                <a:spcPts val="200"/>
+              </a:spcAft>
+            </a:pPr>
+            <a:r>
+              <a:rPr sz="1300" b="0">
+                <a:solidFill>
+                  <a:schemeClr val="bg1"/>
+                </a:solidFill>
+                <a:latin typeface="Arial"/>
+              </a:rPr>
+              <a:t>Pratik Kumar  ·  24BML0027</a:t>
+            </a:r>
+          </a:p>
+          <a:p>
+            <a:pPr>
+              <a:spcAft>
+                <a:spcPts val="200"/>
+              </a:spcAft>
+            </a:pPr>
+            <a:r>
+              <a:rPr sz="1300" b="0">
+                <a:solidFill>
+                  <a:schemeClr val="bg1"/>
+                </a:solidFill>
+                <a:latin typeface="Arial"/>
+              </a:rPr>
+              <a:t>Thakur Chand Choudhary  ·  24BML0012</a:t>
+            </a:r>
+          </a:p>
+          <a:p>
+            <a:pPr>
+              <a:spcAft>
+                <a:spcPts val="0"/>
+              </a:spcAft>
+            </a:pPr>
+            <a:r>
+              <a:rPr sz="1300" b="0">
+                <a:solidFill>
+                  <a:schemeClr val="bg1"/>
+                </a:solidFill>
+                <a:latin typeface="Arial"/>
+              </a:rPr>
+              <a:t>Nikunj Goydani  ·  24BEC0338</a:t>
+            </a:r>
+          </a:p>
+        </p:txBody>
+      </p:sp>
+      <p:sp>
+        <p:nvSpPr>
+          <p:cNvPr id="9" name="faculty-guide"/>
+          <p:cNvSpPr txBox="1"/>
+          <p:nvPr/>
+        </p:nvSpPr>
+        <p:spPr>
+          <a:xfrm>
+            <a:off x="457200" y="3611880"/>
+            <a:ext cx="4114800" cy="274320"/>
+          </a:xfrm>
+          <a:prstGeom prst="rect">
+            <a:avLst/>
+          </a:prstGeom>
+          <a:noFill/>
+        </p:spPr>
+        <p:txBody>
+          <a:bodyPr wrap="square" lIns="0" rIns="0" tIns="0" bIns="0" anchor="t">
+            <a:spAutoFit/>
+          </a:bodyPr>
+          <a:lstStyle/>
+          <a:p>
+            <a:pPr>
+              <a:spcAft>
+                <a:spcPts val="400"/>
+              </a:spcAft>
+            </a:pPr>
+            <a:r>
+              <a:rPr sz="1000" b="1">
+                <a:solidFill>
+                  <a:schemeClr val="accent3"/>
+                </a:solidFill>
+                <a:latin typeface="Courier New"/>
+              </a:rPr>
+              <a:t>FACULTY GUIDE</a:t>
+            </a:r>
+          </a:p>
+          <a:p>
+            <a:pPr>
+              <a:spcAft>
+                <a:spcPts val="200"/>
+              </a:spcAft>
+            </a:pPr>
+            <a:r>
+              <a:rPr sz="1300" b="1">
+                <a:solidFill>
+                  <a:schemeClr val="bg1"/>
+                </a:solidFill>
+                <a:latin typeface="Arial"/>
+              </a:rPr>
+              <a:t>Dr. Rajalaxmi S</a:t>
+            </a:r>
+          </a:p>
+          <a:p>
+            <a:pPr>
+              <a:spcAft>
+                <a:spcPts val="100"/>
+              </a:spcAft>
+            </a:pPr>
+            <a:r>
+              <a:rPr sz="1050" b="0">
+                <a:solidFill>
+                  <a:schemeClr val="bg2"/>
+                </a:solidFill>
+                <a:latin typeface="Arial"/>
+              </a:rPr>
+              <a:t>Assistant Professor Sr. Grade 1</a:t>
+            </a:r>
+          </a:p>
+          <a:p>
+            <a:pPr>
+              <a:spcAft>
+                <a:spcPts val="0"/>
+              </a:spcAft>
+            </a:pPr>
+            <a:r>
+              <a:rPr sz="1050" b="0">
+                <a:solidFill>
+                  <a:schemeClr val="bg2"/>
+                </a:solidFill>
+                <a:latin typeface="Arial"/>
+              </a:rPr>
+              <a:t>School of Electronics Engineering (SENSE), VIT Vellore</a:t>
+            </a:r>
           </a:p>
         </p:txBody>
       </p:sp>
@@ -12313,608 +12144,6 @@
               <a:t>26</a:t>
             </a:fld>
             <a:endParaRPr lang="en-US"/>
-          </a:p>
-        </p:txBody>
-      </p:sp>
-    </p:spTree>
-  </p:cSld>
-  <p:clrMapOvr>
-    <a:masterClrMapping/>
-  </p:clrMapOvr>
-</p:sld>
-</file>
-
-<file path=ppt/slides/slide27.xml><?xml version="1.0" encoding="utf-8"?>
-<p:sld xmlns:a="http://schemas.openxmlformats.org/drawingml/2006/main" xmlns:r="http://schemas.openxmlformats.org/officeDocument/2006/relationships" xmlns:p="http://schemas.openxmlformats.org/presentationml/2006/main">
-  <p:cSld name="Slide 27">
-    <p:spTree>
-      <p:nvGrpSpPr>
-        <p:cNvPr id="1" name=""/>
-        <p:cNvGrpSpPr/>
-        <p:nvPr/>
-      </p:nvGrpSpPr>
-      <p:grpSpPr>
-        <a:xfrm>
-          <a:off x="0" y="0"/>
-          <a:ext cx="0" cy="0"/>
-          <a:chOff x="0" y="0"/>
-          <a:chExt cx="0" cy="0"/>
-        </a:xfrm>
-      </p:grpSpPr>
-      <p:sp>
-        <p:nvSpPr>
-          <p:cNvPr id="2" name="Text 0"/>
-          <p:cNvSpPr/>
-          <p:nvPr>
-            <p:ph idx="100" type="body" hasCustomPrompt="1"/>
-          </p:nvPr>
-        </p:nvSpPr>
-        <p:spPr>
-          <a:xfrm>
-            <a:off x="457200" y="201168"/>
-            <a:ext cx="6400800" cy="256032"/>
-          </a:xfrm>
-          <a:prstGeom prst="rect">
-            <a:avLst/>
-          </a:prstGeom>
-          <a:noFill/>
-          <a:ln/>
-        </p:spPr>
-        <p:txBody>
-          <a:bodyPr wrap="square" lIns="0" tIns="0" rIns="0" bIns="0" rtlCol="0"/>
-          <a:lstStyle/>
-          <a:p>
-            <a:pPr indent="0" marL="0">
-              <a:buNone/>
-            </a:pPr>
-            <a:r>
-              <a:rPr lang="en-US" sz="1000" b="1" dirty="0">
-                <a:solidFill>
-                  <a:schemeClr val="accent2"/>
-                </a:solidFill>
-                <a:latin typeface="Courier New" pitchFamily="34" charset="0"/>
-                <a:ea typeface="Courier New" pitchFamily="34" charset="-122"/>
-                <a:cs typeface="Courier New" pitchFamily="34" charset="-120"/>
-              </a:rPr>
-              <a:t>IMPACT</a:t>
-            </a:r>
-            <a:endParaRPr lang="en-US" sz="1000" dirty="0"/>
-          </a:p>
-        </p:txBody>
-      </p:sp>
-      <p:sp>
-        <p:nvSpPr>
-          <p:cNvPr id="3" name="Text 0"/>
-          <p:cNvSpPr/>
-          <p:nvPr>
-            <p:ph idx="101" type="title" hasCustomPrompt="1"/>
-          </p:nvPr>
-        </p:nvSpPr>
-        <p:spPr>
-          <a:xfrm>
-            <a:off x="457200" y="457200"/>
-            <a:ext cx="8229600" cy="548640"/>
-          </a:xfrm>
-          <a:prstGeom prst="rect">
-            <a:avLst/>
-          </a:prstGeom>
-          <a:noFill/>
-          <a:ln/>
-        </p:spPr>
-        <p:txBody>
-          <a:bodyPr wrap="square" lIns="0" tIns="0" rIns="0" bIns="0" rtlCol="0" anchor="t"/>
-          <a:lstStyle/>
-          <a:p>
-            <a:pPr indent="0" marL="0">
-              <a:buNone/>
-            </a:pPr>
-            <a:r>
-              <a:rPr lang="en-US" sz="2800" b="1" dirty="0">
-                <a:solidFill>
-                  <a:schemeClr val="tx2"/>
-                </a:solidFill>
-              </a:rPr>
-              <a:t>Leaner, safer and easier to read</a:t>
-            </a:r>
-            <a:endParaRPr lang="en-US" sz="2800" dirty="0"/>
-          </a:p>
-        </p:txBody>
-      </p:sp>
-      <p:sp>
-        <p:nvSpPr>
-          <p:cNvPr id="25" name="Slide Number Placeholder 0"/>
-          <p:cNvSpPr>
-            <a:spLocks noGrp="1"/>
-          </p:cNvSpPr>
-          <p:nvPr>
-            <p:ph type="sldNum" sz="quarter" idx="4294967295"/>
-          </p:nvPr>
-        </p:nvSpPr>
-        <p:spPr>
-          <a:xfrm>
-            <a:off x="8229600" y="4800600"/>
-            <a:ext cx="457200" cy="228600"/>
-          </a:xfrm>
-          <a:prstGeom prst="rect">
-            <a:avLst/>
-          </a:prstGeom>
-          <a:extLst>
-            <a:ext uri="{C572A759-6A51-4108-AA02-DFA0A04FC94B}">
-              <ma14:wrappingTextBoxFlag xmlns:ma14="http://schemas.microsoft.com/office/mac/drawingml/2011/main" val="0"/>
-            </a:ext>
-          </a:extLst>
-        </p:spPr>
-        <p:txBody>
-          <a:bodyPr/>
-          <a:lstStyle>
-            <a:lvl1pPr>
-              <a:defRPr sz="800">
-                <a:solidFill>
-                  <a:srgbClr val="4B5563"/>
-                </a:solidFill>
-                <a:latin typeface="Courier New"/>
-                <a:ea typeface="Courier New"/>
-                <a:cs typeface="Courier New"/>
-              </a:defRPr>
-            </a:lvl1pPr>
-          </a:lstStyle>
-          <a:p>
-            <a:pPr algn="r"/>
-            <a:fld id="{F7021451-1387-4CA6-816F-3879F97B5CBC}" type="slidenum">
-              <a:rPr b="0" lang="en-US"/>
-              <a:t>27</a:t>
-            </a:fld>
-            <a:endParaRPr lang="en-US"/>
-          </a:p>
-        </p:txBody>
-      </p:sp>
-      <p:sp>
-        <p:nvSpPr>
-          <p:cNvPr id="5" name="stat-lint errors"/>
-          <p:cNvSpPr txBox="1"/>
-          <p:nvPr/>
-        </p:nvSpPr>
-        <p:spPr>
-          <a:xfrm>
-            <a:off x="457200" y="1325880"/>
-            <a:ext cx="2560320" cy="685800"/>
-          </a:xfrm>
-          <a:prstGeom prst="rect">
-            <a:avLst/>
-          </a:prstGeom>
-          <a:noFill/>
-          <a:ln/>
-        </p:spPr>
-        <p:txBody>
-          <a:bodyPr wrap="square" lIns="0" tIns="0" rIns="0" bIns="0" rtlCol="0" anchor="ctr"/>
-          <a:lstStyle/>
-          <a:p>
-            <a:pPr indent="0" marL="0">
-              <a:buNone/>
-            </a:pPr>
-            <a:r>
-              <a:rPr lang="en-US" sz="4000" b="1" dirty="0">
-                <a:solidFill>
-                  <a:schemeClr val="accent1"/>
-                </a:solidFill>
-                <a:latin typeface="Arial" pitchFamily="34" charset="0"/>
-                <a:ea typeface="Arial" pitchFamily="34" charset="-122"/>
-                <a:cs typeface="Arial" pitchFamily="34" charset="-120"/>
-              </a:rPr>
-              <a:t>65 → 0</a:t>
-            </a:r>
-            <a:endParaRPr lang="en-US" sz="4000" dirty="0"/>
-          </a:p>
-        </p:txBody>
-      </p:sp>
-      <p:sp>
-        <p:nvSpPr>
-          <p:cNvPr id="6" name="Text 3"/>
-          <p:cNvSpPr txBox="1"/>
-          <p:nvPr/>
-        </p:nvSpPr>
-        <p:spPr>
-          <a:xfrm>
-            <a:off x="457200" y="2039112"/>
-            <a:ext cx="2560320" cy="457200"/>
-          </a:xfrm>
-          <a:prstGeom prst="rect">
-            <a:avLst/>
-          </a:prstGeom>
-          <a:noFill/>
-          <a:ln/>
-        </p:spPr>
-        <p:txBody>
-          <a:bodyPr wrap="square" lIns="0" tIns="0" rIns="0" bIns="0" rtlCol="0" anchor="t"/>
-          <a:lstStyle/>
-          <a:p>
-            <a:pPr indent="0" marL="0">
-              <a:buNone/>
-            </a:pPr>
-            <a:r>
-              <a:rPr lang="en-US" sz="1400" dirty="0">
-                <a:solidFill>
-                  <a:schemeClr val="accent6"/>
-                </a:solidFill>
-              </a:rPr>
-              <a:t>lint errors</a:t>
-            </a:r>
-            <a:endParaRPr lang="en-US" sz="1400" dirty="0"/>
-          </a:p>
-        </p:txBody>
-      </p:sp>
-      <p:sp>
-        <p:nvSpPr>
-          <p:cNvPr id="5" name="stat-high-severity production vulnerabilities"/>
-          <p:cNvSpPr txBox="1"/>
-          <p:nvPr/>
-        </p:nvSpPr>
-        <p:spPr>
-          <a:xfrm>
-            <a:off x="3291840" y="1325880"/>
-            <a:ext cx="2560320" cy="685800"/>
-          </a:xfrm>
-          <a:prstGeom prst="rect">
-            <a:avLst/>
-          </a:prstGeom>
-          <a:noFill/>
-          <a:ln/>
-        </p:spPr>
-        <p:txBody>
-          <a:bodyPr wrap="square" lIns="0" tIns="0" rIns="0" bIns="0" rtlCol="0" anchor="ctr"/>
-          <a:lstStyle/>
-          <a:p>
-            <a:pPr indent="0" marL="0">
-              <a:buNone/>
-            </a:pPr>
-            <a:r>
-              <a:rPr lang="en-US" sz="4000" b="1" dirty="0">
-                <a:solidFill>
-                  <a:schemeClr val="accent1"/>
-                </a:solidFill>
-                <a:latin typeface="Arial" pitchFamily="34" charset="0"/>
-                <a:ea typeface="Arial" pitchFamily="34" charset="-122"/>
-                <a:cs typeface="Arial" pitchFamily="34" charset="-120"/>
-              </a:rPr>
-              <a:t>1 → 0</a:t>
-            </a:r>
-            <a:endParaRPr lang="en-US" sz="4000" dirty="0"/>
-          </a:p>
-        </p:txBody>
-      </p:sp>
-      <p:sp>
-        <p:nvSpPr>
-          <p:cNvPr id="6" name="Text 3"/>
-          <p:cNvSpPr txBox="1"/>
-          <p:nvPr/>
-        </p:nvSpPr>
-        <p:spPr>
-          <a:xfrm>
-            <a:off x="3291840" y="2039112"/>
-            <a:ext cx="2560320" cy="457200"/>
-          </a:xfrm>
-          <a:prstGeom prst="rect">
-            <a:avLst/>
-          </a:prstGeom>
-          <a:noFill/>
-          <a:ln/>
-        </p:spPr>
-        <p:txBody>
-          <a:bodyPr wrap="square" lIns="0" tIns="0" rIns="0" bIns="0" rtlCol="0" anchor="t"/>
-          <a:lstStyle/>
-          <a:p>
-            <a:pPr indent="0" marL="0">
-              <a:buNone/>
-            </a:pPr>
-            <a:r>
-              <a:rPr lang="en-US" sz="1400" dirty="0">
-                <a:solidFill>
-                  <a:schemeClr val="accent6"/>
-                </a:solidFill>
-              </a:rPr>
-              <a:t>high-severity production vulnerabilities</a:t>
-            </a:r>
-            <a:endParaRPr lang="en-US" sz="1400" dirty="0"/>
-          </a:p>
-        </p:txBody>
-      </p:sp>
-      <p:sp>
-        <p:nvSpPr>
-          <p:cNvPr id="5" name="stat-automated backend tests"/>
-          <p:cNvSpPr txBox="1"/>
-          <p:nvPr/>
-        </p:nvSpPr>
-        <p:spPr>
-          <a:xfrm>
-            <a:off x="6126480" y="1325880"/>
-            <a:ext cx="2560320" cy="685800"/>
-          </a:xfrm>
-          <a:prstGeom prst="rect">
-            <a:avLst/>
-          </a:prstGeom>
-          <a:noFill/>
-          <a:ln/>
-        </p:spPr>
-        <p:txBody>
-          <a:bodyPr wrap="square" lIns="0" tIns="0" rIns="0" bIns="0" rtlCol="0" anchor="ctr"/>
-          <a:lstStyle/>
-          <a:p>
-            <a:pPr indent="0" marL="0">
-              <a:buNone/>
-            </a:pPr>
-            <a:r>
-              <a:rPr lang="en-US" sz="4000" b="1" dirty="0">
-                <a:solidFill>
-                  <a:schemeClr val="accent1"/>
-                </a:solidFill>
-                <a:latin typeface="Arial" pitchFamily="34" charset="0"/>
-                <a:ea typeface="Arial" pitchFamily="34" charset="-122"/>
-                <a:cs typeface="Arial" pitchFamily="34" charset="-120"/>
-              </a:rPr>
-              <a:t>0 → 41</a:t>
-            </a:r>
-            <a:endParaRPr lang="en-US" sz="4000" dirty="0"/>
-          </a:p>
-        </p:txBody>
-      </p:sp>
-      <p:sp>
-        <p:nvSpPr>
-          <p:cNvPr id="6" name="Text 3"/>
-          <p:cNvSpPr txBox="1"/>
-          <p:nvPr/>
-        </p:nvSpPr>
-        <p:spPr>
-          <a:xfrm>
-            <a:off x="6126480" y="2039112"/>
-            <a:ext cx="2560320" cy="457200"/>
-          </a:xfrm>
-          <a:prstGeom prst="rect">
-            <a:avLst/>
-          </a:prstGeom>
-          <a:noFill/>
-          <a:ln/>
-        </p:spPr>
-        <p:txBody>
-          <a:bodyPr wrap="square" lIns="0" tIns="0" rIns="0" bIns="0" rtlCol="0" anchor="t"/>
-          <a:lstStyle/>
-          <a:p>
-            <a:pPr indent="0" marL="0">
-              <a:buNone/>
-            </a:pPr>
-            <a:r>
-              <a:rPr lang="en-US" sz="1400" dirty="0">
-                <a:solidFill>
-                  <a:schemeClr val="accent6"/>
-                </a:solidFill>
-              </a:rPr>
-              <a:t>automated backend tests</a:t>
-            </a:r>
-            <a:endParaRPr lang="en-US" sz="1400" dirty="0"/>
-          </a:p>
-        </p:txBody>
-      </p:sp>
-      <p:sp>
-        <p:nvSpPr>
-          <p:cNvPr id="15" name="stat-first-load JavaScript (1,316 → 254 kB; 76 kB gzip)"/>
-          <p:cNvSpPr txBox="1"/>
-          <p:nvPr/>
-        </p:nvSpPr>
-        <p:spPr>
-          <a:xfrm>
-            <a:off x="457200" y="3017520"/>
-            <a:ext cx="2560320" cy="685800"/>
-          </a:xfrm>
-          <a:prstGeom prst="rect">
-            <a:avLst/>
-          </a:prstGeom>
-          <a:noFill/>
-          <a:ln/>
-        </p:spPr>
-        <p:txBody>
-          <a:bodyPr wrap="square" lIns="0" tIns="0" rIns="0" bIns="0" rtlCol="0" anchor="ctr"/>
-          <a:lstStyle/>
-          <a:p>
-            <a:pPr indent="0" marL="0">
-              <a:buNone/>
-            </a:pPr>
-            <a:r>
-              <a:rPr lang="en-US" sz="4000" b="1" dirty="0">
-                <a:solidFill>
-                  <a:schemeClr val="accent2"/>
-                </a:solidFill>
-                <a:latin typeface="Arial" pitchFamily="34" charset="0"/>
-                <a:ea typeface="Arial" pitchFamily="34" charset="-122"/>
-                <a:cs typeface="Arial" pitchFamily="34" charset="-120"/>
-              </a:rPr>
-              <a:t>−81%</a:t>
-            </a:r>
-            <a:endParaRPr lang="en-US" sz="4000" dirty="0"/>
-          </a:p>
-        </p:txBody>
-      </p:sp>
-      <p:sp>
-        <p:nvSpPr>
-          <p:cNvPr id="6" name="Text 3"/>
-          <p:cNvSpPr txBox="1"/>
-          <p:nvPr/>
-        </p:nvSpPr>
-        <p:spPr>
-          <a:xfrm>
-            <a:off x="457200" y="3730752"/>
-            <a:ext cx="2560320" cy="457200"/>
-          </a:xfrm>
-          <a:prstGeom prst="rect">
-            <a:avLst/>
-          </a:prstGeom>
-          <a:noFill/>
-          <a:ln/>
-        </p:spPr>
-        <p:txBody>
-          <a:bodyPr wrap="square" lIns="0" tIns="0" rIns="0" bIns="0" rtlCol="0" anchor="t"/>
-          <a:lstStyle/>
-          <a:p>
-            <a:pPr indent="0" marL="0">
-              <a:buNone/>
-            </a:pPr>
-            <a:r>
-              <a:rPr lang="en-US" sz="1400" dirty="0">
-                <a:solidFill>
-                  <a:schemeClr val="accent6"/>
-                </a:solidFill>
-              </a:rPr>
-              <a:t>first-load JavaScript (1,316 → 254 kB; 76 kB gzip)</a:t>
-            </a:r>
-            <a:endParaRPr lang="en-US" sz="1400" dirty="0"/>
-          </a:p>
-        </p:txBody>
-      </p:sp>
-      <p:sp>
-        <p:nvSpPr>
-          <p:cNvPr id="15" name="stat-on-screen text smaller than 12 px"/>
-          <p:cNvSpPr txBox="1"/>
-          <p:nvPr/>
-        </p:nvSpPr>
-        <p:spPr>
-          <a:xfrm>
-            <a:off x="3291840" y="3017520"/>
-            <a:ext cx="2560320" cy="685800"/>
-          </a:xfrm>
-          <a:prstGeom prst="rect">
-            <a:avLst/>
-          </a:prstGeom>
-          <a:noFill/>
-          <a:ln/>
-        </p:spPr>
-        <p:txBody>
-          <a:bodyPr wrap="square" lIns="0" tIns="0" rIns="0" bIns="0" rtlCol="0" anchor="ctr"/>
-          <a:lstStyle/>
-          <a:p>
-            <a:pPr indent="0" marL="0">
-              <a:buNone/>
-            </a:pPr>
-            <a:r>
-              <a:rPr lang="en-US" sz="4000" b="1" dirty="0">
-                <a:solidFill>
-                  <a:schemeClr val="accent2"/>
-                </a:solidFill>
-                <a:latin typeface="Arial" pitchFamily="34" charset="0"/>
-                <a:ea typeface="Arial" pitchFamily="34" charset="-122"/>
-                <a:cs typeface="Arial" pitchFamily="34" charset="-120"/>
-              </a:rPr>
-              <a:t>70% → 0%</a:t>
-            </a:r>
-            <a:endParaRPr lang="en-US" sz="4000" dirty="0"/>
-          </a:p>
-        </p:txBody>
-      </p:sp>
-      <p:sp>
-        <p:nvSpPr>
-          <p:cNvPr id="6" name="Text 3"/>
-          <p:cNvSpPr txBox="1"/>
-          <p:nvPr/>
-        </p:nvSpPr>
-        <p:spPr>
-          <a:xfrm>
-            <a:off x="3291840" y="3730752"/>
-            <a:ext cx="2560320" cy="457200"/>
-          </a:xfrm>
-          <a:prstGeom prst="rect">
-            <a:avLst/>
-          </a:prstGeom>
-          <a:noFill/>
-          <a:ln/>
-        </p:spPr>
-        <p:txBody>
-          <a:bodyPr wrap="square" lIns="0" tIns="0" rIns="0" bIns="0" rtlCol="0" anchor="t"/>
-          <a:lstStyle/>
-          <a:p>
-            <a:pPr indent="0" marL="0">
-              <a:buNone/>
-            </a:pPr>
-            <a:r>
-              <a:rPr lang="en-US" sz="1400" dirty="0">
-                <a:solidFill>
-                  <a:schemeClr val="accent6"/>
-                </a:solidFill>
-              </a:rPr>
-              <a:t>on-screen text smaller than 12 px</a:t>
-            </a:r>
-            <a:endParaRPr lang="en-US" sz="1400" dirty="0"/>
-          </a:p>
-        </p:txBody>
-      </p:sp>
-      <p:sp>
-        <p:nvSpPr>
-          <p:cNvPr id="15" name="stat-elements below WCAG contrast"/>
-          <p:cNvSpPr txBox="1"/>
-          <p:nvPr/>
-        </p:nvSpPr>
-        <p:spPr>
-          <a:xfrm>
-            <a:off x="6126480" y="3017520"/>
-            <a:ext cx="2560320" cy="685800"/>
-          </a:xfrm>
-          <a:prstGeom prst="rect">
-            <a:avLst/>
-          </a:prstGeom>
-          <a:noFill/>
-          <a:ln/>
-        </p:spPr>
-        <p:txBody>
-          <a:bodyPr wrap="square" lIns="0" tIns="0" rIns="0" bIns="0" rtlCol="0" anchor="ctr"/>
-          <a:lstStyle/>
-          <a:p>
-            <a:pPr indent="0" marL="0">
-              <a:buNone/>
-            </a:pPr>
-            <a:r>
-              <a:rPr lang="en-US" sz="4000" b="1" dirty="0">
-                <a:solidFill>
-                  <a:schemeClr val="accent2"/>
-                </a:solidFill>
-                <a:latin typeface="Arial" pitchFamily="34" charset="0"/>
-                <a:ea typeface="Arial" pitchFamily="34" charset="-122"/>
-                <a:cs typeface="Arial" pitchFamily="34" charset="-120"/>
-              </a:rPr>
-              <a:t>133 → 2</a:t>
-            </a:r>
-            <a:endParaRPr lang="en-US" sz="4000" dirty="0"/>
-          </a:p>
-        </p:txBody>
-      </p:sp>
-      <p:sp>
-        <p:nvSpPr>
-          <p:cNvPr id="6" name="Text 3"/>
-          <p:cNvSpPr txBox="1"/>
-          <p:nvPr/>
-        </p:nvSpPr>
-        <p:spPr>
-          <a:xfrm>
-            <a:off x="6126480" y="3730752"/>
-            <a:ext cx="2560320" cy="457200"/>
-          </a:xfrm>
-          <a:prstGeom prst="rect">
-            <a:avLst/>
-          </a:prstGeom>
-          <a:noFill/>
-          <a:ln/>
-        </p:spPr>
-        <p:txBody>
-          <a:bodyPr wrap="square" lIns="0" tIns="0" rIns="0" bIns="0" rtlCol="0" anchor="t"/>
-          <a:lstStyle/>
-          <a:p>
-            <a:pPr indent="0" marL="0">
-              <a:buNone/>
-            </a:pPr>
-            <a:r>
-              <a:rPr lang="en-US" sz="1400" dirty="0">
-                <a:solidFill>
-                  <a:schemeClr val="accent6"/>
-                </a:solidFill>
-              </a:rPr>
-              <a:t>elements below WCAG contrast</a:t>
-            </a:r>
-            <a:endParaRPr lang="en-US" sz="1400" dirty="0"/>
           </a:p>
         </p:txBody>
       </p:sp>
@@ -17449,7 +16678,7 @@
                   <a:schemeClr val="bg1"/>
                 </a:solidFill>
               </a:rPr>
-              <a:t>Ten flows, captured live</a:t>
+              <a:t>Twelve flows, captured live</a:t>
             </a:r>
             <a:endParaRPr lang="en-US" sz="4000" dirty="0"/>
           </a:p>

</xml_diff>